<commit_message>
Deck: 'Both instruments through the same loop' slide (16) with CCMac's D7 rows; loop slide restored to ZWFS-only; campaign brief head-to-head section
Co-Authored-By: Claude Fable 5.1 <noreply@anthropic.com>
</commit_message>
<xml_diff>
--- a/demo_session/deck_zwfs.pptx
+++ b/demo_session/deck_zwfs.pptx
@@ -29,6 +29,7 @@
     <p:sldId id="277" r:id="rId28"/>
     <p:sldId id="278" r:id="rId29"/>
     <p:sldId id="279" r:id="rId30"/>
+    <p:sldId id="280" r:id="rId31"/>
   </p:sldIdLst>
   <p:sldSz cx="12191695" cy="6858000" type="screen4x3"/>
   <p:notesSz cx="6858000" cy="9144000"/>
@@ -6535,7 +6536,7 @@
                 </a:solidFill>
                 <a:latin typeface="Arial"/>
               </a:rPr>
-              <a:t>•  The loop: the DM is held at the 30 nm working surface by a proportional servo (gain 0.5) closed through one reading; each cycle the DM shape is measured once with N photons (photons per measurement, slide 13), compared with the set point's frames, and half the estimated change removed.  The same loop code will run the interferometer.</a:t>
+              <a:t>•  The loop: the DM is held at the 30 nm working surface by a proportional servo (gain 0.5) through one reading: each cycle the shape is measured once with N photons (slide 13), compared with the set point's frames, and half the estimated change removed.</a:t>
             </a:r>
           </a:p>
           <a:p>
@@ -6551,7 +6552,7 @@
                 </a:solidFill>
                 <a:latin typeface="Arial"/>
               </a:rPr>
-              <a:t>•  What it shows: noise and a random walk propagate exactly as theory says, and L and S cost the same light.  What differs is the fixed error: S has none; L imprints a fine-scale error on the DM when a slow ramp leaves a persistent low-order residual; I+ has sites that read with the wrong sign, and no gain fixes a wrong sign.</a:t>
+              <a:t>•  What it shows: noise and a random walk propagate as theory says, and L and S cost the same light.  What differs is the fixed error: S has none; L imprints a fine-scale error under a slow ramp; I+ reads some sites with the wrong sign, and no gain fixes a wrong sign.</a:t>
             </a:r>
           </a:p>
         </p:txBody>
@@ -6564,7 +6565,7 @@
         </p:nvSpPr>
         <p:spPr>
           <a:xfrm>
-            <a:off x="6400800" y="5743194"/>
+            <a:off x="6400800" y="5346953"/>
             <a:ext cx="5394960" cy="274320"/>
           </a:xfrm>
           <a:prstGeom prst="rect">
@@ -6590,7 +6591,7 @@
                 </a:solidFill>
                 <a:latin typeface="Arial"/>
               </a:rPr>
-              <a:t>7.5×10¹² photons per cycle is 2.4 µJ: 9 ms of a 1 mW laser at the test arm's 25% throughput.  Gain 0.5, 60 cycles, matrix measured on the working surface, 193 rays; the 385-ray check gives the same numbers (runs/loop385).  A ramp under a proportional loop always lags by rate/gain; an integral term is the fix.  Code dm_gauge_lib/dmg_loop, gated by tDmgLoop.</a:t>
+              <a:t>7.5×10¹² photons per cycle is 2.4 µJ: 9 ms of a 1 mW laser at the test arm's 25% throughput.  Gain 0.5, 60 cycles, matrix measured on the working surface, 193 rays; the 385-ray check gives the same numbers.  A ramp under a proportional loop always lags by rate/gain.  Code dm_gauge_lib/dmg_loop, gated by tDmgLoop.</a:t>
             </a:r>
           </a:p>
         </p:txBody>
@@ -7424,7 +7425,7 @@
                 </a:solidFill>
                 <a:latin typeface="Arial"/>
               </a:rPr>
-              <a:t>Run it yourself</a:t>
+              <a:t>Both instruments through the same loop</a:t>
             </a:r>
           </a:p>
           <a:p>
@@ -7440,7 +7441,7 @@
                 </a:solidFill>
                 <a:latin typeface="Arial"/>
               </a:rPr>
-              <a:t>One parameter sheet and one script reproduce every number here; the defaults reproduce the stage-7 record to the last printed digit</a:t>
+              <a:t>The interferometer holds the surface at twice the sensor's light but keeps a 9% fixed error; its reflective version cannot hold a 2 pm walk at all</a:t>
             </a:r>
           </a:p>
         </p:txBody>
@@ -7489,56 +7490,17 @@
           </a:p>
         </p:txBody>
       </p:sp>
-      <p:sp>
-        <p:nvSpPr>
-          <p:cNvPr id="4" name="TextBox 3"/>
-          <p:cNvSpPr txBox="1"/>
-          <p:nvPr/>
-        </p:nvSpPr>
-        <p:spPr>
-          <a:xfrm>
-            <a:off x="411480" y="1298448"/>
-            <a:ext cx="11368735" cy="274320"/>
-          </a:xfrm>
-          <a:prstGeom prst="rect">
-            <a:avLst/>
-          </a:prstGeom>
-          <a:noFill/>
-        </p:spPr>
-        <p:txBody>
-          <a:bodyPr wrap="square">
-            <a:spAutoFit/>
-          </a:bodyPr>
-          <a:lstStyle/>
-          <a:p>
-            <a:pPr>
-              <a:spcAft>
-                <a:spcPts val="600"/>
-              </a:spcAft>
-            </a:pPr>
-            <a:r>
-              <a:rPr sz="1500" b="0">
-                <a:solidFill>
-                  <a:srgbClr val="282828"/>
-                </a:solidFill>
-                <a:latin typeface="Arial"/>
-              </a:rPr>
-              <a:t>•  Two files: zwfs_params.m returns every setting at its value of record — grid and ray count, wavelength, the bench's lengths and tuned figures, the mask's etch and spot, the sampling checks, registration, the DM sizes, the test amplitudes and seeds, the color and photon stages.  zwfs_run.m runs the chosen stages and writes the report, a .mat file and the figures into a folder named by the run's tag.</a:t>
-            </a:r>
-          </a:p>
-        </p:txBody>
-      </p:sp>
       <p:graphicFrame>
         <p:nvGraphicFramePr>
-          <p:cNvPr id="5" name="Table 4"/>
+          <p:cNvPr id="4" name="Table 3"/>
           <p:cNvGraphicFramePr>
             <a:graphicFrameLocks noGrp="1"/>
           </p:cNvGraphicFramePr>
           <p:nvPr/>
         </p:nvGraphicFramePr>
         <p:xfrm>
-          <a:off x="411480" y="2465831"/>
-          <a:ext cx="11368735" cy="1680210"/>
+          <a:off x="411480" y="1298448"/>
+          <a:ext cx="11368735" cy="2057400"/>
         </p:xfrm>
         <a:graphic>
           <a:graphicData uri="http://schemas.openxmlformats.org/drawingml/2006/table">
@@ -7547,10 +7509,13 @@
                 <a:tableStyleId>{5C22544A-7EE6-4342-B048-85BDC9FD1C3A}</a:tableStyleId>
               </a:tblPr>
               <a:tblGrid>
-                <a:gridCol w="6601201"/>
-                <a:gridCol w="4767534"/>
+                <a:gridCol w="2977188"/>
+                <a:gridCol w="1889760"/>
+                <a:gridCol w="1817116"/>
+                <a:gridCol w="1889760"/>
+                <a:gridCol w="2794911"/>
               </a:tblGrid>
-              <a:tr h="280035">
+              <a:tr h="468630">
                 <a:tc>
                   <a:txBody>
                     <a:bodyPr wrap="square"/>
@@ -7563,7 +7528,7 @@
                           </a:solidFill>
                           <a:latin typeface="Arial"/>
                         </a:rPr>
-                        <a:t>call</a:t>
+                        <a:t>held to 3 pm rms: photons per cycle</a:t>
                       </a:r>
                     </a:p>
                   </a:txBody>
@@ -7585,7 +7550,73 @@
                           </a:solidFill>
                           <a:latin typeface="Arial"/>
                         </a:rPr>
-                        <a:t>what it does</a:t>
+                        <a:t>ZWFS stepped (S)</a:t>
+                      </a:r>
+                    </a:p>
+                  </a:txBody>
+                  <a:tcPr marL="54864" marR="54864" marT="18288" marB="18288">
+                    <a:solidFill>
+                      <a:srgbClr val="1F4E79"/>
+                    </a:solidFill>
+                  </a:tcPr>
+                </a:tc>
+                <a:tc>
+                  <a:txBody>
+                    <a:bodyPr wrap="square"/>
+                    <a:lstStyle/>
+                    <a:p>
+                      <a:r>
+                        <a:rPr sz="1100" b="1">
+                          <a:solidFill>
+                            <a:srgbClr val="FFFFFF"/>
+                          </a:solidFill>
+                          <a:latin typeface="Arial"/>
+                        </a:rPr>
+                        <a:t>ZWFS polarized pair (V)</a:t>
+                      </a:r>
+                    </a:p>
+                  </a:txBody>
+                  <a:tcPr marL="54864" marR="54864" marT="18288" marB="18288">
+                    <a:solidFill>
+                      <a:srgbClr val="1F4E79"/>
+                    </a:solidFill>
+                  </a:tcPr>
+                </a:tc>
+                <a:tc>
+                  <a:txBody>
+                    <a:bodyPr wrap="square"/>
+                    <a:lstStyle/>
+                    <a:p>
+                      <a:r>
+                        <a:rPr sz="1100" b="1">
+                          <a:solidFill>
+                            <a:srgbClr val="FFFFFF"/>
+                          </a:solidFill>
+                          <a:latin typeface="Arial"/>
+                        </a:rPr>
+                        <a:t>interferometer, lens rig</a:t>
+                      </a:r>
+                    </a:p>
+                  </a:txBody>
+                  <a:tcPr marL="54864" marR="54864" marT="18288" marB="18288">
+                    <a:solidFill>
+                      <a:srgbClr val="1F4E79"/>
+                    </a:solidFill>
+                  </a:tcPr>
+                </a:tc>
+                <a:tc>
+                  <a:txBody>
+                    <a:bodyPr wrap="square"/>
+                    <a:lstStyle/>
+                    <a:p>
+                      <a:r>
+                        <a:rPr sz="1100" b="1">
+                          <a:solidFill>
+                            <a:srgbClr val="FFFFFF"/>
+                          </a:solidFill>
+                          <a:latin typeface="Arial"/>
+                        </a:rPr>
+                        <a:t>interferometer, reflective rig (bare aluminum)</a:t>
                       </a:r>
                     </a:p>
                   </a:txBody>
@@ -7609,7 +7640,7 @@
                           </a:solidFill>
                           <a:latin typeface="Arial"/>
                         </a:rPr>
-                        <a:t>zwfs_run</a:t>
+                        <a:t>noise only</a:t>
                       </a:r>
                     </a:p>
                   </a:txBody>
@@ -7631,7 +7662,73 @@
                           </a:solidFill>
                           <a:latin typeface="Arial"/>
                         </a:rPr>
-                        <a:t>the record: bench checks, the full test set, figures</a:t>
+                        <a:t>2.6×10¹²</a:t>
+                      </a:r>
+                    </a:p>
+                  </a:txBody>
+                  <a:tcPr marL="54864" marR="54864" marT="18288" marB="18288">
+                    <a:solidFill>
+                      <a:srgbClr val="FFFFFF"/>
+                    </a:solidFill>
+                  </a:tcPr>
+                </a:tc>
+                <a:tc>
+                  <a:txBody>
+                    <a:bodyPr wrap="square"/>
+                    <a:lstStyle/>
+                    <a:p>
+                      <a:r>
+                        <a:rPr sz="1100" b="0">
+                          <a:solidFill>
+                            <a:srgbClr val="282828"/>
+                          </a:solidFill>
+                          <a:latin typeface="Arial"/>
+                        </a:rPr>
+                        <a:t>1.5×10¹²</a:t>
+                      </a:r>
+                    </a:p>
+                  </a:txBody>
+                  <a:tcPr marL="54864" marR="54864" marT="18288" marB="18288">
+                    <a:solidFill>
+                      <a:srgbClr val="FFFFFF"/>
+                    </a:solidFill>
+                  </a:tcPr>
+                </a:tc>
+                <a:tc>
+                  <a:txBody>
+                    <a:bodyPr wrap="square"/>
+                    <a:lstStyle/>
+                    <a:p>
+                      <a:r>
+                        <a:rPr sz="1100" b="0">
+                          <a:solidFill>
+                            <a:srgbClr val="282828"/>
+                          </a:solidFill>
+                          <a:latin typeface="Arial"/>
+                        </a:rPr>
+                        <a:t>5.5×10¹²</a:t>
+                      </a:r>
+                    </a:p>
+                  </a:txBody>
+                  <a:tcPr marL="54864" marR="54864" marT="18288" marB="18288">
+                    <a:solidFill>
+                      <a:srgbClr val="FFFFFF"/>
+                    </a:solidFill>
+                  </a:tcPr>
+                </a:tc>
+                <a:tc>
+                  <a:txBody>
+                    <a:bodyPr wrap="square"/>
+                    <a:lstStyle/>
+                    <a:p>
+                      <a:r>
+                        <a:rPr sz="1100" b="0">
+                          <a:solidFill>
+                            <a:srgbClr val="282828"/>
+                          </a:solidFill>
+                          <a:latin typeface="Arial"/>
+                        </a:rPr>
+                        <a:t>3.4×10¹³</a:t>
                       </a:r>
                     </a:p>
                   </a:txBody>
@@ -7655,7 +7752,7 @@
                           </a:solidFill>
                           <a:latin typeface="Arial"/>
                         </a:rPr>
-                        <a:t>zwfs_run('tag','ng385', 'NGRID',385)</a:t>
+                        <a:t>random walk, 2 pm per cycle</a:t>
                       </a:r>
                     </a:p>
                   </a:txBody>
@@ -7677,7 +7774,73 @@
                           </a:solidFill>
                           <a:latin typeface="Arial"/>
                         </a:rPr>
-                        <a:t>the 1-megapixel camera</a:t>
+                        <a:t>7.5×10¹²</a:t>
+                      </a:r>
+                    </a:p>
+                  </a:txBody>
+                  <a:tcPr marL="54864" marR="54864" marT="18288" marB="18288">
+                    <a:solidFill>
+                      <a:srgbClr val="ECF1F6"/>
+                    </a:solidFill>
+                  </a:tcPr>
+                </a:tc>
+                <a:tc>
+                  <a:txBody>
+                    <a:bodyPr wrap="square"/>
+                    <a:lstStyle/>
+                    <a:p>
+                      <a:r>
+                        <a:rPr sz="1100" b="0">
+                          <a:solidFill>
+                            <a:srgbClr val="282828"/>
+                          </a:solidFill>
+                          <a:latin typeface="Arial"/>
+                        </a:rPr>
+                        <a:t>5.3×10¹²</a:t>
+                      </a:r>
+                    </a:p>
+                  </a:txBody>
+                  <a:tcPr marL="54864" marR="54864" marT="18288" marB="18288">
+                    <a:solidFill>
+                      <a:srgbClr val="ECF1F6"/>
+                    </a:solidFill>
+                  </a:tcPr>
+                </a:tc>
+                <a:tc>
+                  <a:txBody>
+                    <a:bodyPr wrap="square"/>
+                    <a:lstStyle/>
+                    <a:p>
+                      <a:r>
+                        <a:rPr sz="1100" b="0">
+                          <a:solidFill>
+                            <a:srgbClr val="282828"/>
+                          </a:solidFill>
+                          <a:latin typeface="Arial"/>
+                        </a:rPr>
+                        <a:t>2.0×10¹³</a:t>
+                      </a:r>
+                    </a:p>
+                  </a:txBody>
+                  <a:tcPr marL="54864" marR="54864" marT="18288" marB="18288">
+                    <a:solidFill>
+                      <a:srgbClr val="ECF1F6"/>
+                    </a:solidFill>
+                  </a:tcPr>
+                </a:tc>
+                <a:tc>
+                  <a:txBody>
+                    <a:bodyPr wrap="square"/>
+                    <a:lstStyle/>
+                    <a:p>
+                      <a:r>
+                        <a:rPr sz="1100" b="0">
+                          <a:solidFill>
+                            <a:srgbClr val="282828"/>
+                          </a:solidFill>
+                          <a:latin typeface="Arial"/>
+                        </a:rPr>
+                        <a:t>never (4.1 pm floor)</a:t>
                       </a:r>
                     </a:p>
                   </a:txBody>
@@ -7701,7 +7864,7 @@
                           </a:solidFill>
                           <a:latin typeface="Arial"/>
                         </a:rPr>
-                        <a:t>zwfs_run('MODEL',2048, 'NGRID',385, 'param_file','macos_param_2048.txt')</a:t>
+                        <a:t>thermal ramp, 5 pm per cycle</a:t>
                       </a:r>
                     </a:p>
                   </a:txBody>
@@ -7723,7 +7886,73 @@
                           </a:solidFill>
                           <a:latin typeface="Arial"/>
                         </a:rPr>
-                        <a:t>the fully sampled setup on a 30 GB machine</a:t>
+                        <a:t>10.0 pm (the loop's lag)</a:t>
+                      </a:r>
+                    </a:p>
+                  </a:txBody>
+                  <a:tcPr marL="54864" marR="54864" marT="18288" marB="18288">
+                    <a:solidFill>
+                      <a:srgbClr val="FFFFFF"/>
+                    </a:solidFill>
+                  </a:tcPr>
+                </a:tc>
+                <a:tc>
+                  <a:txBody>
+                    <a:bodyPr wrap="square"/>
+                    <a:lstStyle/>
+                    <a:p>
+                      <a:r>
+                        <a:rPr sz="1100" b="0">
+                          <a:solidFill>
+                            <a:srgbClr val="282828"/>
+                          </a:solidFill>
+                          <a:latin typeface="Arial"/>
+                        </a:rPr>
+                        <a:t>9.9 pm</a:t>
+                      </a:r>
+                    </a:p>
+                  </a:txBody>
+                  <a:tcPr marL="54864" marR="54864" marT="18288" marB="18288">
+                    <a:solidFill>
+                      <a:srgbClr val="FFFFFF"/>
+                    </a:solidFill>
+                  </a:tcPr>
+                </a:tc>
+                <a:tc>
+                  <a:txBody>
+                    <a:bodyPr wrap="square"/>
+                    <a:lstStyle/>
+                    <a:p>
+                      <a:r>
+                        <a:rPr sz="1100" b="0">
+                          <a:solidFill>
+                            <a:srgbClr val="282828"/>
+                          </a:solidFill>
+                          <a:latin typeface="Arial"/>
+                        </a:rPr>
+                        <a:t>13.1 pm</a:t>
+                      </a:r>
+                    </a:p>
+                  </a:txBody>
+                  <a:tcPr marL="54864" marR="54864" marT="18288" marB="18288">
+                    <a:solidFill>
+                      <a:srgbClr val="FFFFFF"/>
+                    </a:solidFill>
+                  </a:tcPr>
+                </a:tc>
+                <a:tc>
+                  <a:txBody>
+                    <a:bodyPr wrap="square"/>
+                    <a:lstStyle/>
+                    <a:p>
+                      <a:r>
+                        <a:rPr sz="1100" b="0">
+                          <a:solidFill>
+                            <a:srgbClr val="282828"/>
+                          </a:solidFill>
+                          <a:latin typeface="Arial"/>
+                        </a:rPr>
+                        <a:t>39 pm</a:t>
                       </a:r>
                     </a:p>
                   </a:txBody>
@@ -7747,7 +7976,7 @@
                           </a:solidFill>
                           <a:latin typeface="Arial"/>
                         </a:rPr>
-                        <a:t>zwfs_run('stages',{'battery','color','noise','figs'})</a:t>
+                        <a:t>noise-free 1 nm step, after 60 cycles</a:t>
                       </a:r>
                     </a:p>
                   </a:txBody>
@@ -7769,7 +7998,7 @@
                           </a:solidFill>
                           <a:latin typeface="Arial"/>
                         </a:rPr>
-                        <a:t>everything on this deck's later slides</a:t>
+                        <a:t>0.000 pm</a:t>
                       </a:r>
                     </a:p>
                   </a:txBody>
@@ -7779,21 +8008,87 @@
                     </a:solidFill>
                   </a:tcPr>
                 </a:tc>
+                <a:tc>
+                  <a:txBody>
+                    <a:bodyPr wrap="square"/>
+                    <a:lstStyle/>
+                    <a:p>
+                      <a:r>
+                        <a:rPr sz="1100" b="0">
+                          <a:solidFill>
+                            <a:srgbClr val="282828"/>
+                          </a:solidFill>
+                          <a:latin typeface="Arial"/>
+                        </a:rPr>
+                        <a:t>0.000 pm</a:t>
+                      </a:r>
+                    </a:p>
+                  </a:txBody>
+                  <a:tcPr marL="54864" marR="54864" marT="18288" marB="18288">
+                    <a:solidFill>
+                      <a:srgbClr val="ECF1F6"/>
+                    </a:solidFill>
+                  </a:tcPr>
+                </a:tc>
+                <a:tc>
+                  <a:txBody>
+                    <a:bodyPr wrap="square"/>
+                    <a:lstStyle/>
+                    <a:p>
+                      <a:r>
+                        <a:rPr sz="1100" b="0">
+                          <a:solidFill>
+                            <a:srgbClr val="282828"/>
+                          </a:solidFill>
+                          <a:latin typeface="Arial"/>
+                        </a:rPr>
+                        <a:t>87 pm, rising</a:t>
+                      </a:r>
+                    </a:p>
+                  </a:txBody>
+                  <a:tcPr marL="54864" marR="54864" marT="18288" marB="18288">
+                    <a:solidFill>
+                      <a:srgbClr val="ECF1F6"/>
+                    </a:solidFill>
+                  </a:tcPr>
+                </a:tc>
+                <a:tc>
+                  <a:txBody>
+                    <a:bodyPr wrap="square"/>
+                    <a:lstStyle/>
+                    <a:p>
+                      <a:r>
+                        <a:rPr sz="1100" b="0">
+                          <a:solidFill>
+                            <a:srgbClr val="282828"/>
+                          </a:solidFill>
+                          <a:latin typeface="Arial"/>
+                        </a:rPr>
+                        <a:t>276 pm</a:t>
+                      </a:r>
+                    </a:p>
+                  </a:txBody>
+                  <a:tcPr marL="54864" marR="54864" marT="18288" marB="18288">
+                    <a:solidFill>
+                      <a:srgbClr val="ECF1F6"/>
+                    </a:solidFill>
+                  </a:tcPr>
+                </a:tc>
               </a:tr>
-              <a:tr h="280035">
-                <a:tc>
-                  <a:txBody>
-                    <a:bodyPr wrap="square"/>
-                    <a:lstStyle/>
-                    <a:p>
-                      <a:r>
-                        <a:rPr sz="1100" b="0">
-                          <a:solidFill>
-                            <a:srgbClr val="282828"/>
-                          </a:solidFill>
-                          <a:latin typeface="Arial"/>
-                        </a:rPr>
-                        <a:t>./zwfs_batch.sh TAG "the same arguments"</a:t>
+              <a:tr h="468630">
+                <a:tc>
+                  <a:txBody>
+                    <a:bodyPr wrap="square"/>
+                    <a:lstStyle/>
+                    <a:p>
+                      <a:r>
+                        <a:rPr sz="1100" b="0">
+                          <a:solidFill>
+                            <a:srgbClr val="282828"/>
+                          </a:solidFill>
+                          <a:latin typeface="Arial"/>
+                        </a:rPr>
+                        <a:t>single-shot noise at 10¹² photons per measurement</a:t>
                       </a:r>
                     </a:p>
                   </a:txBody>
@@ -7815,7 +8110,73 @@
                           </a:solidFill>
                           <a:latin typeface="Arial"/>
                         </a:rPr>
-                        <a:t>unattended, memory-capped, logged</a:t>
+                        <a:t>8.2 pm</a:t>
+                      </a:r>
+                    </a:p>
+                  </a:txBody>
+                  <a:tcPr marL="54864" marR="54864" marT="18288" marB="18288">
+                    <a:solidFill>
+                      <a:srgbClr val="FFFFFF"/>
+                    </a:solidFill>
+                  </a:tcPr>
+                </a:tc>
+                <a:tc>
+                  <a:txBody>
+                    <a:bodyPr wrap="square"/>
+                    <a:lstStyle/>
+                    <a:p>
+                      <a:r>
+                        <a:rPr sz="1100" b="0">
+                          <a:solidFill>
+                            <a:srgbClr val="282828"/>
+                          </a:solidFill>
+                          <a:latin typeface="Arial"/>
+                        </a:rPr>
+                        <a:t>6.4 pm</a:t>
+                      </a:r>
+                    </a:p>
+                  </a:txBody>
+                  <a:tcPr marL="54864" marR="54864" marT="18288" marB="18288">
+                    <a:solidFill>
+                      <a:srgbClr val="FFFFFF"/>
+                    </a:solidFill>
+                  </a:tcPr>
+                </a:tc>
+                <a:tc>
+                  <a:txBody>
+                    <a:bodyPr wrap="square"/>
+                    <a:lstStyle/>
+                    <a:p>
+                      <a:r>
+                        <a:rPr sz="1100" b="0">
+                          <a:solidFill>
+                            <a:srgbClr val="282828"/>
+                          </a:solidFill>
+                          <a:latin typeface="Arial"/>
+                        </a:rPr>
+                        <a:t>12.0 pm</a:t>
+                      </a:r>
+                    </a:p>
+                  </a:txBody>
+                  <a:tcPr marL="54864" marR="54864" marT="18288" marB="18288">
+                    <a:solidFill>
+                      <a:srgbClr val="FFFFFF"/>
+                    </a:solidFill>
+                  </a:tcPr>
+                </a:tc>
+                <a:tc>
+                  <a:txBody>
+                    <a:bodyPr wrap="square"/>
+                    <a:lstStyle/>
+                    <a:p>
+                      <a:r>
+                        <a:rPr sz="1100" b="0">
+                          <a:solidFill>
+                            <a:srgbClr val="282828"/>
+                          </a:solidFill>
+                          <a:latin typeface="Arial"/>
+                        </a:rPr>
+                        <a:t>—</a:t>
                       </a:r>
                     </a:p>
                   </a:txBody>
@@ -7832,13 +8193,13 @@
       </p:graphicFrame>
       <p:sp>
         <p:nvSpPr>
-          <p:cNvPr id="6" name="TextBox 5"/>
+          <p:cNvPr id="5" name="TextBox 4"/>
           <p:cNvSpPr txBox="1"/>
           <p:nvPr/>
         </p:nvSpPr>
         <p:spPr>
           <a:xfrm>
-            <a:off x="411480" y="4292346"/>
+            <a:off x="411480" y="3502152"/>
             <a:ext cx="11368735" cy="274320"/>
           </a:xfrm>
           <a:prstGeom prst="rect">
@@ -7864,20 +8225,36 @@
                 </a:solidFill>
                 <a:latin typeface="Arial"/>
               </a:rPr>
-              <a:t>•  Checks that run every time: the no-mask round trip through the bracket (must return the field unchanged); the reference-wave model against the engine's own field; the pupil brightness must not change with the DM shape; the sampling checks (pixels across the dimple, camera pixels per actuator); and the search for the camera-to-DM mirror/transpose and sign.</a:t>
-            </a:r>
-          </a:p>
-        </p:txBody>
-      </p:sp>
-      <p:sp>
-        <p:nvSpPr>
-          <p:cNvPr id="7" name="TextBox 6"/>
+              <a:t>•  Same loop code, same drift realization, same scoring (dm_gauge_lib/dmg_loop; the interferometer rows by CCMac).  The loop propagates noise as theory says on every instrument, so the light each needs follows from its single-shot noise: the interferometer's four-step reading is about 1.5× noisier per photon than the sensor's stepped reading, about twice the photons.</a:t>
+            </a:r>
+          </a:p>
+          <a:p>
+            <a:pPr>
+              <a:spcAft>
+                <a:spcPts val="600"/>
+              </a:spcAft>
+            </a:pPr>
+            <a:r>
+              <a:rPr sz="1500" b="0">
+                <a:solidFill>
+                  <a:srgbClr val="282828"/>
+                </a:solidFill>
+                <a:latin typeface="Arial"/>
+              </a:rPr>
+              <a:t>•  The fixed error is the difference. The sensor's stepped and polarized readings return to zero after a step; the interferometer keeps about 9% of any change (its fine-pattern roll-off and cross-talk, now in closed loop), so it behaves like the sensor's linear reading, not its stepped one.  The reflective interferometer's remaining fold cross-talk (0.18 open-loop, once the ideal-reflector artifact was removed with bare aluminum) becomes a hard wall in hold mode: the 2 pm walk is never held to 3 pm.  Open-loop batteries could not make that distinction.</a:t>
+            </a:r>
+          </a:p>
+        </p:txBody>
+      </p:sp>
+      <p:sp>
+        <p:nvSpPr>
+          <p:cNvPr id="6" name="TextBox 5"/>
           <p:cNvSpPr txBox="1"/>
           <p:nvPr/>
         </p:nvSpPr>
         <p:spPr>
           <a:xfrm>
-            <a:off x="411480" y="5459730"/>
+            <a:off x="411480" y="6047994"/>
             <a:ext cx="11368735" cy="274320"/>
           </a:xfrm>
           <a:prstGeom prst="rect">
@@ -7903,7 +8280,7 @@
                 </a:solidFill>
                 <a:latin typeface="Arial"/>
               </a:rPr>
-              <a:t>Reproduction check: 64 lines of results against the stage-7 report, 8 differ in the last printed digit (the actuator fit's solver tolerance).  README "Run it yourself" carries the parameter table.</a:t>
+              <a:t>Sensor rows: zwfs_dm96 runs/loop193, vloop193.  Interferometer rows: tg_psi_dm96_oap runs/loop_lens, loop_oap (bare aluminum on both OAPs; the ideal-reflector null was an idealization, its exactly-zero retardance variation).  All at gain 0.5, 60 cycles, matrix measured on the 30 nm working surface.</a:t>
             </a:r>
           </a:p>
         </p:txBody>
@@ -7960,7 +8337,7 @@
                 </a:solidFill>
                 <a:latin typeface="Arial"/>
               </a:rPr>
-              <a:t>Side by side with the Twyman–Green</a:t>
+              <a:t>Run it yourself</a:t>
             </a:r>
           </a:p>
           <a:p>
@@ -7976,7 +8353,7 @@
                 </a:solidFill>
                 <a:latin typeface="Arial"/>
               </a:rPr>
-              <a:t>The interferometer loses response at fine patterns and never fails; the sensor, calibrated on its working surface, reads a change to 5 pm up to 50–60 nm</a:t>
+              <a:t>One parameter sheet and one script reproduce every number here; the defaults reproduce the stage-7 record to the last printed digit</a:t>
             </a:r>
           </a:p>
         </p:txBody>
@@ -8025,17 +8402,56 @@
           </a:p>
         </p:txBody>
       </p:sp>
+      <p:sp>
+        <p:nvSpPr>
+          <p:cNvPr id="4" name="TextBox 3"/>
+          <p:cNvSpPr txBox="1"/>
+          <p:nvPr/>
+        </p:nvSpPr>
+        <p:spPr>
+          <a:xfrm>
+            <a:off x="411480" y="1298448"/>
+            <a:ext cx="11368735" cy="274320"/>
+          </a:xfrm>
+          <a:prstGeom prst="rect">
+            <a:avLst/>
+          </a:prstGeom>
+          <a:noFill/>
+        </p:spPr>
+        <p:txBody>
+          <a:bodyPr wrap="square">
+            <a:spAutoFit/>
+          </a:bodyPr>
+          <a:lstStyle/>
+          <a:p>
+            <a:pPr>
+              <a:spcAft>
+                <a:spcPts val="600"/>
+              </a:spcAft>
+            </a:pPr>
+            <a:r>
+              <a:rPr sz="1500" b="0">
+                <a:solidFill>
+                  <a:srgbClr val="282828"/>
+                </a:solidFill>
+                <a:latin typeface="Arial"/>
+              </a:rPr>
+              <a:t>•  Two files: zwfs_params.m returns every setting at its value of record — grid and ray count, wavelength, the bench's lengths and tuned figures, the mask's etch and spot, the sampling checks, registration, the DM sizes, the test amplitudes and seeds, the color and photon stages.  zwfs_run.m runs the chosen stages and writes the report, a .mat file and the figures into a folder named by the run's tag.</a:t>
+            </a:r>
+          </a:p>
+        </p:txBody>
+      </p:sp>
       <p:graphicFrame>
         <p:nvGraphicFramePr>
-          <p:cNvPr id="4" name="Table 3"/>
+          <p:cNvPr id="5" name="Table 4"/>
           <p:cNvGraphicFramePr>
             <a:graphicFrameLocks noGrp="1"/>
           </p:cNvGraphicFramePr>
           <p:nvPr/>
         </p:nvGraphicFramePr>
         <p:xfrm>
-          <a:off x="411480" y="1298448"/>
-          <a:ext cx="11368733" cy="4023360"/>
+          <a:off x="411480" y="2465831"/>
+          <a:ext cx="11368735" cy="1680210"/>
         </p:xfrm>
         <a:graphic>
           <a:graphicData uri="http://schemas.openxmlformats.org/drawingml/2006/table">
@@ -8044,16 +8460,25 @@
                 <a:tableStyleId>{5C22544A-7EE6-4342-B048-85BDC9FD1C3A}</a:tableStyleId>
               </a:tblPr>
               <a:tblGrid>
-                <a:gridCol w="3608337"/>
-                <a:gridCol w="2224317"/>
-                <a:gridCol w="5536079"/>
+                <a:gridCol w="6601201"/>
+                <a:gridCol w="4767534"/>
               </a:tblGrid>
               <a:tr h="280035">
                 <a:tc>
                   <a:txBody>
                     <a:bodyPr wrap="square"/>
                     <a:lstStyle/>
-                    <a:p/>
+                    <a:p>
+                      <a:r>
+                        <a:rPr sz="1100" b="1">
+                          <a:solidFill>
+                            <a:srgbClr val="FFFFFF"/>
+                          </a:solidFill>
+                          <a:latin typeface="Arial"/>
+                        </a:rPr>
+                        <a:t>call</a:t>
+                      </a:r>
+                    </a:p>
                   </a:txBody>
                   <a:tcPr marL="54864" marR="54864" marT="18288" marB="18288">
                     <a:solidFill>
@@ -8073,29 +8498,7 @@
                           </a:solidFill>
                           <a:latin typeface="Arial"/>
                         </a:rPr>
-                        <a:t>Twyman–Green PSI (measured)</a:t>
-                      </a:r>
-                    </a:p>
-                  </a:txBody>
-                  <a:tcPr marL="54864" marR="54864" marT="18288" marB="18288">
-                    <a:solidFill>
-                      <a:srgbClr val="1F4E79"/>
-                    </a:solidFill>
-                  </a:tcPr>
-                </a:tc>
-                <a:tc>
-                  <a:txBody>
-                    <a:bodyPr wrap="square"/>
-                    <a:lstStyle/>
-                    <a:p>
-                      <a:r>
-                        <a:rPr sz="1100" b="1">
-                          <a:solidFill>
-                            <a:srgbClr val="FFFFFF"/>
-                          </a:solidFill>
-                          <a:latin typeface="Arial"/>
-                        </a:rPr>
-                        <a:t>Zernike sensor (measured)</a:t>
+                        <a:t>what it does</a:t>
                       </a:r>
                     </a:p>
                   </a:txBody>
@@ -8119,7 +8522,7 @@
                           </a:solidFill>
                           <a:latin typeface="Arial"/>
                         </a:rPr>
-                        <a:t>reference beam</a:t>
+                        <a:t>zwfs_run</a:t>
                       </a:r>
                     </a:p>
                   </a:txBody>
@@ -8141,165 +8544,7 @@
                           </a:solidFill>
                           <a:latin typeface="Arial"/>
                         </a:rPr>
-                        <a:t>the second arm's flat</a:t>
-                      </a:r>
-                    </a:p>
-                  </a:txBody>
-                  <a:tcPr marL="54864" marR="54864" marT="18288" marB="18288">
-                    <a:solidFill>
-                      <a:srgbClr val="FFFFFF"/>
-                    </a:solidFill>
-                  </a:tcPr>
-                </a:tc>
-                <a:tc>
-                  <a:txBody>
-                    <a:bodyPr wrap="square"/>
-                    <a:lstStyle/>
-                    <a:p>
-                      <a:r>
-                        <a:rPr sz="1100" b="0">
-                          <a:solidFill>
-                            <a:srgbClr val="282828"/>
-                          </a:solidFill>
-                          <a:latin typeface="Arial"/>
-                        </a:rPr>
-                        <a:t>made from the beam's own focal core</a:t>
-                      </a:r>
-                    </a:p>
-                  </a:txBody>
-                  <a:tcPr marL="54864" marR="54864" marT="18288" marB="18288">
-                    <a:solidFill>
-                      <a:srgbClr val="FFFFFF"/>
-                    </a:solidFill>
-                  </a:tcPr>
-                </a:tc>
-              </a:tr>
-              <a:tr h="468630">
-                <a:tc>
-                  <a:txBody>
-                    <a:bodyPr wrap="square"/>
-                    <a:lstStyle/>
-                    <a:p>
-                      <a:r>
-                        <a:rPr sz="1100" b="0">
-                          <a:solidFill>
-                            <a:srgbClr val="282828"/>
-                          </a:solidFill>
-                          <a:latin typeface="Arial"/>
-                        </a:rPr>
-                        <a:t>one measurement costs</a:t>
-                      </a:r>
-                    </a:p>
-                  </a:txBody>
-                  <a:tcPr marL="54864" marR="54864" marT="18288" marB="18288">
-                    <a:solidFill>
-                      <a:srgbClr val="ECF1F6"/>
-                    </a:solidFill>
-                  </a:tcPr>
-                </a:tc>
-                <a:tc>
-                  <a:txBody>
-                    <a:bodyPr wrap="square"/>
-                    <a:lstStyle/>
-                    <a:p>
-                      <a:r>
-                        <a:rPr sz="1100" b="0">
-                          <a:solidFill>
-                            <a:srgbClr val="282828"/>
-                          </a:solidFill>
-                          <a:latin typeface="Arial"/>
-                        </a:rPr>
-                        <a:t>6 traces (3 per arm), 4 fringe frames</a:t>
-                      </a:r>
-                    </a:p>
-                  </a:txBody>
-                  <a:tcPr marL="54864" marR="54864" marT="18288" marB="18288">
-                    <a:solidFill>
-                      <a:srgbClr val="ECF1F6"/>
-                    </a:solidFill>
-                  </a:tcPr>
-                </a:tc>
-                <a:tc>
-                  <a:txBody>
-                    <a:bodyPr wrap="square"/>
-                    <a:lstStyle/>
-                    <a:p>
-                      <a:r>
-                        <a:rPr sz="1100" b="0">
-                          <a:solidFill>
-                            <a:srgbClr val="282828"/>
-                          </a:solidFill>
-                          <a:latin typeface="Arial"/>
-                        </a:rPr>
-                        <a:t>1 or 4 camera frames; 256 calibration frames once per working surface</a:t>
-                      </a:r>
-                    </a:p>
-                  </a:txBody>
-                  <a:tcPr marL="54864" marR="54864" marT="18288" marB="18288">
-                    <a:solidFill>
-                      <a:srgbClr val="ECF1F6"/>
-                    </a:solidFill>
-                  </a:tcPr>
-                </a:tc>
-              </a:tr>
-              <a:tr h="468630">
-                <a:tc>
-                  <a:txBody>
-                    <a:bodyPr wrap="square"/>
-                    <a:lstStyle/>
-                    <a:p>
-                      <a:r>
-                        <a:rPr sz="1100" b="0">
-                          <a:solidFill>
-                            <a:srgbClr val="282828"/>
-                          </a:solidFill>
-                          <a:latin typeface="Arial"/>
-                        </a:rPr>
-                        <a:t>polarization hardware</a:t>
-                      </a:r>
-                    </a:p>
-                  </a:txBody>
-                  <a:tcPr marL="54864" marR="54864" marT="18288" marB="18288">
-                    <a:solidFill>
-                      <a:srgbClr val="FFFFFF"/>
-                    </a:solidFill>
-                  </a:tcPr>
-                </a:tc>
-                <a:tc>
-                  <a:txBody>
-                    <a:bodyPr wrap="square"/>
-                    <a:lstStyle/>
-                    <a:p>
-                      <a:r>
-                        <a:rPr sz="1100" b="0">
-                          <a:solidFill>
-                            <a:srgbClr val="282828"/>
-                          </a:solidFill>
-                          <a:latin typeface="Arial"/>
-                        </a:rPr>
-                        <a:t>polarizer, 5 waveplates, analyzer</a:t>
-                      </a:r>
-                    </a:p>
-                  </a:txBody>
-                  <a:tcPr marL="54864" marR="54864" marT="18288" marB="18288">
-                    <a:solidFill>
-                      <a:srgbClr val="FFFFFF"/>
-                    </a:solidFill>
-                  </a:tcPr>
-                </a:tc>
-                <a:tc>
-                  <a:txBody>
-                    <a:bodyPr wrap="square"/>
-                    <a:lstStyle/>
-                    <a:p>
-                      <a:r>
-                        <a:rPr sz="1100" b="0">
-                          <a:solidFill>
-                            <a:srgbClr val="282828"/>
-                          </a:solidFill>
-                          <a:latin typeface="Arial"/>
-                        </a:rPr>
-                        <a:t>none</a:t>
+                        <a:t>the record: bench checks, the full test set, figures</a:t>
                       </a:r>
                     </a:p>
                   </a:txBody>
@@ -8323,7 +8568,7 @@
                           </a:solidFill>
                           <a:latin typeface="Arial"/>
                         </a:rPr>
-                        <a:t>moving parts</a:t>
+                        <a:t>zwfs_run('tag','ng385', 'NGRID',385)</a:t>
                       </a:r>
                     </a:p>
                   </a:txBody>
@@ -8345,29 +8590,7 @@
                           </a:solidFill>
                           <a:latin typeface="Arial"/>
                         </a:rPr>
-                        <a:t>none (polarization-stepped)</a:t>
-                      </a:r>
-                    </a:p>
-                  </a:txBody>
-                  <a:tcPr marL="54864" marR="54864" marT="18288" marB="18288">
-                    <a:solidFill>
-                      <a:srgbClr val="ECF1F6"/>
-                    </a:solidFill>
-                  </a:tcPr>
-                </a:tc>
-                <a:tc>
-                  <a:txBody>
-                    <a:bodyPr wrap="square"/>
-                    <a:lstStyle/>
-                    <a:p>
-                      <a:r>
-                        <a:rPr sz="1100" b="0">
-                          <a:solidFill>
-                            <a:srgbClr val="282828"/>
-                          </a:solidFill>
-                          <a:latin typeface="Arial"/>
-                        </a:rPr>
-                        <a:t>none</a:t>
+                        <a:t>the 1-megapixel camera</a:t>
                       </a:r>
                     </a:p>
                   </a:txBody>
@@ -8391,7 +8614,7 @@
                           </a:solidFill>
                           <a:latin typeface="Arial"/>
                         </a:rPr>
-                        <a:t>null, nothing aligned</a:t>
+                        <a:t>zwfs_run('MODEL',2048, 'NGRID',385, 'param_file','macos_param_2048.txt')</a:t>
                       </a:r>
                     </a:p>
                   </a:txBody>
@@ -8413,103 +8636,13 @@
                           </a:solidFill>
                           <a:latin typeface="Arial"/>
                         </a:rPr>
-                        <a:t>0.134 nm</a:t>
+                        <a:t>the fully sampled setup on a 30 GB machine</a:t>
                       </a:r>
                     </a:p>
                   </a:txBody>
                   <a:tcPr marL="54864" marR="54864" marT="18288" marB="18288">
                     <a:solidFill>
                       <a:srgbClr val="FFFFFF"/>
-                    </a:solidFill>
-                  </a:tcPr>
-                </a:tc>
-                <a:tc>
-                  <a:txBody>
-                    <a:bodyPr wrap="square"/>
-                    <a:lstStyle/>
-                    <a:p>
-                      <a:r>
-                        <a:rPr sz="1100" b="0">
-                          <a:solidFill>
-                            <a:srgbClr val="282828"/>
-                          </a:solidFill>
-                          <a:latin typeface="Arial"/>
-                        </a:rPr>
-                        <a:t>0 by construction (the flat is the reference)</a:t>
-                      </a:r>
-                    </a:p>
-                  </a:txBody>
-                  <a:tcPr marL="54864" marR="54864" marT="18288" marB="18288">
-                    <a:solidFill>
-                      <a:srgbClr val="FFFFFF"/>
-                    </a:solidFill>
-                  </a:tcPr>
-                </a:tc>
-              </a:tr>
-              <a:tr h="468630">
-                <a:tc>
-                  <a:txBody>
-                    <a:bodyPr wrap="square"/>
-                    <a:lstStyle/>
-                    <a:p>
-                      <a:r>
-                        <a:rPr sz="1100" b="0">
-                          <a:solidFill>
-                            <a:srgbClr val="282828"/>
-                          </a:solidFill>
-                          <a:latin typeface="Arial"/>
-                        </a:rPr>
-                        <a:t>response falls off at</a:t>
-                      </a:r>
-                    </a:p>
-                  </a:txBody>
-                  <a:tcPr marL="54864" marR="54864" marT="18288" marB="18288">
-                    <a:solidFill>
-                      <a:srgbClr val="ECF1F6"/>
-                    </a:solidFill>
-                  </a:tcPr>
-                </a:tc>
-                <a:tc>
-                  <a:txBody>
-                    <a:bodyPr wrap="square"/>
-                    <a:lstStyle/>
-                    <a:p>
-                      <a:r>
-                        <a:rPr sz="1100" b="0">
-                          <a:solidFill>
-                            <a:srgbClr val="282828"/>
-                          </a:solidFill>
-                          <a:latin typeface="Arial"/>
-                        </a:rPr>
-                        <a:t>fine patterns: 0.50 at the 96×96 checkerboard</a:t>
-                      </a:r>
-                    </a:p>
-                  </a:txBody>
-                  <a:tcPr marL="54864" marR="54864" marT="18288" marB="18288">
-                    <a:solidFill>
-                      <a:srgbClr val="ECF1F6"/>
-                    </a:solidFill>
-                  </a:tcPr>
-                </a:tc>
-                <a:tc>
-                  <a:txBody>
-                    <a:bodyPr wrap="square"/>
-                    <a:lstStyle/>
-                    <a:p>
-                      <a:r>
-                        <a:rPr sz="1100" b="0">
-                          <a:solidFill>
-                            <a:srgbClr val="282828"/>
-                          </a:solidFill>
-                          <a:latin typeface="Arial"/>
-                        </a:rPr>
-                        <a:t>0.5 to 1 cycle across the pupil (0.5 at 1); piston unseen</a:t>
-                      </a:r>
-                    </a:p>
-                  </a:txBody>
-                  <a:tcPr marL="54864" marR="54864" marT="18288" marB="18288">
-                    <a:solidFill>
-                      <a:srgbClr val="ECF1F6"/>
                     </a:solidFill>
                   </a:tcPr>
                 </a:tc>
@@ -8527,75 +8660,7 @@
                           </a:solidFill>
                           <a:latin typeface="Arial"/>
                         </a:rPr>
-                        <a:t>working surface it can handle</a:t>
-                      </a:r>
-                    </a:p>
-                  </a:txBody>
-                  <a:tcPr marL="54864" marR="54864" marT="18288" marB="18288">
-                    <a:solidFill>
-                      <a:srgbClr val="FFFFFF"/>
-                    </a:solidFill>
-                  </a:tcPr>
-                </a:tc>
-                <a:tc>
-                  <a:txBody>
-                    <a:bodyPr wrap="square"/>
-                    <a:lstStyle/>
-                    <a:p>
-                      <a:r>
-                        <a:rPr sz="1100" b="0">
-                          <a:solidFill>
-                            <a:srgbClr val="282828"/>
-                          </a:solidFill>
-                          <a:latin typeface="Arial"/>
-                        </a:rPr>
-                        <a:t>480 nm rms and beyond</a:t>
-                      </a:r>
-                    </a:p>
-                  </a:txBody>
-                  <a:tcPr marL="54864" marR="54864" marT="18288" marB="18288">
-                    <a:solidFill>
-                      <a:srgbClr val="FFFFFF"/>
-                    </a:solidFill>
-                  </a:tcPr>
-                </a:tc>
-                <a:tc>
-                  <a:txBody>
-                    <a:bodyPr wrap="square"/>
-                    <a:lstStyle/>
-                    <a:p>
-                      <a:r>
-                        <a:rPr sz="1100" b="0">
-                          <a:solidFill>
-                            <a:srgbClr val="282828"/>
-                          </a:solidFill>
-                          <a:latin typeface="Arial"/>
-                        </a:rPr>
-                        <a:t>40 nm rms one-frame (1 mm actuators), 50–60 nm four-frame</a:t>
-                      </a:r>
-                    </a:p>
-                  </a:txBody>
-                  <a:tcPr marL="54864" marR="54864" marT="18288" marB="18288">
-                    <a:solidFill>
-                      <a:srgbClr val="FFFFFF"/>
-                    </a:solidFill>
-                  </a:tcPr>
-                </a:tc>
-              </a:tr>
-              <a:tr h="468630">
-                <a:tc>
-                  <a:txBody>
-                    <a:bodyPr wrap="square"/>
-                    <a:lstStyle/>
-                    <a:p>
-                      <a:r>
-                        <a:rPr sz="1100" b="0">
-                          <a:solidFill>
-                            <a:srgbClr val="282828"/>
-                          </a:solidFill>
-                          <a:latin typeface="Arial"/>
-                        </a:rPr>
-                        <a:t>a 10 nm actuator change on a 30 nm surface</a:t>
+                        <a:t>zwfs_run('stages',{'battery','color','noise','figs'})</a:t>
                       </a:r>
                     </a:p>
                   </a:txBody>
@@ -8617,29 +8682,7 @@
                           </a:solidFill>
                           <a:latin typeface="Arial"/>
                         </a:rPr>
-                        <a:t>gain 0.92, floor 46 pm</a:t>
-                      </a:r>
-                    </a:p>
-                  </a:txBody>
-                  <a:tcPr marL="54864" marR="54864" marT="18288" marB="18288">
-                    <a:solidFill>
-                      <a:srgbClr val="ECF1F6"/>
-                    </a:solidFill>
-                  </a:tcPr>
-                </a:tc>
-                <a:tc>
-                  <a:txBody>
-                    <a:bodyPr wrap="square"/>
-                    <a:lstStyle/>
-                    <a:p>
-                      <a:r>
-                        <a:rPr sz="1100" b="0">
-                          <a:solidFill>
-                            <a:srgbClr val="282828"/>
-                          </a:solidFill>
-                          <a:latin typeface="Arial"/>
-                        </a:rPr>
-                        <a:t>gain 0.99, floor 5 pm (stepped, four frames; matrix on the surface) — gain 1.05, floor 23 pm (linear, one frame)</a:t>
+                        <a:t>everything on this deck's later slides</a:t>
                       </a:r>
                     </a:p>
                   </a:txBody>
@@ -8663,7 +8706,7 @@
                           </a:solidFill>
                           <a:latin typeface="Arial"/>
                         </a:rPr>
-                        <a:t>photons per measurement for 1 pm</a:t>
+                        <a:t>./zwfs_batch.sh TAG "the same arguments"</a:t>
                       </a:r>
                     </a:p>
                   </a:txBody>
@@ -8685,103 +8728,13 @@
                           </a:solidFill>
                           <a:latin typeface="Arial"/>
                         </a:rPr>
-                        <a:t>8×10¹⁴</a:t>
+                        <a:t>unattended, memory-capped, logged</a:t>
                       </a:r>
                     </a:p>
                   </a:txBody>
                   <a:tcPr marL="54864" marR="54864" marT="18288" marB="18288">
                     <a:solidFill>
                       <a:srgbClr val="FFFFFF"/>
-                    </a:solidFill>
-                  </a:tcPr>
-                </a:tc>
-                <a:tc>
-                  <a:txBody>
-                    <a:bodyPr wrap="square"/>
-                    <a:lstStyle/>
-                    <a:p>
-                      <a:r>
-                        <a:rPr sz="1100" b="0">
-                          <a:solidFill>
-                            <a:srgbClr val="282828"/>
-                          </a:solidFill>
-                          <a:latin typeface="Arial"/>
-                        </a:rPr>
-                        <a:t>0.4 to 1×10¹⁴</a:t>
-                      </a:r>
-                    </a:p>
-                  </a:txBody>
-                  <a:tcPr marL="54864" marR="54864" marT="18288" marB="18288">
-                    <a:solidFill>
-                      <a:srgbClr val="FFFFFF"/>
-                    </a:solidFill>
-                  </a:tcPr>
-                </a:tc>
-              </a:tr>
-              <a:tr h="468630">
-                <a:tc>
-                  <a:txBody>
-                    <a:bodyPr wrap="square"/>
-                    <a:lstStyle/>
-                    <a:p>
-                      <a:r>
-                        <a:rPr sz="1100" b="0">
-                          <a:solidFill>
-                            <a:srgbClr val="282828"/>
-                          </a:solidFill>
-                          <a:latin typeface="Arial"/>
-                        </a:rPr>
-                        <a:t>held in closed loop to 3 pm against a 2 pm random walk: photons per cycle</a:t>
-                      </a:r>
-                    </a:p>
-                  </a:txBody>
-                  <a:tcPr marL="54864" marR="54864" marT="18288" marB="18288">
-                    <a:solidFill>
-                      <a:srgbClr val="ECF1F6"/>
-                    </a:solidFill>
-                  </a:tcPr>
-                </a:tc>
-                <a:tc>
-                  <a:txBody>
-                    <a:bodyPr wrap="square"/>
-                    <a:lstStyle/>
-                    <a:p>
-                      <a:r>
-                        <a:rPr sz="1100" b="0">
-                          <a:solidFill>
-                            <a:srgbClr val="282828"/>
-                          </a:solidFill>
-                          <a:latin typeface="Arial"/>
-                        </a:rPr>
-                        <a:t>pending (same loop code, CCMac)</a:t>
-                      </a:r>
-                    </a:p>
-                  </a:txBody>
-                  <a:tcPr marL="54864" marR="54864" marT="18288" marB="18288">
-                    <a:solidFill>
-                      <a:srgbClr val="ECF1F6"/>
-                    </a:solidFill>
-                  </a:tcPr>
-                </a:tc>
-                <a:tc>
-                  <a:txBody>
-                    <a:bodyPr wrap="square"/>
-                    <a:lstStyle/>
-                    <a:p>
-                      <a:r>
-                        <a:rPr sz="1100" b="0">
-                          <a:solidFill>
-                            <a:srgbClr val="282828"/>
-                          </a:solidFill>
-                          <a:latin typeface="Arial"/>
-                        </a:rPr>
-                        <a:t>7.5×10¹² (stepped), 7.3×10¹² (linear), 5.3×10¹² (polarized pair)</a:t>
-                      </a:r>
-                    </a:p>
-                  </a:txBody>
-                  <a:tcPr marL="54864" marR="54864" marT="18288" marB="18288">
-                    <a:solidFill>
-                      <a:srgbClr val="ECF1F6"/>
                     </a:solidFill>
                   </a:tcPr>
                 </a:tc>
@@ -8792,13 +8745,13 @@
       </p:graphicFrame>
       <p:sp>
         <p:nvSpPr>
-          <p:cNvPr id="5" name="TextBox 4"/>
+          <p:cNvPr id="6" name="TextBox 5"/>
           <p:cNvSpPr txBox="1"/>
           <p:nvPr/>
         </p:nvSpPr>
         <p:spPr>
           <a:xfrm>
-            <a:off x="411480" y="5468112"/>
+            <a:off x="411480" y="4292346"/>
             <a:ext cx="11368735" cy="274320"/>
           </a:xfrm>
           <a:prstGeom prst="rect">
@@ -8824,20 +8777,20 @@
                 </a:solidFill>
                 <a:latin typeface="Arial"/>
               </a:rPr>
-              <a:t>•  Reading: the interferometer measures any surface and pays at fine patterns; the sensor measures small changes on a small working surface more cheaply — no polarization train, a floor ten times lower once its response matrix is measured on that surface — and pays at the lowest spatial frequencies and in the surface it can handle.</a:t>
-            </a:r>
-          </a:p>
-        </p:txBody>
-      </p:sp>
-      <p:sp>
-        <p:nvSpPr>
-          <p:cNvPr id="6" name="TextBox 5"/>
+              <a:t>•  Checks that run every time: the no-mask round trip through the bracket (must return the field unchanged); the reference-wave model against the engine's own field; the pupil brightness must not change with the DM shape; the sampling checks (pixels across the dimple, camera pixels per actuator); and the search for the camera-to-DM mirror/transpose and sign.</a:t>
+            </a:r>
+          </a:p>
+        </p:txBody>
+      </p:sp>
+      <p:sp>
+        <p:nvSpPr>
+          <p:cNvPr id="7" name="TextBox 6"/>
           <p:cNvSpPr txBox="1"/>
           <p:nvPr/>
         </p:nvSpPr>
         <p:spPr>
           <a:xfrm>
-            <a:off x="411480" y="6387846"/>
+            <a:off x="411480" y="5459730"/>
             <a:ext cx="11368735" cy="274320"/>
           </a:xfrm>
           <a:prstGeom prst="rect">
@@ -8863,7 +8816,7 @@
                 </a:solidFill>
                 <a:latin typeface="Arial"/>
               </a:rPr>
-              <a:t>PSI column: tg_psi_dm96 run 10 and S4/S5; sensor column: 385 rays, matrix calibration on the working surface (slide 10), photons at development sampling.  Both in actuator units through the same code (dm_gauge_lib).</a:t>
+              <a:t>Reproduction check: 64 lines of results against the stage-7 report, 8 differ in the last printed digit (the actuator fit's solver tolerance).  README "Run it yourself" carries the parameter table.</a:t>
             </a:r>
           </a:p>
         </p:txBody>
@@ -8920,7 +8873,7 @@
                 </a:solidFill>
                 <a:latin typeface="Arial"/>
               </a:rPr>
-              <a:t>What the Zernike-sensor literature offers, in priority order</a:t>
+              <a:t>Side by side with the Twyman–Green</a:t>
             </a:r>
           </a:p>
           <a:p>
@@ -8936,7 +8889,7 @@
                 </a:solidFill>
                 <a:latin typeface="Arial"/>
               </a:rPr>
-              <a:t>Twelve papers read; the first import — re-computing the reference wave — is now built and measured (slide 8)</a:t>
+              <a:t>The interferometer loses response at fine patterns and never fails; the sensor, calibrated on its working surface, reads a change to 5 pm up to 50–60 nm</a:t>
             </a:r>
           </a:p>
         </p:txBody>
@@ -8995,7 +8948,7 @@
         </p:nvGraphicFramePr>
         <p:xfrm>
           <a:off x="411480" y="1298448"/>
-          <a:ext cx="11368734" cy="3091815"/>
+          <a:ext cx="11368733" cy="4303395"/>
         </p:xfrm>
         <a:graphic>
           <a:graphicData uri="http://schemas.openxmlformats.org/drawingml/2006/table">
@@ -9004,15 +8957,27 @@
                 <a:tableStyleId>{5C22544A-7EE6-4342-B048-85BDC9FD1C3A}</a:tableStyleId>
               </a:tblPr>
               <a:tblGrid>
-                <a:gridCol w="218948"/>
-                <a:gridCol w="2691327"/>
-                <a:gridCol w="8458459"/>
+                <a:gridCol w="3531564"/>
+                <a:gridCol w="2418879"/>
+                <a:gridCol w="5418290"/>
               </a:tblGrid>
               <a:tr h="280035">
                 <a:tc>
                   <a:txBody>
                     <a:bodyPr wrap="square"/>
                     <a:lstStyle/>
+                    <a:p/>
+                  </a:txBody>
+                  <a:tcPr marL="54864" marR="54864" marT="18288" marB="18288">
+                    <a:solidFill>
+                      <a:srgbClr val="1F4E79"/>
+                    </a:solidFill>
+                  </a:tcPr>
+                </a:tc>
+                <a:tc>
+                  <a:txBody>
+                    <a:bodyPr wrap="square"/>
+                    <a:lstStyle/>
                     <a:p>
                       <a:r>
                         <a:rPr sz="1100" b="1">
@@ -9021,7 +8986,7 @@
                           </a:solidFill>
                           <a:latin typeface="Arial"/>
                         </a:rPr>
-                        <a:t>#</a:t>
+                        <a:t>Twyman–Green PSI (measured)</a:t>
                       </a:r>
                     </a:p>
                   </a:txBody>
@@ -9043,7 +9008,7 @@
                           </a:solidFill>
                           <a:latin typeface="Arial"/>
                         </a:rPr>
-                        <a:t>paper</a:t>
+                        <a:t>Zernike sensor (measured)</a:t>
                       </a:r>
                     </a:p>
                   </a:txBody>
@@ -9053,25 +9018,71 @@
                     </a:solidFill>
                   </a:tcPr>
                 </a:tc>
-                <a:tc>
-                  <a:txBody>
-                    <a:bodyPr wrap="square"/>
-                    <a:lstStyle/>
-                    <a:p>
-                      <a:r>
-                        <a:rPr sz="1100" b="1">
-                          <a:solidFill>
-                            <a:srgbClr val="FFFFFF"/>
-                          </a:solidFill>
-                          <a:latin typeface="Arial"/>
-                        </a:rPr>
-                        <a:t>what it gives this model</a:t>
-                      </a:r>
-                    </a:p>
-                  </a:txBody>
-                  <a:tcPr marL="54864" marR="54864" marT="18288" marB="18288">
-                    <a:solidFill>
-                      <a:srgbClr val="1F4E79"/>
+              </a:tr>
+              <a:tr h="280035">
+                <a:tc>
+                  <a:txBody>
+                    <a:bodyPr wrap="square"/>
+                    <a:lstStyle/>
+                    <a:p>
+                      <a:r>
+                        <a:rPr sz="1100" b="0">
+                          <a:solidFill>
+                            <a:srgbClr val="282828"/>
+                          </a:solidFill>
+                          <a:latin typeface="Arial"/>
+                        </a:rPr>
+                        <a:t>reference beam</a:t>
+                      </a:r>
+                    </a:p>
+                  </a:txBody>
+                  <a:tcPr marL="54864" marR="54864" marT="18288" marB="18288">
+                    <a:solidFill>
+                      <a:srgbClr val="FFFFFF"/>
+                    </a:solidFill>
+                  </a:tcPr>
+                </a:tc>
+                <a:tc>
+                  <a:txBody>
+                    <a:bodyPr wrap="square"/>
+                    <a:lstStyle/>
+                    <a:p>
+                      <a:r>
+                        <a:rPr sz="1100" b="0">
+                          <a:solidFill>
+                            <a:srgbClr val="282828"/>
+                          </a:solidFill>
+                          <a:latin typeface="Arial"/>
+                        </a:rPr>
+                        <a:t>the second arm's flat</a:t>
+                      </a:r>
+                    </a:p>
+                  </a:txBody>
+                  <a:tcPr marL="54864" marR="54864" marT="18288" marB="18288">
+                    <a:solidFill>
+                      <a:srgbClr val="FFFFFF"/>
+                    </a:solidFill>
+                  </a:tcPr>
+                </a:tc>
+                <a:tc>
+                  <a:txBody>
+                    <a:bodyPr wrap="square"/>
+                    <a:lstStyle/>
+                    <a:p>
+                      <a:r>
+                        <a:rPr sz="1100" b="0">
+                          <a:solidFill>
+                            <a:srgbClr val="282828"/>
+                          </a:solidFill>
+                          <a:latin typeface="Arial"/>
+                        </a:rPr>
+                        <a:t>made from the beam's own focal core</a:t>
+                      </a:r>
+                    </a:p>
+                  </a:txBody>
+                  <a:tcPr marL="54864" marR="54864" marT="18288" marB="18288">
+                    <a:solidFill>
+                      <a:srgbClr val="FFFFFF"/>
                     </a:solidFill>
                   </a:tcPr>
                 </a:tc>
@@ -9089,7 +9100,75 @@
                           </a:solidFill>
                           <a:latin typeface="Arial"/>
                         </a:rPr>
-                        <a:t>1</a:t>
+                        <a:t>one measurement costs</a:t>
+                      </a:r>
+                    </a:p>
+                  </a:txBody>
+                  <a:tcPr marL="54864" marR="54864" marT="18288" marB="18288">
+                    <a:solidFill>
+                      <a:srgbClr val="ECF1F6"/>
+                    </a:solidFill>
+                  </a:tcPr>
+                </a:tc>
+                <a:tc>
+                  <a:txBody>
+                    <a:bodyPr wrap="square"/>
+                    <a:lstStyle/>
+                    <a:p>
+                      <a:r>
+                        <a:rPr sz="1100" b="0">
+                          <a:solidFill>
+                            <a:srgbClr val="282828"/>
+                          </a:solidFill>
+                          <a:latin typeface="Arial"/>
+                        </a:rPr>
+                        <a:t>6 traces (3 per arm), 4 fringe frames</a:t>
+                      </a:r>
+                    </a:p>
+                  </a:txBody>
+                  <a:tcPr marL="54864" marR="54864" marT="18288" marB="18288">
+                    <a:solidFill>
+                      <a:srgbClr val="ECF1F6"/>
+                    </a:solidFill>
+                  </a:tcPr>
+                </a:tc>
+                <a:tc>
+                  <a:txBody>
+                    <a:bodyPr wrap="square"/>
+                    <a:lstStyle/>
+                    <a:p>
+                      <a:r>
+                        <a:rPr sz="1100" b="0">
+                          <a:solidFill>
+                            <a:srgbClr val="282828"/>
+                          </a:solidFill>
+                          <a:latin typeface="Arial"/>
+                        </a:rPr>
+                        <a:t>1 or 4 camera frames; 256 calibration frames once per working surface</a:t>
+                      </a:r>
+                    </a:p>
+                  </a:txBody>
+                  <a:tcPr marL="54864" marR="54864" marT="18288" marB="18288">
+                    <a:solidFill>
+                      <a:srgbClr val="ECF1F6"/>
+                    </a:solidFill>
+                  </a:tcPr>
+                </a:tc>
+              </a:tr>
+              <a:tr h="280035">
+                <a:tc>
+                  <a:txBody>
+                    <a:bodyPr wrap="square"/>
+                    <a:lstStyle/>
+                    <a:p>
+                      <a:r>
+                        <a:rPr sz="1100" b="0">
+                          <a:solidFill>
+                            <a:srgbClr val="282828"/>
+                          </a:solidFill>
+                          <a:latin typeface="Arial"/>
+                        </a:rPr>
+                        <a:t>polarization hardware</a:t>
                       </a:r>
                     </a:p>
                   </a:txBody>
@@ -9111,7 +9190,7 @@
                           </a:solidFill>
                           <a:latin typeface="Arial"/>
                         </a:rPr>
-                        <a:t>Ruane, Wallace, Steeves et al. 2020, JATIS 6, 045005</a:t>
+                        <a:t>polarizer, 5 waveplates, analyzer</a:t>
                       </a:r>
                     </a:p>
                   </a:txBody>
@@ -9133,7 +9212,143 @@
                           </a:solidFill>
                           <a:latin typeface="Arial"/>
                         </a:rPr>
-                        <a:t>Exact per-pixel reconstruction from the pupil amplitude, the reference wave b and the masked image; a sensitivity factor per pixel; a four-term systematic budget; 1 pm reached at 4.4×10⁵ frames; no loss to 25 % bandwidth</a:t>
+                        <a:t>none</a:t>
+                      </a:r>
+                    </a:p>
+                  </a:txBody>
+                  <a:tcPr marL="54864" marR="54864" marT="18288" marB="18288">
+                    <a:solidFill>
+                      <a:srgbClr val="FFFFFF"/>
+                    </a:solidFill>
+                  </a:tcPr>
+                </a:tc>
+              </a:tr>
+              <a:tr h="280035">
+                <a:tc>
+                  <a:txBody>
+                    <a:bodyPr wrap="square"/>
+                    <a:lstStyle/>
+                    <a:p>
+                      <a:r>
+                        <a:rPr sz="1100" b="0">
+                          <a:solidFill>
+                            <a:srgbClr val="282828"/>
+                          </a:solidFill>
+                          <a:latin typeface="Arial"/>
+                        </a:rPr>
+                        <a:t>moving parts</a:t>
+                      </a:r>
+                    </a:p>
+                  </a:txBody>
+                  <a:tcPr marL="54864" marR="54864" marT="18288" marB="18288">
+                    <a:solidFill>
+                      <a:srgbClr val="ECF1F6"/>
+                    </a:solidFill>
+                  </a:tcPr>
+                </a:tc>
+                <a:tc>
+                  <a:txBody>
+                    <a:bodyPr wrap="square"/>
+                    <a:lstStyle/>
+                    <a:p>
+                      <a:r>
+                        <a:rPr sz="1100" b="0">
+                          <a:solidFill>
+                            <a:srgbClr val="282828"/>
+                          </a:solidFill>
+                          <a:latin typeface="Arial"/>
+                        </a:rPr>
+                        <a:t>none (polarization-stepped)</a:t>
+                      </a:r>
+                    </a:p>
+                  </a:txBody>
+                  <a:tcPr marL="54864" marR="54864" marT="18288" marB="18288">
+                    <a:solidFill>
+                      <a:srgbClr val="ECF1F6"/>
+                    </a:solidFill>
+                  </a:tcPr>
+                </a:tc>
+                <a:tc>
+                  <a:txBody>
+                    <a:bodyPr wrap="square"/>
+                    <a:lstStyle/>
+                    <a:p>
+                      <a:r>
+                        <a:rPr sz="1100" b="0">
+                          <a:solidFill>
+                            <a:srgbClr val="282828"/>
+                          </a:solidFill>
+                          <a:latin typeface="Arial"/>
+                        </a:rPr>
+                        <a:t>none</a:t>
+                      </a:r>
+                    </a:p>
+                  </a:txBody>
+                  <a:tcPr marL="54864" marR="54864" marT="18288" marB="18288">
+                    <a:solidFill>
+                      <a:srgbClr val="ECF1F6"/>
+                    </a:solidFill>
+                  </a:tcPr>
+                </a:tc>
+              </a:tr>
+              <a:tr h="280035">
+                <a:tc>
+                  <a:txBody>
+                    <a:bodyPr wrap="square"/>
+                    <a:lstStyle/>
+                    <a:p>
+                      <a:r>
+                        <a:rPr sz="1100" b="0">
+                          <a:solidFill>
+                            <a:srgbClr val="282828"/>
+                          </a:solidFill>
+                          <a:latin typeface="Arial"/>
+                        </a:rPr>
+                        <a:t>null, nothing aligned</a:t>
+                      </a:r>
+                    </a:p>
+                  </a:txBody>
+                  <a:tcPr marL="54864" marR="54864" marT="18288" marB="18288">
+                    <a:solidFill>
+                      <a:srgbClr val="FFFFFF"/>
+                    </a:solidFill>
+                  </a:tcPr>
+                </a:tc>
+                <a:tc>
+                  <a:txBody>
+                    <a:bodyPr wrap="square"/>
+                    <a:lstStyle/>
+                    <a:p>
+                      <a:r>
+                        <a:rPr sz="1100" b="0">
+                          <a:solidFill>
+                            <a:srgbClr val="282828"/>
+                          </a:solidFill>
+                          <a:latin typeface="Arial"/>
+                        </a:rPr>
+                        <a:t>0.134 nm</a:t>
+                      </a:r>
+                    </a:p>
+                  </a:txBody>
+                  <a:tcPr marL="54864" marR="54864" marT="18288" marB="18288">
+                    <a:solidFill>
+                      <a:srgbClr val="FFFFFF"/>
+                    </a:solidFill>
+                  </a:tcPr>
+                </a:tc>
+                <a:tc>
+                  <a:txBody>
+                    <a:bodyPr wrap="square"/>
+                    <a:lstStyle/>
+                    <a:p>
+                      <a:r>
+                        <a:rPr sz="1100" b="0">
+                          <a:solidFill>
+                            <a:srgbClr val="282828"/>
+                          </a:solidFill>
+                          <a:latin typeface="Arial"/>
+                        </a:rPr>
+                        <a:t>0 by construction (the flat is the reference)</a:t>
                       </a:r>
                     </a:p>
                   </a:txBody>
@@ -9157,7 +9372,7 @@
                           </a:solidFill>
                           <a:latin typeface="Arial"/>
                         </a:rPr>
-                        <a:t>2</a:t>
+                        <a:t>response falls off at</a:t>
                       </a:r>
                     </a:p>
                   </a:txBody>
@@ -9179,7 +9394,7 @@
                           </a:solidFill>
                           <a:latin typeface="Arial"/>
                         </a:rPr>
-                        <a:t>Doelman, Fagginger Auer, Escuti, Snik 2019, Opt. Lett. 44, 17</a:t>
+                        <a:t>fine patterns: 0.50 at the 96×96 checkerboard</a:t>
                       </a:r>
                     </a:p>
                   </a:txBody>
@@ -9201,13 +9416,81 @@
                           </a:solidFill>
                           <a:latin typeface="Arial"/>
                         </a:rPr>
-                        <a:t>Vector Zernike: ±π/2 on opposite circular polarizations gives two pupil images, an exact phase-and-amplitude solution, an iterated b, achromatic to 100 % bandwidth; the leakage terms are written down</a:t>
+                        <a:t>0.5 to 1 cycle across the pupil (0.5 at 1); piston unseen</a:t>
                       </a:r>
                     </a:p>
                   </a:txBody>
                   <a:tcPr marL="54864" marR="54864" marT="18288" marB="18288">
                     <a:solidFill>
                       <a:srgbClr val="ECF1F6"/>
+                    </a:solidFill>
+                  </a:tcPr>
+                </a:tc>
+              </a:tr>
+              <a:tr h="280035">
+                <a:tc>
+                  <a:txBody>
+                    <a:bodyPr wrap="square"/>
+                    <a:lstStyle/>
+                    <a:p>
+                      <a:r>
+                        <a:rPr sz="1100" b="0">
+                          <a:solidFill>
+                            <a:srgbClr val="282828"/>
+                          </a:solidFill>
+                          <a:latin typeface="Arial"/>
+                        </a:rPr>
+                        <a:t>working surface it can handle</a:t>
+                      </a:r>
+                    </a:p>
+                  </a:txBody>
+                  <a:tcPr marL="54864" marR="54864" marT="18288" marB="18288">
+                    <a:solidFill>
+                      <a:srgbClr val="FFFFFF"/>
+                    </a:solidFill>
+                  </a:tcPr>
+                </a:tc>
+                <a:tc>
+                  <a:txBody>
+                    <a:bodyPr wrap="square"/>
+                    <a:lstStyle/>
+                    <a:p>
+                      <a:r>
+                        <a:rPr sz="1100" b="0">
+                          <a:solidFill>
+                            <a:srgbClr val="282828"/>
+                          </a:solidFill>
+                          <a:latin typeface="Arial"/>
+                        </a:rPr>
+                        <a:t>480 nm rms and beyond</a:t>
+                      </a:r>
+                    </a:p>
+                  </a:txBody>
+                  <a:tcPr marL="54864" marR="54864" marT="18288" marB="18288">
+                    <a:solidFill>
+                      <a:srgbClr val="FFFFFF"/>
+                    </a:solidFill>
+                  </a:tcPr>
+                </a:tc>
+                <a:tc>
+                  <a:txBody>
+                    <a:bodyPr wrap="square"/>
+                    <a:lstStyle/>
+                    <a:p>
+                      <a:r>
+                        <a:rPr sz="1100" b="0">
+                          <a:solidFill>
+                            <a:srgbClr val="282828"/>
+                          </a:solidFill>
+                          <a:latin typeface="Arial"/>
+                        </a:rPr>
+                        <a:t>40 nm rms one-frame (1 mm actuators), 50–60 nm four-frame</a:t>
+                      </a:r>
+                    </a:p>
+                  </a:txBody>
+                  <a:tcPr marL="54864" marR="54864" marT="18288" marB="18288">
+                    <a:solidFill>
+                      <a:srgbClr val="FFFFFF"/>
                     </a:solidFill>
                   </a:tcPr>
                 </a:tc>
@@ -9225,7 +9508,75 @@
                           </a:solidFill>
                           <a:latin typeface="Arial"/>
                         </a:rPr>
-                        <a:t>3</a:t>
+                        <a:t>a 10 nm actuator change on a 30 nm surface</a:t>
+                      </a:r>
+                    </a:p>
+                  </a:txBody>
+                  <a:tcPr marL="54864" marR="54864" marT="18288" marB="18288">
+                    <a:solidFill>
+                      <a:srgbClr val="ECF1F6"/>
+                    </a:solidFill>
+                  </a:tcPr>
+                </a:tc>
+                <a:tc>
+                  <a:txBody>
+                    <a:bodyPr wrap="square"/>
+                    <a:lstStyle/>
+                    <a:p>
+                      <a:r>
+                        <a:rPr sz="1100" b="0">
+                          <a:solidFill>
+                            <a:srgbClr val="282828"/>
+                          </a:solidFill>
+                          <a:latin typeface="Arial"/>
+                        </a:rPr>
+                        <a:t>gain 0.92, floor 46 pm</a:t>
+                      </a:r>
+                    </a:p>
+                  </a:txBody>
+                  <a:tcPr marL="54864" marR="54864" marT="18288" marB="18288">
+                    <a:solidFill>
+                      <a:srgbClr val="ECF1F6"/>
+                    </a:solidFill>
+                  </a:tcPr>
+                </a:tc>
+                <a:tc>
+                  <a:txBody>
+                    <a:bodyPr wrap="square"/>
+                    <a:lstStyle/>
+                    <a:p>
+                      <a:r>
+                        <a:rPr sz="1100" b="0">
+                          <a:solidFill>
+                            <a:srgbClr val="282828"/>
+                          </a:solidFill>
+                          <a:latin typeface="Arial"/>
+                        </a:rPr>
+                        <a:t>gain 0.99, floor 5 pm (stepped, four frames; matrix on the surface) — gain 1.05, floor 23 pm (linear, one frame)</a:t>
+                      </a:r>
+                    </a:p>
+                  </a:txBody>
+                  <a:tcPr marL="54864" marR="54864" marT="18288" marB="18288">
+                    <a:solidFill>
+                      <a:srgbClr val="ECF1F6"/>
+                    </a:solidFill>
+                  </a:tcPr>
+                </a:tc>
+              </a:tr>
+              <a:tr h="280035">
+                <a:tc>
+                  <a:txBody>
+                    <a:bodyPr wrap="square"/>
+                    <a:lstStyle/>
+                    <a:p>
+                      <a:r>
+                        <a:rPr sz="1100" b="0">
+                          <a:solidFill>
+                            <a:srgbClr val="282828"/>
+                          </a:solidFill>
+                          <a:latin typeface="Arial"/>
+                        </a:rPr>
+                        <a:t>photons per measurement for 1 pm</a:t>
                       </a:r>
                     </a:p>
                   </a:txBody>
@@ -9247,7 +9598,7 @@
                           </a:solidFill>
                           <a:latin typeface="Arial"/>
                         </a:rPr>
-                        <a:t>N'Diaye, Vigan, Dohlen et al. 2016, A&amp;A 592, A79 (ZELDA II)</a:t>
+                        <a:t>8×10¹⁴</a:t>
                       </a:r>
                     </a:p>
                   </a:txBody>
@@ -9269,7 +9620,7 @@
                           </a:solidFill>
                           <a:latin typeface="Arial"/>
                         </a:rPr>
-                        <a:t>Second-order reconstruction with b from the mask model; 1.06 λ/D at π/2; range −0.14 to +0.36 λ; the sensitivity factor drifts 10 % day to day on SPHERE</a:t>
+                        <a:t>0.4 to 1×10¹⁴</a:t>
                       </a:r>
                     </a:p>
                   </a:txBody>
@@ -9293,7 +9644,7 @@
                           </a:solidFill>
                           <a:latin typeface="Arial"/>
                         </a:rPr>
-                        <a:t>4</a:t>
+                        <a:t>held in closed loop to 3 pm against a 2 pm random walk: photons per cycle</a:t>
                       </a:r>
                     </a:p>
                   </a:txBody>
@@ -9315,7 +9666,7 @@
                           </a:solidFill>
                           <a:latin typeface="Arial"/>
                         </a:rPr>
-                        <a:t>Chambouleyron, Cissé, Salama, Haffert, Wallace et al. 2024, SPIE 13097</a:t>
+                        <a:t>2.0×10¹³ (lens rig); never with the reflective rig</a:t>
                       </a:r>
                     </a:p>
                   </a:txBody>
@@ -9337,7 +9688,7 @@
                           </a:solidFill>
                           <a:latin typeface="Arial"/>
                         </a:rPr>
-                        <a:t>A phase-shifted pair (±π/2) yields cos φ and sin φ; iterative reconstructors reach about 1 rad rms; the bench limits were polarization crosstalk and defocus between the two pupils</a:t>
+                        <a:t>7.5×10¹² (stepped), 7.3×10¹² (linear), 5.3×10¹² (polarized pair)</a:t>
                       </a:r>
                     </a:p>
                   </a:txBody>
@@ -9361,7 +9712,7 @@
                           </a:solidFill>
                           <a:latin typeface="Arial"/>
                         </a:rPr>
-                        <a:t>5</a:t>
+                        <a:t>fixed error in closed loop (noise-free 1 nm step after 60 cycles)</a:t>
                       </a:r>
                     </a:p>
                   </a:txBody>
@@ -9383,7 +9734,7 @@
                           </a:solidFill>
                           <a:latin typeface="Arial"/>
                         </a:rPr>
-                        <a:t>Haffert 2024, A&amp;A 683, A113</a:t>
+                        <a:t>87 pm and rising (lens); 276 pm (reflective)</a:t>
                       </a:r>
                     </a:p>
                   </a:txBody>
@@ -9405,81 +9756,13 @@
                           </a:solidFill>
                           <a:latin typeface="Arial"/>
                         </a:rPr>
-                        <a:t>Iterative nonlinear reconstructors reach machine precision below 0.25 rad rms; phase sorting extends to 0.75 rad; adding wavelengths to 1.4 rad rms</a:t>
+                        <a:t>0.000 pm (stepped, polarized pair)</a:t>
                       </a:r>
                     </a:p>
                   </a:txBody>
                   <a:tcPr marL="54864" marR="54864" marT="18288" marB="18288">
                     <a:solidFill>
                       <a:srgbClr val="FFFFFF"/>
-                    </a:solidFill>
-                  </a:tcPr>
-                </a:tc>
-              </a:tr>
-              <a:tr h="468630">
-                <a:tc>
-                  <a:txBody>
-                    <a:bodyPr wrap="square"/>
-                    <a:lstStyle/>
-                    <a:p>
-                      <a:r>
-                        <a:rPr sz="1100" b="0">
-                          <a:solidFill>
-                            <a:srgbClr val="282828"/>
-                          </a:solidFill>
-                          <a:latin typeface="Arial"/>
-                        </a:rPr>
-                        <a:t>6</a:t>
-                      </a:r>
-                    </a:p>
-                  </a:txBody>
-                  <a:tcPr marL="54864" marR="54864" marT="18288" marB="18288">
-                    <a:solidFill>
-                      <a:srgbClr val="ECF1F6"/>
-                    </a:solidFill>
-                  </a:tcPr>
-                </a:tc>
-                <a:tc>
-                  <a:txBody>
-                    <a:bodyPr wrap="square"/>
-                    <a:lstStyle/>
-                    <a:p>
-                      <a:r>
-                        <a:rPr sz="1100" b="0">
-                          <a:solidFill>
-                            <a:srgbClr val="282828"/>
-                          </a:solidFill>
-                          <a:latin typeface="Arial"/>
-                        </a:rPr>
-                        <a:t>Darcis, Haffert, Chambouleyron, Doelman et al. 2025, A&amp;A</a:t>
-                      </a:r>
-                    </a:p>
-                  </a:txBody>
-                  <a:tcPr marL="54864" marR="54864" marT="18288" marB="18288">
-                    <a:solidFill>
-                      <a:srgbClr val="ECF1F6"/>
-                    </a:solidFill>
-                  </a:tcPr>
-                </a:tc>
-                <a:tc>
-                  <a:txBody>
-                    <a:bodyPr wrap="square"/>
-                    <a:lstStyle/>
-                    <a:p>
-                      <a:r>
-                        <a:rPr sz="1100" b="0">
-                          <a:solidFill>
-                            <a:srgbClr val="282828"/>
-                          </a:solidFill>
-                          <a:latin typeface="Arial"/>
-                        </a:rPr>
-                        <a:t>Multi-wavelength gradient descent through the forward model: dynamic range for the scalar sensor, photon robustness across a wider band, two-wavelength unwrapping of petal errors</a:t>
-                      </a:r>
-                    </a:p>
-                  </a:txBody>
-                  <a:tcPr marL="54864" marR="54864" marT="18288" marB="18288">
-                    <a:solidFill>
-                      <a:srgbClr val="ECF1F6"/>
                     </a:solidFill>
                   </a:tcPr>
                 </a:tc>
@@ -9496,7 +9779,7 @@
         </p:nvSpPr>
         <p:spPr>
           <a:xfrm>
-            <a:off x="411480" y="4536567"/>
+            <a:off x="411480" y="5748147"/>
             <a:ext cx="11368735" cy="274320"/>
           </a:xfrm>
           <a:prstGeom prst="rect">
@@ -9516,13 +9799,52 @@
               </a:spcAft>
             </a:pPr>
             <a:r>
-              <a:rPr sz="1050" b="0">
-                <a:solidFill>
-                  <a:srgbClr val="6E6E6E"/>
+              <a:rPr sz="1500" b="0">
+                <a:solidFill>
+                  <a:srgbClr val="282828"/>
                 </a:solidFill>
                 <a:latin typeface="Arial"/>
               </a:rPr>
-              <a:t>Priority = payoff against this campaign's measured weak results.  Synopses and links: macos/REPORT_zwfs_lit_scan.md.</a:t>
+              <a:t>•  Reading: the interferometer measures any surface and pays at fine patterns; the sensor measures small changes on a small working surface more cheaply — no polarization train, a floor ten times lower once its response matrix is measured on that surface — and pays at the lowest spatial frequencies and in the surface it can handle.</a:t>
+            </a:r>
+          </a:p>
+        </p:txBody>
+      </p:sp>
+      <p:sp>
+        <p:nvSpPr>
+          <p:cNvPr id="6" name="TextBox 5"/>
+          <p:cNvSpPr txBox="1"/>
+          <p:nvPr/>
+        </p:nvSpPr>
+        <p:spPr>
+          <a:xfrm>
+            <a:off x="411480" y="6667881"/>
+            <a:ext cx="11368735" cy="274320"/>
+          </a:xfrm>
+          <a:prstGeom prst="rect">
+            <a:avLst/>
+          </a:prstGeom>
+          <a:noFill/>
+        </p:spPr>
+        <p:txBody>
+          <a:bodyPr wrap="square">
+            <a:spAutoFit/>
+          </a:bodyPr>
+          <a:lstStyle/>
+          <a:p>
+            <a:pPr>
+              <a:spcAft>
+                <a:spcPts val="600"/>
+              </a:spcAft>
+            </a:pPr>
+            <a:r>
+              <a:rPr sz="1050" b="0">
+                <a:solidFill>
+                  <a:srgbClr val="6E6E6E"/>
+                </a:solidFill>
+                <a:latin typeface="Arial"/>
+              </a:rPr>
+              <a:t>PSI column: tg_psi_dm96 run 10 and S4/S5; sensor column: 385 rays, matrix calibration on the working surface (slide 10), photons at development sampling.  Both in actuator units through the same code (dm_gauge_lib).</a:t>
             </a:r>
           </a:p>
         </p:txBody>
@@ -9579,7 +9901,7 @@
                 </a:solidFill>
                 <a:latin typeface="Arial"/>
               </a:rPr>
-              <a:t>Demonstrations, segmented mirrors, and the in-house precedent</a:t>
+              <a:t>What the Zernike-sensor literature offers, in priority order</a:t>
             </a:r>
           </a:p>
           <a:p>
@@ -9595,7 +9917,7 @@
                 </a:solidFill>
                 <a:latin typeface="Arial"/>
               </a:rPr>
-              <a:t>Picometers by alternating DM shapes and averaging; segment piston by model iteration, underestimated below 50 % Strehl</a:t>
+              <a:t>Twelve papers read; the first import — re-computing the reference wave — is now built and measured (slide 8)</a:t>
             </a:r>
           </a:p>
         </p:txBody>
@@ -9663,9 +9985,9 @@
                 <a:tableStyleId>{5C22544A-7EE6-4342-B048-85BDC9FD1C3A}</a:tableStyleId>
               </a:tblPr>
               <a:tblGrid>
-                <a:gridCol w="291592"/>
-                <a:gridCol w="3730058"/>
-                <a:gridCol w="7347084"/>
+                <a:gridCol w="218948"/>
+                <a:gridCol w="2691327"/>
+                <a:gridCol w="8458459"/>
               </a:tblGrid>
               <a:tr h="280035">
                 <a:tc>
@@ -9748,7 +10070,7 @@
                           </a:solidFill>
                           <a:latin typeface="Arial"/>
                         </a:rPr>
-                        <a:t>7</a:t>
+                        <a:t>1</a:t>
                       </a:r>
                     </a:p>
                   </a:txBody>
@@ -9770,7 +10092,7 @@
                           </a:solidFill>
                           <a:latin typeface="Arial"/>
                         </a:rPr>
-                        <a:t>Steeves, Wallace, Kettenbeil, Jewell 2020, Optica 7, 1267</a:t>
+                        <a:t>Ruane, Wallace, Steeves et al. 2020, JATIS 6, 045005</a:t>
                       </a:r>
                     </a:p>
                   </a:txBody>
@@ -9792,7 +10114,7 @@
                           </a:solidFill>
                           <a:latin typeface="Arial"/>
                         </a:rPr>
-                        <a:t>1.6 pm repeatability in 4.3 s by alternating flat and waffle DM shapes and averaging the differences; a reconstruction robust at the highest spatial frequencies</a:t>
+                        <a:t>Exact per-pixel reconstruction from the pupil amplitude, the reference wave b and the masked image; a sensitivity factor per pixel; a four-term systematic budget; 1 pm reached at 4.4×10⁵ frames; no loss to 25 % bandwidth</a:t>
                       </a:r>
                     </a:p>
                   </a:txBody>
@@ -9816,7 +10138,7 @@
                           </a:solidFill>
                           <a:latin typeface="Arial"/>
                         </a:rPr>
-                        <a:t>8</a:t>
+                        <a:t>2</a:t>
                       </a:r>
                     </a:p>
                   </a:txBody>
@@ -9838,7 +10160,7 @@
                           </a:solidFill>
                           <a:latin typeface="Arial"/>
                         </a:rPr>
-                        <a:t>Wallace, Rao, Jensen-Clem, Serabyn 2011, SPIE 8126</a:t>
+                        <a:t>Doelman, Fagginger Auer, Escuti, Snik 2019, Opt. Lett. 44, 17</a:t>
                       </a:r>
                     </a:p>
                   </a:txBody>
@@ -9860,7 +10182,7 @@
                           </a:solidFill>
                           <a:latin typeface="Arial"/>
                         </a:rPr>
-                        <a:t>All-reflective phase-shifting Zernike interferometer: a dynamic, arbitrary core phase shift read in four steps gives phase and amplitude; low sensitivity to vibration, polarization and wavelength</a:t>
+                        <a:t>Vector Zernike: ±π/2 on opposite circular polarizations gives two pupil images, an exact phase-and-amplitude solution, an iterated b, achromatic to 100 % bandwidth; the leakage terms are written down</a:t>
                       </a:r>
                     </a:p>
                   </a:txBody>
@@ -9884,7 +10206,7 @@
                           </a:solidFill>
                           <a:latin typeface="Arial"/>
                         </a:rPr>
-                        <a:t>9</a:t>
+                        <a:t>3</a:t>
                       </a:r>
                     </a:p>
                   </a:txBody>
@@ -9906,7 +10228,7 @@
                           </a:solidFill>
                           <a:latin typeface="Arial"/>
                         </a:rPr>
-                        <a:t>Moore and Redding 2018, SPIE 10698</a:t>
+                        <a:t>N'Diaye, Vigan, Dohlen et al. 2016, A&amp;A 592, A79 (ZELDA II)</a:t>
                       </a:r>
                     </a:p>
                   </a:txBody>
@@ -9928,7 +10250,7 @@
                           </a:solidFill>
                           <a:latin typeface="Arial"/>
                         </a:rPr>
-                        <a:t>Nonlinear polychromatic physical-optics reconstruction for picometer differential metrology on LUVOIR; the in-house precedent for the reconstructor above</a:t>
+                        <a:t>Second-order reconstruction with b from the mask model; 1.06 λ/D at π/2; range −0.14 to +0.36 λ; the sensitivity factor drifts 10 % day to day on SPHERE</a:t>
                       </a:r>
                     </a:p>
                   </a:txBody>
@@ -9952,7 +10274,7 @@
                           </a:solidFill>
                           <a:latin typeface="Arial"/>
                         </a:rPr>
-                        <a:t>10</a:t>
+                        <a:t>4</a:t>
                       </a:r>
                     </a:p>
                   </a:txBody>
@@ -9974,7 +10296,7 @@
                           </a:solidFill>
                           <a:latin typeface="Arial"/>
                         </a:rPr>
-                        <a:t>Keck vector-Zernike segment control 2024 (arXiv 2404.08728); Wallace et al. 2022 (arXiv 2205.02241)</a:t>
+                        <a:t>Chambouleyron, Cissé, Salama, Haffert, Wallace et al. 2024, SPIE 13097</a:t>
                       </a:r>
                     </a:p>
                   </a:txBody>
@@ -9996,7 +10318,7 @@
                           </a:solidFill>
                           <a:latin typeface="Arial"/>
                         </a:rPr>
-                        <a:t>Segment piston by model-based iteration; 11 nm rms piston uncertainty; underestimation 2 to 4× below 50 % Strehl; fabricated shifts 0.30π and 0.68π instead of ±0.5π</a:t>
+                        <a:t>A phase-shifted pair (±π/2) yields cos φ and sin φ; iterative reconstructors reach about 1 rad rms; the bench limits were polarization crosstalk and defocus between the two pupils</a:t>
                       </a:r>
                     </a:p>
                   </a:txBody>
@@ -10020,7 +10342,7 @@
                           </a:solidFill>
                           <a:latin typeface="Arial"/>
                         </a:rPr>
-                        <a:t>11</a:t>
+                        <a:t>5</a:t>
                       </a:r>
                     </a:p>
                   </a:txBody>
@@ -10042,7 +10364,7 @@
                           </a:solidFill>
                           <a:latin typeface="Arial"/>
                         </a:rPr>
-                        <a:t>HiCAT mid-order Zernike sensor 2024 (arXiv 2409.03411)</a:t>
+                        <a:t>Haffert 2024, A&amp;A 683, A113</a:t>
                       </a:r>
                     </a:p>
                   </a:txBody>
@@ -10064,7 +10386,7 @@
                           </a:solidFill>
                           <a:latin typeface="Arial"/>
                         </a:rPr>
-                        <a:t>Per-segment piston, tip and tilt by interaction matrix; a minimal step of 125 ± 31 pm at SNR 4; 14-bit DM quantization reads as steps in the response</a:t>
+                        <a:t>Iterative nonlinear reconstructors reach machine precision below 0.25 rad rms; phase sorting extends to 0.75 rad; adding wavelengths to 1.4 rad rms</a:t>
                       </a:r>
                     </a:p>
                   </a:txBody>
@@ -10088,7 +10410,7 @@
                           </a:solidFill>
                           <a:latin typeface="Arial"/>
                         </a:rPr>
-                        <a:t>12</a:t>
+                        <a:t>6</a:t>
                       </a:r>
                     </a:p>
                   </a:txBody>
@@ -10110,7 +10432,7 @@
                           </a:solidFill>
                           <a:latin typeface="Arial"/>
                         </a:rPr>
-                        <a:t>Shi et al. 2015, SPIE 9605 (Roman low-order sensor)</a:t>
+                        <a:t>Darcis, Haffert, Chambouleyron, Doelman et al. 2025, A&amp;A</a:t>
                       </a:r>
                     </a:p>
                   </a:txBody>
@@ -10132,7 +10454,7 @@
                           </a:solidFill>
                           <a:latin typeface="Arial"/>
                         </a:rPr>
-                        <a:t>A reflective dimple on the focal-plane mask senses Z2 to Z11 from the rejected starlight: the spatially filtered form of the same sensor</a:t>
+                        <a:t>Multi-wavelength gradient descent through the forward model: dynamic range for the scalar sensor, photon robustness across a wider band, two-wavelength unwrapping of petal errors</a:t>
                       </a:r>
                     </a:p>
                   </a:txBody>
@@ -10181,7 +10503,7 @@
                 </a:solidFill>
                 <a:latin typeface="Arial"/>
               </a:rPr>
-              <a:t>Also read: PIAA-ZWFS (2026, arXiv 2606.28136), lossless pupil apodization that closes the gap to the fundamental sensitivity limit by 10× — a design lever, not a model change.</a:t>
+              <a:t>Priority = payoff against this campaign's measured weak results.  Synopses and links: macos/REPORT_zwfs_lit_scan.md.</a:t>
             </a:r>
           </a:p>
         </p:txBody>
@@ -10528,7 +10850,7 @@
                 </a:solidFill>
                 <a:latin typeface="Arial"/>
               </a:rPr>
-              <a:t>Conclusions: what the corrected model and the exact reading settled</a:t>
+              <a:t>Demonstrations, segmented mirrors, and the in-house precedent</a:t>
             </a:r>
           </a:p>
           <a:p>
@@ -10544,7 +10866,7 @@
                 </a:solidFill>
                 <a:latin typeface="Arial"/>
               </a:rPr>
-              <a:t>Fixing the model was the bigger gain; a response matrix measured on the working surface takes the stepped reading to 5 pm; color and photons are not the limit</a:t>
+              <a:t>Picometers by alternating DM shapes and averaging; segment piston by model iteration, underestimated below 50 % Strehl</a:t>
             </a:r>
           </a:p>
         </p:txBody>
@@ -10593,15 +10915,518 @@
           </a:p>
         </p:txBody>
       </p:sp>
-      <p:sp>
-        <p:nvSpPr>
-          <p:cNvPr id="4" name="TextBox 3"/>
+      <p:graphicFrame>
+        <p:nvGraphicFramePr>
+          <p:cNvPr id="4" name="Table 3"/>
+          <p:cNvGraphicFramePr>
+            <a:graphicFrameLocks noGrp="1"/>
+          </p:cNvGraphicFramePr>
+          <p:nvPr/>
+        </p:nvGraphicFramePr>
+        <p:xfrm>
+          <a:off x="411480" y="1298448"/>
+          <a:ext cx="11368734" cy="3091815"/>
+        </p:xfrm>
+        <a:graphic>
+          <a:graphicData uri="http://schemas.openxmlformats.org/drawingml/2006/table">
+            <a:tbl>
+              <a:tblPr firstRow="1" bandRow="1">
+                <a:tableStyleId>{5C22544A-7EE6-4342-B048-85BDC9FD1C3A}</a:tableStyleId>
+              </a:tblPr>
+              <a:tblGrid>
+                <a:gridCol w="291592"/>
+                <a:gridCol w="3730058"/>
+                <a:gridCol w="7347084"/>
+              </a:tblGrid>
+              <a:tr h="280035">
+                <a:tc>
+                  <a:txBody>
+                    <a:bodyPr wrap="square"/>
+                    <a:lstStyle/>
+                    <a:p>
+                      <a:r>
+                        <a:rPr sz="1100" b="1">
+                          <a:solidFill>
+                            <a:srgbClr val="FFFFFF"/>
+                          </a:solidFill>
+                          <a:latin typeface="Arial"/>
+                        </a:rPr>
+                        <a:t>#</a:t>
+                      </a:r>
+                    </a:p>
+                  </a:txBody>
+                  <a:tcPr marL="54864" marR="54864" marT="18288" marB="18288">
+                    <a:solidFill>
+                      <a:srgbClr val="1F4E79"/>
+                    </a:solidFill>
+                  </a:tcPr>
+                </a:tc>
+                <a:tc>
+                  <a:txBody>
+                    <a:bodyPr wrap="square"/>
+                    <a:lstStyle/>
+                    <a:p>
+                      <a:r>
+                        <a:rPr sz="1100" b="1">
+                          <a:solidFill>
+                            <a:srgbClr val="FFFFFF"/>
+                          </a:solidFill>
+                          <a:latin typeface="Arial"/>
+                        </a:rPr>
+                        <a:t>paper</a:t>
+                      </a:r>
+                    </a:p>
+                  </a:txBody>
+                  <a:tcPr marL="54864" marR="54864" marT="18288" marB="18288">
+                    <a:solidFill>
+                      <a:srgbClr val="1F4E79"/>
+                    </a:solidFill>
+                  </a:tcPr>
+                </a:tc>
+                <a:tc>
+                  <a:txBody>
+                    <a:bodyPr wrap="square"/>
+                    <a:lstStyle/>
+                    <a:p>
+                      <a:r>
+                        <a:rPr sz="1100" b="1">
+                          <a:solidFill>
+                            <a:srgbClr val="FFFFFF"/>
+                          </a:solidFill>
+                          <a:latin typeface="Arial"/>
+                        </a:rPr>
+                        <a:t>what it gives this model</a:t>
+                      </a:r>
+                    </a:p>
+                  </a:txBody>
+                  <a:tcPr marL="54864" marR="54864" marT="18288" marB="18288">
+                    <a:solidFill>
+                      <a:srgbClr val="1F4E79"/>
+                    </a:solidFill>
+                  </a:tcPr>
+                </a:tc>
+              </a:tr>
+              <a:tr h="468630">
+                <a:tc>
+                  <a:txBody>
+                    <a:bodyPr wrap="square"/>
+                    <a:lstStyle/>
+                    <a:p>
+                      <a:r>
+                        <a:rPr sz="1100" b="0">
+                          <a:solidFill>
+                            <a:srgbClr val="282828"/>
+                          </a:solidFill>
+                          <a:latin typeface="Arial"/>
+                        </a:rPr>
+                        <a:t>7</a:t>
+                      </a:r>
+                    </a:p>
+                  </a:txBody>
+                  <a:tcPr marL="54864" marR="54864" marT="18288" marB="18288">
+                    <a:solidFill>
+                      <a:srgbClr val="FFFFFF"/>
+                    </a:solidFill>
+                  </a:tcPr>
+                </a:tc>
+                <a:tc>
+                  <a:txBody>
+                    <a:bodyPr wrap="square"/>
+                    <a:lstStyle/>
+                    <a:p>
+                      <a:r>
+                        <a:rPr sz="1100" b="0">
+                          <a:solidFill>
+                            <a:srgbClr val="282828"/>
+                          </a:solidFill>
+                          <a:latin typeface="Arial"/>
+                        </a:rPr>
+                        <a:t>Steeves, Wallace, Kettenbeil, Jewell 2020, Optica 7, 1267</a:t>
+                      </a:r>
+                    </a:p>
+                  </a:txBody>
+                  <a:tcPr marL="54864" marR="54864" marT="18288" marB="18288">
+                    <a:solidFill>
+                      <a:srgbClr val="FFFFFF"/>
+                    </a:solidFill>
+                  </a:tcPr>
+                </a:tc>
+                <a:tc>
+                  <a:txBody>
+                    <a:bodyPr wrap="square"/>
+                    <a:lstStyle/>
+                    <a:p>
+                      <a:r>
+                        <a:rPr sz="1100" b="0">
+                          <a:solidFill>
+                            <a:srgbClr val="282828"/>
+                          </a:solidFill>
+                          <a:latin typeface="Arial"/>
+                        </a:rPr>
+                        <a:t>1.6 pm repeatability in 4.3 s by alternating flat and waffle DM shapes and averaging the differences; a reconstruction robust at the highest spatial frequencies</a:t>
+                      </a:r>
+                    </a:p>
+                  </a:txBody>
+                  <a:tcPr marL="54864" marR="54864" marT="18288" marB="18288">
+                    <a:solidFill>
+                      <a:srgbClr val="FFFFFF"/>
+                    </a:solidFill>
+                  </a:tcPr>
+                </a:tc>
+              </a:tr>
+              <a:tr h="468630">
+                <a:tc>
+                  <a:txBody>
+                    <a:bodyPr wrap="square"/>
+                    <a:lstStyle/>
+                    <a:p>
+                      <a:r>
+                        <a:rPr sz="1100" b="0">
+                          <a:solidFill>
+                            <a:srgbClr val="282828"/>
+                          </a:solidFill>
+                          <a:latin typeface="Arial"/>
+                        </a:rPr>
+                        <a:t>8</a:t>
+                      </a:r>
+                    </a:p>
+                  </a:txBody>
+                  <a:tcPr marL="54864" marR="54864" marT="18288" marB="18288">
+                    <a:solidFill>
+                      <a:srgbClr val="ECF1F6"/>
+                    </a:solidFill>
+                  </a:tcPr>
+                </a:tc>
+                <a:tc>
+                  <a:txBody>
+                    <a:bodyPr wrap="square"/>
+                    <a:lstStyle/>
+                    <a:p>
+                      <a:r>
+                        <a:rPr sz="1100" b="0">
+                          <a:solidFill>
+                            <a:srgbClr val="282828"/>
+                          </a:solidFill>
+                          <a:latin typeface="Arial"/>
+                        </a:rPr>
+                        <a:t>Wallace, Rao, Jensen-Clem, Serabyn 2011, SPIE 8126</a:t>
+                      </a:r>
+                    </a:p>
+                  </a:txBody>
+                  <a:tcPr marL="54864" marR="54864" marT="18288" marB="18288">
+                    <a:solidFill>
+                      <a:srgbClr val="ECF1F6"/>
+                    </a:solidFill>
+                  </a:tcPr>
+                </a:tc>
+                <a:tc>
+                  <a:txBody>
+                    <a:bodyPr wrap="square"/>
+                    <a:lstStyle/>
+                    <a:p>
+                      <a:r>
+                        <a:rPr sz="1100" b="0">
+                          <a:solidFill>
+                            <a:srgbClr val="282828"/>
+                          </a:solidFill>
+                          <a:latin typeface="Arial"/>
+                        </a:rPr>
+                        <a:t>All-reflective phase-shifting Zernike interferometer: a dynamic, arbitrary core phase shift read in four steps gives phase and amplitude; low sensitivity to vibration, polarization and wavelength</a:t>
+                      </a:r>
+                    </a:p>
+                  </a:txBody>
+                  <a:tcPr marL="54864" marR="54864" marT="18288" marB="18288">
+                    <a:solidFill>
+                      <a:srgbClr val="ECF1F6"/>
+                    </a:solidFill>
+                  </a:tcPr>
+                </a:tc>
+              </a:tr>
+              <a:tr h="468630">
+                <a:tc>
+                  <a:txBody>
+                    <a:bodyPr wrap="square"/>
+                    <a:lstStyle/>
+                    <a:p>
+                      <a:r>
+                        <a:rPr sz="1100" b="0">
+                          <a:solidFill>
+                            <a:srgbClr val="282828"/>
+                          </a:solidFill>
+                          <a:latin typeface="Arial"/>
+                        </a:rPr>
+                        <a:t>9</a:t>
+                      </a:r>
+                    </a:p>
+                  </a:txBody>
+                  <a:tcPr marL="54864" marR="54864" marT="18288" marB="18288">
+                    <a:solidFill>
+                      <a:srgbClr val="FFFFFF"/>
+                    </a:solidFill>
+                  </a:tcPr>
+                </a:tc>
+                <a:tc>
+                  <a:txBody>
+                    <a:bodyPr wrap="square"/>
+                    <a:lstStyle/>
+                    <a:p>
+                      <a:r>
+                        <a:rPr sz="1100" b="0">
+                          <a:solidFill>
+                            <a:srgbClr val="282828"/>
+                          </a:solidFill>
+                          <a:latin typeface="Arial"/>
+                        </a:rPr>
+                        <a:t>Moore and Redding 2018, SPIE 10698</a:t>
+                      </a:r>
+                    </a:p>
+                  </a:txBody>
+                  <a:tcPr marL="54864" marR="54864" marT="18288" marB="18288">
+                    <a:solidFill>
+                      <a:srgbClr val="FFFFFF"/>
+                    </a:solidFill>
+                  </a:tcPr>
+                </a:tc>
+                <a:tc>
+                  <a:txBody>
+                    <a:bodyPr wrap="square"/>
+                    <a:lstStyle/>
+                    <a:p>
+                      <a:r>
+                        <a:rPr sz="1100" b="0">
+                          <a:solidFill>
+                            <a:srgbClr val="282828"/>
+                          </a:solidFill>
+                          <a:latin typeface="Arial"/>
+                        </a:rPr>
+                        <a:t>Nonlinear polychromatic physical-optics reconstruction for picometer differential metrology on LUVOIR; the in-house precedent for the reconstructor above</a:t>
+                      </a:r>
+                    </a:p>
+                  </a:txBody>
+                  <a:tcPr marL="54864" marR="54864" marT="18288" marB="18288">
+                    <a:solidFill>
+                      <a:srgbClr val="FFFFFF"/>
+                    </a:solidFill>
+                  </a:tcPr>
+                </a:tc>
+              </a:tr>
+              <a:tr h="468630">
+                <a:tc>
+                  <a:txBody>
+                    <a:bodyPr wrap="square"/>
+                    <a:lstStyle/>
+                    <a:p>
+                      <a:r>
+                        <a:rPr sz="1100" b="0">
+                          <a:solidFill>
+                            <a:srgbClr val="282828"/>
+                          </a:solidFill>
+                          <a:latin typeface="Arial"/>
+                        </a:rPr>
+                        <a:t>10</a:t>
+                      </a:r>
+                    </a:p>
+                  </a:txBody>
+                  <a:tcPr marL="54864" marR="54864" marT="18288" marB="18288">
+                    <a:solidFill>
+                      <a:srgbClr val="ECF1F6"/>
+                    </a:solidFill>
+                  </a:tcPr>
+                </a:tc>
+                <a:tc>
+                  <a:txBody>
+                    <a:bodyPr wrap="square"/>
+                    <a:lstStyle/>
+                    <a:p>
+                      <a:r>
+                        <a:rPr sz="1100" b="0">
+                          <a:solidFill>
+                            <a:srgbClr val="282828"/>
+                          </a:solidFill>
+                          <a:latin typeface="Arial"/>
+                        </a:rPr>
+                        <a:t>Keck vector-Zernike segment control 2024 (arXiv 2404.08728); Wallace et al. 2022 (arXiv 2205.02241)</a:t>
+                      </a:r>
+                    </a:p>
+                  </a:txBody>
+                  <a:tcPr marL="54864" marR="54864" marT="18288" marB="18288">
+                    <a:solidFill>
+                      <a:srgbClr val="ECF1F6"/>
+                    </a:solidFill>
+                  </a:tcPr>
+                </a:tc>
+                <a:tc>
+                  <a:txBody>
+                    <a:bodyPr wrap="square"/>
+                    <a:lstStyle/>
+                    <a:p>
+                      <a:r>
+                        <a:rPr sz="1100" b="0">
+                          <a:solidFill>
+                            <a:srgbClr val="282828"/>
+                          </a:solidFill>
+                          <a:latin typeface="Arial"/>
+                        </a:rPr>
+                        <a:t>Segment piston by model-based iteration; 11 nm rms piston uncertainty; underestimation 2 to 4× below 50 % Strehl; fabricated shifts 0.30π and 0.68π instead of ±0.5π</a:t>
+                      </a:r>
+                    </a:p>
+                  </a:txBody>
+                  <a:tcPr marL="54864" marR="54864" marT="18288" marB="18288">
+                    <a:solidFill>
+                      <a:srgbClr val="ECF1F6"/>
+                    </a:solidFill>
+                  </a:tcPr>
+                </a:tc>
+              </a:tr>
+              <a:tr h="468630">
+                <a:tc>
+                  <a:txBody>
+                    <a:bodyPr wrap="square"/>
+                    <a:lstStyle/>
+                    <a:p>
+                      <a:r>
+                        <a:rPr sz="1100" b="0">
+                          <a:solidFill>
+                            <a:srgbClr val="282828"/>
+                          </a:solidFill>
+                          <a:latin typeface="Arial"/>
+                        </a:rPr>
+                        <a:t>11</a:t>
+                      </a:r>
+                    </a:p>
+                  </a:txBody>
+                  <a:tcPr marL="54864" marR="54864" marT="18288" marB="18288">
+                    <a:solidFill>
+                      <a:srgbClr val="FFFFFF"/>
+                    </a:solidFill>
+                  </a:tcPr>
+                </a:tc>
+                <a:tc>
+                  <a:txBody>
+                    <a:bodyPr wrap="square"/>
+                    <a:lstStyle/>
+                    <a:p>
+                      <a:r>
+                        <a:rPr sz="1100" b="0">
+                          <a:solidFill>
+                            <a:srgbClr val="282828"/>
+                          </a:solidFill>
+                          <a:latin typeface="Arial"/>
+                        </a:rPr>
+                        <a:t>HiCAT mid-order Zernike sensor 2024 (arXiv 2409.03411)</a:t>
+                      </a:r>
+                    </a:p>
+                  </a:txBody>
+                  <a:tcPr marL="54864" marR="54864" marT="18288" marB="18288">
+                    <a:solidFill>
+                      <a:srgbClr val="FFFFFF"/>
+                    </a:solidFill>
+                  </a:tcPr>
+                </a:tc>
+                <a:tc>
+                  <a:txBody>
+                    <a:bodyPr wrap="square"/>
+                    <a:lstStyle/>
+                    <a:p>
+                      <a:r>
+                        <a:rPr sz="1100" b="0">
+                          <a:solidFill>
+                            <a:srgbClr val="282828"/>
+                          </a:solidFill>
+                          <a:latin typeface="Arial"/>
+                        </a:rPr>
+                        <a:t>Per-segment piston, tip and tilt by interaction matrix; a minimal step of 125 ± 31 pm at SNR 4; 14-bit DM quantization reads as steps in the response</a:t>
+                      </a:r>
+                    </a:p>
+                  </a:txBody>
+                  <a:tcPr marL="54864" marR="54864" marT="18288" marB="18288">
+                    <a:solidFill>
+                      <a:srgbClr val="FFFFFF"/>
+                    </a:solidFill>
+                  </a:tcPr>
+                </a:tc>
+              </a:tr>
+              <a:tr h="468630">
+                <a:tc>
+                  <a:txBody>
+                    <a:bodyPr wrap="square"/>
+                    <a:lstStyle/>
+                    <a:p>
+                      <a:r>
+                        <a:rPr sz="1100" b="0">
+                          <a:solidFill>
+                            <a:srgbClr val="282828"/>
+                          </a:solidFill>
+                          <a:latin typeface="Arial"/>
+                        </a:rPr>
+                        <a:t>12</a:t>
+                      </a:r>
+                    </a:p>
+                  </a:txBody>
+                  <a:tcPr marL="54864" marR="54864" marT="18288" marB="18288">
+                    <a:solidFill>
+                      <a:srgbClr val="ECF1F6"/>
+                    </a:solidFill>
+                  </a:tcPr>
+                </a:tc>
+                <a:tc>
+                  <a:txBody>
+                    <a:bodyPr wrap="square"/>
+                    <a:lstStyle/>
+                    <a:p>
+                      <a:r>
+                        <a:rPr sz="1100" b="0">
+                          <a:solidFill>
+                            <a:srgbClr val="282828"/>
+                          </a:solidFill>
+                          <a:latin typeface="Arial"/>
+                        </a:rPr>
+                        <a:t>Shi et al. 2015, SPIE 9605 (Roman low-order sensor)</a:t>
+                      </a:r>
+                    </a:p>
+                  </a:txBody>
+                  <a:tcPr marL="54864" marR="54864" marT="18288" marB="18288">
+                    <a:solidFill>
+                      <a:srgbClr val="ECF1F6"/>
+                    </a:solidFill>
+                  </a:tcPr>
+                </a:tc>
+                <a:tc>
+                  <a:txBody>
+                    <a:bodyPr wrap="square"/>
+                    <a:lstStyle/>
+                    <a:p>
+                      <a:r>
+                        <a:rPr sz="1100" b="0">
+                          <a:solidFill>
+                            <a:srgbClr val="282828"/>
+                          </a:solidFill>
+                          <a:latin typeface="Arial"/>
+                        </a:rPr>
+                        <a:t>A reflective dimple on the focal-plane mask senses Z2 to Z11 from the rejected starlight: the spatially filtered form of the same sensor</a:t>
+                      </a:r>
+                    </a:p>
+                  </a:txBody>
+                  <a:tcPr marL="54864" marR="54864" marT="18288" marB="18288">
+                    <a:solidFill>
+                      <a:srgbClr val="ECF1F6"/>
+                    </a:solidFill>
+                  </a:tcPr>
+                </a:tc>
+              </a:tr>
+            </a:tbl>
+          </a:graphicData>
+        </a:graphic>
+      </p:graphicFrame>
+      <p:sp>
+        <p:nvSpPr>
+          <p:cNvPr id="5" name="TextBox 4"/>
           <p:cNvSpPr txBox="1"/>
           <p:nvPr/>
         </p:nvSpPr>
         <p:spPr>
           <a:xfrm>
-            <a:off x="411480" y="1298448"/>
+            <a:off x="411480" y="4536567"/>
             <a:ext cx="11368735" cy="274320"/>
           </a:xfrm>
           <a:prstGeom prst="rect">
@@ -10621,148 +11446,13 @@
               </a:spcAft>
             </a:pPr>
             <a:r>
-              <a:rPr sz="1500" b="0">
-                <a:solidFill>
-                  <a:srgbClr val="282828"/>
+              <a:rPr sz="1050" b="0">
+                <a:solidFill>
+                  <a:srgbClr val="6E6E6E"/>
                 </a:solidFill>
                 <a:latin typeface="Arial"/>
               </a:rPr>
-              <a:t>•  The model must keep the pupil image in focus: the two spheres around the mask share one radius, and the script checks the no-mask round trip on every run.  The correction alone took the single-actuator floor from 744 to 67 pm and made the undetected grid case detectable.</a:t>
-            </a:r>
-          </a:p>
-          <a:p>
-            <a:pPr>
-              <a:spcAft>
-                <a:spcPts val="600"/>
-              </a:spcAft>
-            </a:pPr>
-            <a:r>
-              <a:rPr sz="1500" b="0">
-                <a:solidFill>
-                  <a:srgbClr val="282828"/>
-                </a:solidFill>
-                <a:latin typeface="Arial"/>
-              </a:rPr>
-              <a:t>•  The exact reading with a re-computed reference is the import that paid (paper 1): 26 pm from one frame on a 30 nm working surface, SNR 355 — with the sign fold settled once from four stepped frames and refined.  The plain stepped sign map misses 3% of pixels and can flip a single actuator's sign.</a:t>
-            </a:r>
-          </a:p>
-          <a:p>
-            <a:pPr>
-              <a:spcAft>
-                <a:spcPts val="600"/>
-              </a:spcAft>
-            </a:pPr>
-            <a:r>
-              <a:rPr sz="1500" b="0">
-                <a:solidFill>
-                  <a:srgbClr val="282828"/>
-                </a:solidFill>
-                <a:latin typeface="Arial"/>
-              </a:rPr>
-              <a:t>•  Calibrate with a measured response matrix, on the working surface: the sparse-grid measurement of every actuator's response (with the sensor's piston null carried) reads a single actuator on the flat at 0.994 with a 4 pm floor; measured on the working surface it gives the stepped reading 0.99 and 5 pm there and makes the linear one-frame reading usable (1.05, 23 pm).  The floors fall ten times; what remains is gain stability as the surface drifts (7% over 20 nm rms) and the one-frame exact readings' sign fold.</a:t>
-            </a:r>
-          </a:p>
-          <a:p>
-            <a:pPr>
-              <a:spcAft>
-                <a:spcPts val="600"/>
-              </a:spcAft>
-            </a:pPr>
-            <a:r>
-              <a:rPr sz="1500" b="0">
-                <a:solidFill>
-                  <a:srgbClr val="282828"/>
-                </a:solidFill>
-                <a:latin typeface="Arial"/>
-              </a:rPr>
-              <a:t>•  Sampling is settled, and a bias in the fit is fixed: camera pixels per actuator (the ray count) set the gain on a test actuator; sampling the single-site response pattern at the actuator center took that gain to 0.996 at 5 pixels per actuator.</a:t>
-            </a:r>
-          </a:p>
-          <a:p>
-            <a:pPr>
-              <a:spcAft>
-                <a:spcPts val="600"/>
-              </a:spcAft>
-            </a:pPr>
-            <a:r>
-              <a:rPr sz="1500" b="0">
-                <a:solidFill>
-                  <a:srgbClr val="282828"/>
-                </a:solidFill>
-                <a:latin typeface="Arial"/>
-              </a:rPr>
-              <a:t>•  Color and photons are not levers: the chromatic null was the defocus; 10¹⁴ photons per measurement reach 1 pm.  The budget is systematic error: the 25 to 60 pm floors and the gain's stability.</a:t>
-            </a:r>
-          </a:p>
-          <a:p>
-            <a:pPr>
-              <a:spcAft>
-                <a:spcPts val="600"/>
-              </a:spcAft>
-            </a:pPr>
-            <a:r>
-              <a:rPr sz="1500" b="0">
-                <a:solidFill>
-                  <a:srgbClr val="282828"/>
-                </a:solidFill>
-                <a:latin typeface="Arial"/>
-              </a:rPr>
-              <a:t>•  In closed loop the stepped reading has no fixed error: it holds a 2 pm-per-cycle walk to 3 pm from 7.5×10¹² photons per cycle and returns to zero after a step; the linear reading costs the same light but leaves a fine-scale error under a slow ramp; the one-frame exact reading runs away.</a:t>
-            </a:r>
-          </a:p>
-          <a:p>
-            <a:pPr>
-              <a:spcAft>
-                <a:spcPts val="600"/>
-              </a:spcAft>
-            </a:pPr>
-            <a:r>
-              <a:rPr sz="1500" b="0">
-                <a:solidFill>
-                  <a:srgbClr val="282828"/>
-                </a:solidFill>
-                <a:latin typeface="Arial"/>
-              </a:rPr>
-              <a:t>•  The polarized dimple is the best reading on every line: two simultaneous frames, no fold, 3 pm held from 5.3×10¹² photons per cycle, and a calibration that stays within 2% out to 60 nm rms.</a:t>
-            </a:r>
-          </a:p>
-        </p:txBody>
-      </p:sp>
-      <p:sp>
-        <p:nvSpPr>
-          <p:cNvPr id="5" name="TextBox 4"/>
-          <p:cNvSpPr txBox="1"/>
-          <p:nvPr/>
-        </p:nvSpPr>
-        <p:spPr>
-          <a:xfrm>
-            <a:off x="411480" y="7517130"/>
-            <a:ext cx="11368735" cy="274320"/>
-          </a:xfrm>
-          <a:prstGeom prst="rect">
-            <a:avLst/>
-          </a:prstGeom>
-          <a:noFill/>
-        </p:spPr>
-        <p:txBody>
-          <a:bodyPr wrap="square">
-            <a:spAutoFit/>
-          </a:bodyPr>
-          <a:lstStyle/>
-          <a:p>
-            <a:pPr>
-              <a:spcAft>
-                <a:spcPts val="600"/>
-              </a:spcAft>
-            </a:pPr>
-            <a:r>
-              <a:rPr sz="1050" b="0">
-                <a:solidFill>
-                  <a:srgbClr val="6E6E6E"/>
-                </a:solidFill>
-                <a:latin typeface="Arial"/>
-              </a:rPr>
-              <a:t>Script and records: templates/40_benches/zwfs_dm96 (README S7/S8; runs/rec193, ng385, ng385s3, m2048, rec193full).</a:t>
+              <a:t>Also read: PIAA-ZWFS (2026, arXiv 2606.28136), lossless pupil apodization that closes the gap to the fundamental sensitivity limit by 10× — a design lever, not a model change.</a:t>
             </a:r>
           </a:p>
         </p:txBody>
@@ -10819,7 +11509,7 @@
                 </a:solidFill>
                 <a:latin typeface="Arial"/>
               </a:rPr>
-              <a:t>Conclusions: what to import next, in order</a:t>
+              <a:t>Conclusions: what the corrected model and the exact reading settled</a:t>
             </a:r>
           </a:p>
           <a:p>
@@ -10835,7 +11525,7 @@
                 </a:solidFill>
                 <a:latin typeface="Arial"/>
               </a:rPr>
-              <a:t>The JPL budget form, DM calibration through the sensor's own images, the vector sensor priced before it is built, and the interferometer's lever</a:t>
+              <a:t>Fixing the model was the bigger gain; a response matrix measured on the working surface takes the stepped reading to 5 pm; color and photons are not the limit</a:t>
             </a:r>
           </a:p>
         </p:txBody>
@@ -10918,7 +11608,7 @@
                 </a:solidFill>
                 <a:latin typeface="Arial"/>
               </a:rPr>
-              <a:t>•  The JPL budget form: a sensitivity factor per pixel from the measured fields — the quantity the working-surface effect on slide 10 is made of — predicts the photon-noise stage analytically, and four systematic terms (pupil calibration at ½, reference wave at 1, dimple depth, initial phase) become the rows of the error budget.</a:t>
+              <a:t>•  The model must keep the pupil image in focus: the two spheres around the mask share one radius, and the script checks the no-mask round trip on every run.  The correction alone took the single-actuator floor from 744 to 67 pm and made the undetected grid case detectable.</a:t>
             </a:r>
           </a:p>
           <a:p>
@@ -10934,7 +11624,7 @@
                 </a:solidFill>
                 <a:latin typeface="Arial"/>
               </a:rPr>
-              <a:t>•  The response matrix for the interferometer too: its calibration still uses a single-site response pattern, with the stencil bias fixed here (slide 9); the sparse-grid measured matrix is the calibration its reflective build should carry.  Model-matched DM calibration (actuator positions and gains through the sensor's own images) remains the lever for a real DM's geometry.</a:t>
+              <a:t>•  The exact reading with a re-computed reference is the import that paid (paper 1): 26 pm from one frame on a 30 nm working surface, SNR 355 — with the sign fold settled once from four stepped frames and refined.  The plain stepped sign map misses 3% of pixels and can flip a single actuator's sign.</a:t>
             </a:r>
           </a:p>
           <a:p>
@@ -10950,7 +11640,7 @@
                 </a:solidFill>
                 <a:latin typeface="Arial"/>
               </a:rPr>
-              <a:t>•  Color as a joint fit, not a combination: an equal-weight combination inherits a bad channel; a joint fit through the exact reading would use 700 to 780 nm for range and 632.8 nm for the calibration of record.</a:t>
+              <a:t>•  Calibrate with a measured response matrix, on the working surface: the sparse-grid measurement of every actuator's response (with the sensor's piston null carried) reads a single actuator on the flat at 0.994 with a 4 pm floor; measured on the working surface it gives the stepped reading 0.99 and 5 pm there and makes the linear one-frame reading usable (1.05, 23 pm).  The floors fall ten times; what remains is gain stability as the surface drifts (7% over 20 nm rms) and the one-frame exact readings' sign fold.</a:t>
             </a:r>
           </a:p>
           <a:p>
@@ -10966,7 +11656,7 @@
                 </a:solidFill>
                 <a:latin typeface="Arial"/>
               </a:rPr>
-              <a:t>•  Model the vector sensor before the metasurface is built: the exact two-image solution and its leakage terms (retardance offsets, splitter rotation) run on the engine's polarization machinery; the bench limits at Keck and SEAL were defocus and crosstalk between the two pupil images, both priceable here.</a:t>
+              <a:t>•  Sampling is settled, and a bias in the fit is fixed: camera pixels per actuator (the ray count) set the gain on a test actuator; sampling the single-site response pattern at the actuator center took that gain to 0.996 at 5 pixels per actuator.</a:t>
             </a:r>
           </a:p>
           <a:p>
@@ -10982,7 +11672,39 @@
                 </a:solidFill>
                 <a:latin typeface="Arial"/>
               </a:rPr>
-              <a:t>•  The interferometer, for balance: a PZT phase shift buys no model gain — its floors are geometric and color-independent — but on hardware an absolute phase scale and freedom from polarization systematics; the recommended form is a hybrid: polarization snapshot for the change measurements, a PZT on the reference flat as calibrator.  Its all-mirror (OAP) version is in build.</a:t>
+              <a:t>•  Color and photons are not levers: the chromatic null was the defocus; 10¹⁴ photons per measurement reach 1 pm.  The budget is systematic error: the 25 to 60 pm floors and the gain's stability.</a:t>
+            </a:r>
+          </a:p>
+          <a:p>
+            <a:pPr>
+              <a:spcAft>
+                <a:spcPts val="600"/>
+              </a:spcAft>
+            </a:pPr>
+            <a:r>
+              <a:rPr sz="1500" b="0">
+                <a:solidFill>
+                  <a:srgbClr val="282828"/>
+                </a:solidFill>
+                <a:latin typeface="Arial"/>
+              </a:rPr>
+              <a:t>•  In closed loop the stepped reading has no fixed error: it holds a 2 pm-per-cycle walk to 3 pm from 7.5×10¹² photons per cycle and returns to zero after a step; the linear reading costs the same light but leaves a fine-scale error under a slow ramp; the one-frame exact reading runs away.</a:t>
+            </a:r>
+          </a:p>
+          <a:p>
+            <a:pPr>
+              <a:spcAft>
+                <a:spcPts val="600"/>
+              </a:spcAft>
+            </a:pPr>
+            <a:r>
+              <a:rPr sz="1500" b="0">
+                <a:solidFill>
+                  <a:srgbClr val="282828"/>
+                </a:solidFill>
+                <a:latin typeface="Arial"/>
+              </a:rPr>
+              <a:t>•  The polarized dimple is the best reading on every line: two simultaneous frames, no fold, 3 pm held from 5.3×10¹² photons per cycle, and a calibration that stays within 2% out to 60 nm rms.</a:t>
             </a:r>
           </a:p>
         </p:txBody>
@@ -10995,7 +11717,7 @@
         </p:nvSpPr>
         <p:spPr>
           <a:xfrm>
-            <a:off x="411480" y="5998464"/>
+            <a:off x="411480" y="7517130"/>
             <a:ext cx="11368735" cy="274320"/>
           </a:xfrm>
           <a:prstGeom prst="rect">
@@ -11021,7 +11743,7 @@
                 </a:solidFill>
                 <a:latin typeface="Arial"/>
               </a:rPr>
-              <a:t>Segmented-mirror lessons carried forward: the sensor reads segment piston but not global piston, DM quantization appears as steps in the response, and piston is underestimated below 50 % Strehl (Keck) — all three enter the e5-class segmented gauges.</a:t>
+              <a:t>Script and records: templates/40_benches/zwfs_dm96 (README S7/S8; runs/rec193, ng385, ng385s3, m2048, rec193full).</a:t>
             </a:r>
           </a:p>
         </p:txBody>
@@ -11052,63 +11774,6 @@
         </p:nvSpPr>
         <p:spPr>
           <a:xfrm>
-            <a:off x="822960" y="2743200"/>
-            <a:ext cx="10545775" cy="1280160"/>
-          </a:xfrm>
-          <a:prstGeom prst="rect">
-            <a:avLst/>
-          </a:prstGeom>
-          <a:noFill/>
-        </p:spPr>
-        <p:txBody>
-          <a:bodyPr wrap="square">
-            <a:spAutoFit/>
-          </a:bodyPr>
-          <a:lstStyle/>
-          <a:p>
-            <a:pPr algn="ctr">
-              <a:spcAft>
-                <a:spcPts val="400"/>
-              </a:spcAft>
-            </a:pPr>
-            <a:r>
-              <a:rPr sz="4000" b="1">
-                <a:solidFill>
-                  <a:srgbClr val="1F4E79"/>
-                </a:solidFill>
-                <a:latin typeface="Arial"/>
-              </a:rPr>
-              <a:t>Backup</a:t>
-            </a:r>
-          </a:p>
-        </p:txBody>
-      </p:sp>
-    </p:spTree>
-  </p:cSld>
-  <p:clrMapOvr>
-    <a:masterClrMapping/>
-  </p:clrMapOvr>
-</p:sld>
-</file>
-
-<file path=ppt/slides/slide23.xml><?xml version="1.0" encoding="utf-8"?>
-<p:sld xmlns:a="http://schemas.openxmlformats.org/drawingml/2006/main" xmlns:p="http://schemas.openxmlformats.org/presentationml/2006/main" xmlns:r="http://schemas.openxmlformats.org/officeDocument/2006/relationships">
-  <p:cSld>
-    <p:spTree>
-      <p:nvGrpSpPr>
-        <p:cNvPr id="1" name=""/>
-        <p:cNvGrpSpPr/>
-        <p:nvPr/>
-      </p:nvGrpSpPr>
-      <p:grpSpPr/>
-      <p:sp>
-        <p:nvSpPr>
-          <p:cNvPr id="2" name="TextBox 1"/>
-          <p:cNvSpPr txBox="1"/>
-          <p:nvPr/>
-        </p:nvSpPr>
-        <p:spPr>
-          <a:xfrm>
             <a:off x="411480" y="201168"/>
             <a:ext cx="11368735" cy="914400"/>
           </a:xfrm>
@@ -11135,7 +11800,7 @@
                 </a:solidFill>
                 <a:latin typeface="Arial"/>
               </a:rPr>
-              <a:t>Before the correction: the first poke and color results</a:t>
+              <a:t>Conclusions: what to import next, in order</a:t>
             </a:r>
           </a:p>
           <a:p>
@@ -11151,7 +11816,7 @@
                 </a:solidFill>
                 <a:latin typeface="Arial"/>
               </a:rPr>
-              <a:t>Kept for the record; every number on this slide is from the out-of-focus model</a:t>
+              <a:t>The JPL budget form, DM calibration through the sensor's own images, the vector sensor priced before it is built, and the interferometer's lever</a:t>
             </a:r>
           </a:p>
         </p:txBody>
@@ -11200,6 +11865,322 @@
           </a:p>
         </p:txBody>
       </p:sp>
+      <p:sp>
+        <p:nvSpPr>
+          <p:cNvPr id="4" name="TextBox 3"/>
+          <p:cNvSpPr txBox="1"/>
+          <p:nvPr/>
+        </p:nvSpPr>
+        <p:spPr>
+          <a:xfrm>
+            <a:off x="411480" y="1298448"/>
+            <a:ext cx="11368735" cy="274320"/>
+          </a:xfrm>
+          <a:prstGeom prst="rect">
+            <a:avLst/>
+          </a:prstGeom>
+          <a:noFill/>
+        </p:spPr>
+        <p:txBody>
+          <a:bodyPr wrap="square">
+            <a:spAutoFit/>
+          </a:bodyPr>
+          <a:lstStyle/>
+          <a:p>
+            <a:pPr>
+              <a:spcAft>
+                <a:spcPts val="600"/>
+              </a:spcAft>
+            </a:pPr>
+            <a:r>
+              <a:rPr sz="1500" b="0">
+                <a:solidFill>
+                  <a:srgbClr val="282828"/>
+                </a:solidFill>
+                <a:latin typeface="Arial"/>
+              </a:rPr>
+              <a:t>•  The JPL budget form: a sensitivity factor per pixel from the measured fields — the quantity the working-surface effect on slide 10 is made of — predicts the photon-noise stage analytically, and four systematic terms (pupil calibration at ½, reference wave at 1, dimple depth, initial phase) become the rows of the error budget.</a:t>
+            </a:r>
+          </a:p>
+          <a:p>
+            <a:pPr>
+              <a:spcAft>
+                <a:spcPts val="600"/>
+              </a:spcAft>
+            </a:pPr>
+            <a:r>
+              <a:rPr sz="1500" b="0">
+                <a:solidFill>
+                  <a:srgbClr val="282828"/>
+                </a:solidFill>
+                <a:latin typeface="Arial"/>
+              </a:rPr>
+              <a:t>•  The response matrix for the interferometer too: its calibration still uses a single-site response pattern, with the stencil bias fixed here (slide 9); the sparse-grid measured matrix is the calibration its reflective build should carry.  Model-matched DM calibration (actuator positions and gains through the sensor's own images) remains the lever for a real DM's geometry.</a:t>
+            </a:r>
+          </a:p>
+          <a:p>
+            <a:pPr>
+              <a:spcAft>
+                <a:spcPts val="600"/>
+              </a:spcAft>
+            </a:pPr>
+            <a:r>
+              <a:rPr sz="1500" b="0">
+                <a:solidFill>
+                  <a:srgbClr val="282828"/>
+                </a:solidFill>
+                <a:latin typeface="Arial"/>
+              </a:rPr>
+              <a:t>•  Color as a joint fit, not a combination: an equal-weight combination inherits a bad channel; a joint fit through the exact reading would use 700 to 780 nm for range and 632.8 nm for the calibration of record.</a:t>
+            </a:r>
+          </a:p>
+          <a:p>
+            <a:pPr>
+              <a:spcAft>
+                <a:spcPts val="600"/>
+              </a:spcAft>
+            </a:pPr>
+            <a:r>
+              <a:rPr sz="1500" b="0">
+                <a:solidFill>
+                  <a:srgbClr val="282828"/>
+                </a:solidFill>
+                <a:latin typeface="Arial"/>
+              </a:rPr>
+              <a:t>•  Model the vector sensor before the metasurface is built: the exact two-image solution and its leakage terms (retardance offsets, splitter rotation) run on the engine's polarization machinery; the bench limits at Keck and SEAL were defocus and crosstalk between the two pupil images, both priceable here.</a:t>
+            </a:r>
+          </a:p>
+          <a:p>
+            <a:pPr>
+              <a:spcAft>
+                <a:spcPts val="600"/>
+              </a:spcAft>
+            </a:pPr>
+            <a:r>
+              <a:rPr sz="1500" b="0">
+                <a:solidFill>
+                  <a:srgbClr val="282828"/>
+                </a:solidFill>
+                <a:latin typeface="Arial"/>
+              </a:rPr>
+              <a:t>•  The interferometer, for balance: a PZT phase shift buys no model gain — its floors are geometric and color-independent — but on hardware an absolute phase scale and freedom from polarization systematics; the recommended form is a hybrid: polarization snapshot for the change measurements, a PZT on the reference flat as calibrator.  Its all-mirror (OAP) version is in build.</a:t>
+            </a:r>
+          </a:p>
+        </p:txBody>
+      </p:sp>
+      <p:sp>
+        <p:nvSpPr>
+          <p:cNvPr id="5" name="TextBox 4"/>
+          <p:cNvSpPr txBox="1"/>
+          <p:nvPr/>
+        </p:nvSpPr>
+        <p:spPr>
+          <a:xfrm>
+            <a:off x="411480" y="5998464"/>
+            <a:ext cx="11368735" cy="274320"/>
+          </a:xfrm>
+          <a:prstGeom prst="rect">
+            <a:avLst/>
+          </a:prstGeom>
+          <a:noFill/>
+        </p:spPr>
+        <p:txBody>
+          <a:bodyPr wrap="square">
+            <a:spAutoFit/>
+          </a:bodyPr>
+          <a:lstStyle/>
+          <a:p>
+            <a:pPr>
+              <a:spcAft>
+                <a:spcPts val="600"/>
+              </a:spcAft>
+            </a:pPr>
+            <a:r>
+              <a:rPr sz="1050" b="0">
+                <a:solidFill>
+                  <a:srgbClr val="6E6E6E"/>
+                </a:solidFill>
+                <a:latin typeface="Arial"/>
+              </a:rPr>
+              <a:t>Segmented-mirror lessons carried forward: the sensor reads segment piston but not global piston, DM quantization appears as steps in the response, and piston is underestimated below 50 % Strehl (Keck) — all three enter the e5-class segmented gauges.</a:t>
+            </a:r>
+          </a:p>
+        </p:txBody>
+      </p:sp>
+    </p:spTree>
+  </p:cSld>
+  <p:clrMapOvr>
+    <a:masterClrMapping/>
+  </p:clrMapOvr>
+</p:sld>
+</file>
+
+<file path=ppt/slides/slide23.xml><?xml version="1.0" encoding="utf-8"?>
+<p:sld xmlns:a="http://schemas.openxmlformats.org/drawingml/2006/main" xmlns:p="http://schemas.openxmlformats.org/presentationml/2006/main" xmlns:r="http://schemas.openxmlformats.org/officeDocument/2006/relationships">
+  <p:cSld>
+    <p:spTree>
+      <p:nvGrpSpPr>
+        <p:cNvPr id="1" name=""/>
+        <p:cNvGrpSpPr/>
+        <p:nvPr/>
+      </p:nvGrpSpPr>
+      <p:grpSpPr/>
+      <p:sp>
+        <p:nvSpPr>
+          <p:cNvPr id="2" name="TextBox 1"/>
+          <p:cNvSpPr txBox="1"/>
+          <p:nvPr/>
+        </p:nvSpPr>
+        <p:spPr>
+          <a:xfrm>
+            <a:off x="822960" y="2743200"/>
+            <a:ext cx="10545775" cy="1280160"/>
+          </a:xfrm>
+          <a:prstGeom prst="rect">
+            <a:avLst/>
+          </a:prstGeom>
+          <a:noFill/>
+        </p:spPr>
+        <p:txBody>
+          <a:bodyPr wrap="square">
+            <a:spAutoFit/>
+          </a:bodyPr>
+          <a:lstStyle/>
+          <a:p>
+            <a:pPr algn="ctr">
+              <a:spcAft>
+                <a:spcPts val="400"/>
+              </a:spcAft>
+            </a:pPr>
+            <a:r>
+              <a:rPr sz="4000" b="1">
+                <a:solidFill>
+                  <a:srgbClr val="1F4E79"/>
+                </a:solidFill>
+                <a:latin typeface="Arial"/>
+              </a:rPr>
+              <a:t>Backup</a:t>
+            </a:r>
+          </a:p>
+        </p:txBody>
+      </p:sp>
+    </p:spTree>
+  </p:cSld>
+  <p:clrMapOvr>
+    <a:masterClrMapping/>
+  </p:clrMapOvr>
+</p:sld>
+</file>
+
+<file path=ppt/slides/slide24.xml><?xml version="1.0" encoding="utf-8"?>
+<p:sld xmlns:a="http://schemas.openxmlformats.org/drawingml/2006/main" xmlns:p="http://schemas.openxmlformats.org/presentationml/2006/main" xmlns:r="http://schemas.openxmlformats.org/officeDocument/2006/relationships">
+  <p:cSld>
+    <p:spTree>
+      <p:nvGrpSpPr>
+        <p:cNvPr id="1" name=""/>
+        <p:cNvGrpSpPr/>
+        <p:nvPr/>
+      </p:nvGrpSpPr>
+      <p:grpSpPr/>
+      <p:sp>
+        <p:nvSpPr>
+          <p:cNvPr id="2" name="TextBox 1"/>
+          <p:cNvSpPr txBox="1"/>
+          <p:nvPr/>
+        </p:nvSpPr>
+        <p:spPr>
+          <a:xfrm>
+            <a:off x="411480" y="201168"/>
+            <a:ext cx="11368735" cy="914400"/>
+          </a:xfrm>
+          <a:prstGeom prst="rect">
+            <a:avLst/>
+          </a:prstGeom>
+          <a:noFill/>
+        </p:spPr>
+        <p:txBody>
+          <a:bodyPr wrap="square">
+            <a:spAutoFit/>
+          </a:bodyPr>
+          <a:lstStyle/>
+          <a:p>
+            <a:pPr>
+              <a:spcAft>
+                <a:spcPts val="400"/>
+              </a:spcAft>
+            </a:pPr>
+            <a:r>
+              <a:rPr sz="2400" b="1">
+                <a:solidFill>
+                  <a:srgbClr val="1F4E79"/>
+                </a:solidFill>
+                <a:latin typeface="Arial"/>
+              </a:rPr>
+              <a:t>Before the correction: the first poke and color results</a:t>
+            </a:r>
+          </a:p>
+          <a:p>
+            <a:pPr>
+              <a:spcAft>
+                <a:spcPts val="0"/>
+              </a:spcAft>
+            </a:pPr>
+            <a:r>
+              <a:rPr sz="1250" b="0">
+                <a:solidFill>
+                  <a:srgbClr val="6E6E6E"/>
+                </a:solidFill>
+                <a:latin typeface="Arial"/>
+              </a:rPr>
+              <a:t>Kept for the record; every number on this slide is from the out-of-focus model</a:t>
+            </a:r>
+          </a:p>
+        </p:txBody>
+      </p:sp>
+      <p:sp>
+        <p:nvSpPr>
+          <p:cNvPr id="3" name="Rectangle 2"/>
+          <p:cNvSpPr/>
+          <p:nvPr/>
+        </p:nvSpPr>
+        <p:spPr>
+          <a:xfrm>
+            <a:off x="411480" y="1133856"/>
+            <a:ext cx="11368735" cy="20320"/>
+          </a:xfrm>
+          <a:prstGeom prst="rect">
+            <a:avLst/>
+          </a:prstGeom>
+          <a:solidFill>
+            <a:srgbClr val="B8C6D4"/>
+          </a:solidFill>
+          <a:ln>
+            <a:noFill/>
+          </a:ln>
+          <a:effectLst/>
+        </p:spPr>
+        <p:style>
+          <a:lnRef idx="1">
+            <a:schemeClr val="accent1"/>
+          </a:lnRef>
+          <a:fillRef idx="3">
+            <a:schemeClr val="accent1"/>
+          </a:fillRef>
+          <a:effectRef idx="2">
+            <a:schemeClr val="accent1"/>
+          </a:effectRef>
+          <a:fontRef idx="minor">
+            <a:schemeClr val="lt1"/>
+          </a:fontRef>
+        </p:style>
+        <p:txBody>
+          <a:bodyPr rtlCol="0" anchor="ctr"/>
+          <a:lstStyle/>
+          <a:p>
+            <a:pPr algn="ctr"/>
+          </a:p>
+        </p:txBody>
+      </p:sp>
       <p:pic>
         <p:nvPicPr>
           <p:cNvPr id="4" name="Picture 3" descr="zwfs_poke_triptych.png"/>
@@ -11428,7 +12409,7 @@
 </p:sld>
 </file>
 
-<file path=ppt/slides/slide24.xml><?xml version="1.0" encoding="utf-8"?>
+<file path=ppt/slides/slide25.xml><?xml version="1.0" encoding="utf-8"?>
 <p:sld xmlns:a="http://schemas.openxmlformats.org/drawingml/2006/main" xmlns:p="http://schemas.openxmlformats.org/presentationml/2006/main" xmlns:r="http://schemas.openxmlformats.org/officeDocument/2006/relationships">
   <p:cSld>
     <p:spTree>

</xml_diff>

<commit_message>
ZWFS V3: the arm's polarization aberration per channel -- brief, deck slide 16, slice, engine note
BRIEF_zwfs_campaign V3 section (method, basis ruling, the lens rig's
numbers, the design scan, the rule); deck_zwfs slide 16 "What can spoil
the polarized dimple, priced" (V2 + V3 in one table; conclusions bullet
re-stated; 26 slides, DRAFT); CURRENT_SLICE; macos_f90/CLAUDE.md: the
vector-mode field on the Twyman-Green train is the scalar trace's exact
conjugate on the grid (common phase slope -2.0000, residual 4e-9), and
carries the Fresnel losses -- measured 2026-09-12, not bridged.

Resources: 65788d9 (code) + d5019fc (record) on dev-candidate, local.

Co-Authored-By: Claude Fable 5.1 <noreply@anthropic.com>
</commit_message>
<xml_diff>
--- a/demo_session/deck_zwfs.pptx
+++ b/demo_session/deck_zwfs.pptx
@@ -30,6 +30,7 @@
     <p:sldId id="278" r:id="rId29"/>
     <p:sldId id="279" r:id="rId30"/>
     <p:sldId id="280" r:id="rId31"/>
+    <p:sldId id="281" r:id="rId32"/>
   </p:sldIdLst>
   <p:sldSz cx="12191695" cy="6858000" type="screen4x3"/>
   <p:notesSz cx="6858000" cy="9144000"/>
@@ -7368,7 +7369,7 @@
                 </a:solidFill>
                 <a:latin typeface="Arial"/>
               </a:rPr>
-              <a:t>Ideal metasurface: each image is the scalar sensor with its own dimple sign.  Next: metasurface retardance error, the arm's polarization aberrations, the stepped reading's between-frame drift.  Records: runs/v193base, v193noise, vloop193.</a:t>
+              <a:t>Ideal metasurface: each image is the scalar sensor with its own dimple sign.  Its two imperfections are priced on the next slide; still open: the stepped reading's between-frame drift.  Records: runs/v193base, v193noise, vloop193.</a:t>
             </a:r>
           </a:p>
         </p:txBody>
@@ -7425,7 +7426,7 @@
                 </a:solidFill>
                 <a:latin typeface="Arial"/>
               </a:rPr>
-              <a:t>Both instruments through the same loop</a:t>
+              <a:t>What can spoil the polarized dimple, priced</a:t>
             </a:r>
           </a:p>
           <a:p>
@@ -7441,7 +7442,7 @@
                 </a:solidFill>
                 <a:latin typeface="Arial"/>
               </a:rPr>
-              <a:t>The interferometer holds the surface at twice the sensor's light but keeps a 9% fixed error; its reflective version cannot hold a 2 pm walk at all</a:t>
+              <a:t>A retardance error in the metasurface and the test arm's polarization aberration both wash out through the working-surface matrix; only a large difference between the two channels' phases costs anything</a:t>
             </a:r>
           </a:p>
         </p:txBody>
@@ -7500,7 +7501,7 @@
         </p:nvGraphicFramePr>
         <p:xfrm>
           <a:off x="411480" y="1298448"/>
-          <a:ext cx="11368735" cy="2057400"/>
+          <a:ext cx="11368733" cy="3097530"/>
         </p:xfrm>
         <a:graphic>
           <a:graphicData uri="http://schemas.openxmlformats.org/drawingml/2006/table">
@@ -7509,11 +7510,10 @@
                 <a:tableStyleId>{5C22544A-7EE6-4342-B048-85BDC9FD1C3A}</a:tableStyleId>
               </a:tblPr>
               <a:tblGrid>
-                <a:gridCol w="2977188"/>
-                <a:gridCol w="1889760"/>
-                <a:gridCol w="1817116"/>
-                <a:gridCol w="1889760"/>
-                <a:gridCol w="2794911"/>
+                <a:gridCol w="3644522"/>
+                <a:gridCol w="1631875"/>
+                <a:gridCol w="2556605"/>
+                <a:gridCol w="3535731"/>
               </a:tblGrid>
               <a:tr h="468630">
                 <a:tc>
@@ -7528,7 +7528,7 @@
                           </a:solidFill>
                           <a:latin typeface="Arial"/>
                         </a:rPr>
-                        <a:t>held to 3 pm rms: photons per cycle</a:t>
+                        <a:t>term</a:t>
                       </a:r>
                     </a:p>
                   </a:txBody>
@@ -7550,7 +7550,7 @@
                           </a:solidFill>
                           <a:latin typeface="Arial"/>
                         </a:rPr>
-                        <a:t>ZWFS stepped (S)</a:t>
+                        <a:t>uncalibrated, absolute (100 nm pokes)</a:t>
                       </a:r>
                     </a:p>
                   </a:txBody>
@@ -7572,7 +7572,7 @@
                           </a:solidFill>
                           <a:latin typeface="Arial"/>
                         </a:rPr>
-                        <a:t>ZWFS polarized pair (V)</a:t>
+                        <a:t>with the bench's own calibration</a:t>
                       </a:r>
                     </a:p>
                   </a:txBody>
@@ -7594,7 +7594,7 @@
                           </a:solidFill>
                           <a:latin typeface="Arial"/>
                         </a:rPr>
-                        <a:t>interferometer, lens rig</a:t>
+                        <a:t>through the matrix measured on the 30 nm surface: 10 nm change / 47 × 1 nm / dense 10 nm</a:t>
                       </a:r>
                     </a:p>
                   </a:txBody>
@@ -7604,43 +7604,21 @@
                     </a:solidFill>
                   </a:tcPr>
                 </a:tc>
-                <a:tc>
-                  <a:txBody>
-                    <a:bodyPr wrap="square"/>
-                    <a:lstStyle/>
-                    <a:p>
-                      <a:r>
-                        <a:rPr sz="1100" b="1">
-                          <a:solidFill>
-                            <a:srgbClr val="FFFFFF"/>
-                          </a:solidFill>
-                          <a:latin typeface="Arial"/>
-                        </a:rPr>
-                        <a:t>interferometer, reflective rig (bare aluminum)</a:t>
-                      </a:r>
-                    </a:p>
-                  </a:txBody>
-                  <a:tcPr marL="54864" marR="54864" marT="18288" marB="18288">
-                    <a:solidFill>
-                      <a:srgbClr val="1F4E79"/>
-                    </a:solidFill>
-                  </a:tcPr>
-                </a:tc>
               </a:tr>
-              <a:tr h="280035">
-                <a:tc>
-                  <a:txBody>
-                    <a:bodyPr wrap="square"/>
-                    <a:lstStyle/>
-                    <a:p>
-                      <a:r>
-                        <a:rPr sz="1100" b="0">
-                          <a:solidFill>
-                            <a:srgbClr val="282828"/>
-                          </a:solidFill>
-                          <a:latin typeface="Arial"/>
-                        </a:rPr>
-                        <a:t>noise only</a:t>
+              <a:tr h="657225">
+                <a:tc>
+                  <a:txBody>
+                    <a:bodyPr wrap="square"/>
+                    <a:lstStyle/>
+                    <a:p>
+                      <a:r>
+                        <a:rPr sz="1100" b="0">
+                          <a:solidFill>
+                            <a:srgbClr val="282828"/>
+                          </a:solidFill>
+                          <a:latin typeface="Arial"/>
+                        </a:rPr>
+                        <a:t>metasurface retardance error 0.1 rad: 5% of the light unshifted, one complex constant on both images</a:t>
                       </a:r>
                     </a:p>
                   </a:txBody>
@@ -7662,7 +7640,7 @@
                           </a:solidFill>
                           <a:latin typeface="Arial"/>
                         </a:rPr>
-                        <a:t>2.6×10¹²</a:t>
+                        <a:t>0.75 nm (leak in phase), 18 pm (in quadrature)</a:t>
                       </a:r>
                     </a:p>
                   </a:txBody>
@@ -7684,7 +7662,7 @@
                           </a:solidFill>
                           <a:latin typeface="Arial"/>
                         </a:rPr>
-                        <a:t>1.5×10¹²</a:t>
+                        <a:t>0.05 pm: three numbers fitted on the flat's two images</a:t>
                       </a:r>
                     </a:p>
                   </a:txBody>
@@ -7706,7 +7684,7 @@
                           </a:solidFill>
                           <a:latin typeface="Arial"/>
                         </a:rPr>
-                        <a:t>5.5×10¹²</a:t>
+                        <a:t>0.993, 4 pm / 0.999, 3 pm / 0.33 nm — the ideal numbers; loop identical</a:t>
                       </a:r>
                     </a:p>
                   </a:txBody>
@@ -7716,19 +7694,111 @@
                     </a:solidFill>
                   </a:tcPr>
                 </a:tc>
-                <a:tc>
-                  <a:txBody>
-                    <a:bodyPr wrap="square"/>
-                    <a:lstStyle/>
-                    <a:p>
-                      <a:r>
-                        <a:rPr sz="1100" b="0">
-                          <a:solidFill>
-                            <a:srgbClr val="282828"/>
-                          </a:solidFill>
-                          <a:latin typeface="Arial"/>
-                        </a:rPr>
-                        <a:t>3.4×10¹³</a:t>
+              </a:tr>
+              <a:tr h="657225">
+                <a:tc>
+                  <a:txBody>
+                    <a:bodyPr wrap="square"/>
+                    <a:lstStyle/>
+                    <a:p>
+                      <a:r>
+                        <a:rPr sz="1100" b="0">
+                          <a:solidFill>
+                            <a:srgbClr val="282828"/>
+                          </a:solidFill>
+                          <a:latin typeface="Arial"/>
+                        </a:rPr>
+                        <a:t>this lens rig's arm, laser 45° to the fold plane: the channels' phases differ by 1.6 mrad rms (six 7° glass faces, 0.5% diattenuation)</a:t>
+                      </a:r>
+                    </a:p>
+                  </a:txBody>
+                  <a:tcPr marL="54864" marR="54864" marT="18288" marB="18288">
+                    <a:solidFill>
+                      <a:srgbClr val="ECF1F6"/>
+                    </a:solidFill>
+                  </a:tcPr>
+                </a:tc>
+                <a:tc>
+                  <a:txBody>
+                    <a:bodyPr wrap="square"/>
+                    <a:lstStyle/>
+                    <a:p>
+                      <a:r>
+                        <a:rPr sz="1100" b="0">
+                          <a:solidFill>
+                            <a:srgbClr val="282828"/>
+                          </a:solidFill>
+                          <a:latin typeface="Arial"/>
+                        </a:rPr>
+                        <a:t>9 pm (17 at 0°; 0.1 with the laser on the fold plane's axis)</a:t>
+                      </a:r>
+                    </a:p>
+                  </a:txBody>
+                  <a:tcPr marL="54864" marR="54864" marT="18288" marB="18288">
+                    <a:solidFill>
+                      <a:srgbClr val="ECF1F6"/>
+                    </a:solidFill>
+                  </a:tcPr>
+                </a:tc>
+                <a:tc>
+                  <a:txBody>
+                    <a:bodyPr wrap="square"/>
+                    <a:lstStyle/>
+                    <a:p>
+                      <a:r>
+                        <a:rPr sz="1100" b="0">
+                          <a:solidFill>
+                            <a:srgbClr val="282828"/>
+                          </a:solidFill>
+                          <a:latin typeface="Arial"/>
+                        </a:rPr>
+                        <a:t>9.5 pm: the unmasked reference frames cannot see a phase; 0.05 pm with a polarimetric map</a:t>
+                      </a:r>
+                    </a:p>
+                  </a:txBody>
+                  <a:tcPr marL="54864" marR="54864" marT="18288" marB="18288">
+                    <a:solidFill>
+                      <a:srgbClr val="ECF1F6"/>
+                    </a:solidFill>
+                  </a:tcPr>
+                </a:tc>
+                <a:tc>
+                  <a:txBody>
+                    <a:bodyPr wrap="square"/>
+                    <a:lstStyle/>
+                    <a:p>
+                      <a:r>
+                        <a:rPr sz="1100" b="0">
+                          <a:solidFill>
+                            <a:srgbClr val="282828"/>
+                          </a:solidFill>
+                          <a:latin typeface="Arial"/>
+                        </a:rPr>
+                        <a:t>ideal to the printed digit</a:t>
+                      </a:r>
+                    </a:p>
+                  </a:txBody>
+                  <a:tcPr marL="54864" marR="54864" marT="18288" marB="18288">
+                    <a:solidFill>
+                      <a:srgbClr val="ECF1F6"/>
+                    </a:solidFill>
+                  </a:tcPr>
+                </a:tc>
+              </a:tr>
+              <a:tr h="657225">
+                <a:tc>
+                  <a:txBody>
+                    <a:bodyPr wrap="square"/>
+                    <a:lstStyle/>
+                    <a:p>
+                      <a:r>
+                        <a:rPr sz="1100" b="0">
+                          <a:solidFill>
+                            <a:srgbClr val="282828"/>
+                          </a:solidFill>
+                          <a:latin typeface="Arial"/>
+                        </a:rPr>
+                        <a:t>channel phase difference 0.1 / 0.3 rad rms (a pupil-varying diattenuation)</a:t>
                       </a:r>
                     </a:p>
                   </a:txBody>
@@ -7738,21 +7808,87 @@
                     </a:solidFill>
                   </a:tcPr>
                 </a:tc>
+                <a:tc>
+                  <a:txBody>
+                    <a:bodyPr wrap="square"/>
+                    <a:lstStyle/>
+                    <a:p>
+                      <a:r>
+                        <a:rPr sz="1100" b="0">
+                          <a:solidFill>
+                            <a:srgbClr val="282828"/>
+                          </a:solidFill>
+                          <a:latin typeface="Arial"/>
+                        </a:rPr>
+                        <a:t>0.6 / 1.9 nm (6 nm per rad)</a:t>
+                      </a:r>
+                    </a:p>
+                  </a:txBody>
+                  <a:tcPr marL="54864" marR="54864" marT="18288" marB="18288">
+                    <a:solidFill>
+                      <a:srgbClr val="FFFFFF"/>
+                    </a:solidFill>
+                  </a:tcPr>
+                </a:tc>
+                <a:tc>
+                  <a:txBody>
+                    <a:bodyPr wrap="square"/>
+                    <a:lstStyle/>
+                    <a:p>
+                      <a:r>
+                        <a:rPr sz="1100" b="0">
+                          <a:solidFill>
+                            <a:srgbClr val="282828"/>
+                          </a:solidFill>
+                          <a:latin typeface="Arial"/>
+                        </a:rPr>
+                        <a:t>unchanged</a:t>
+                      </a:r>
+                    </a:p>
+                  </a:txBody>
+                  <a:tcPr marL="54864" marR="54864" marT="18288" marB="18288">
+                    <a:solidFill>
+                      <a:srgbClr val="FFFFFF"/>
+                    </a:solidFill>
+                  </a:tcPr>
+                </a:tc>
+                <a:tc>
+                  <a:txBody>
+                    <a:bodyPr wrap="square"/>
+                    <a:lstStyle/>
+                    <a:p>
+                      <a:r>
+                        <a:rPr sz="1100" b="0">
+                          <a:solidFill>
+                            <a:srgbClr val="282828"/>
+                          </a:solidFill>
+                          <a:latin typeface="Arial"/>
+                        </a:rPr>
+                        <a:t>0.995, 4 / 1.001, 4 / 0.44 nm at 0.1; 0.997, 4 / 1.007, 8 / 0.96 nm at 0.3; loop at 0.3: 10% less gain, same noise, no fixed error</a:t>
+                      </a:r>
+                    </a:p>
+                  </a:txBody>
+                  <a:tcPr marL="54864" marR="54864" marT="18288" marB="18288">
+                    <a:solidFill>
+                      <a:srgbClr val="FFFFFF"/>
+                    </a:solidFill>
+                  </a:tcPr>
+                </a:tc>
               </a:tr>
-              <a:tr h="280035">
-                <a:tc>
-                  <a:txBody>
-                    <a:bodyPr wrap="square"/>
-                    <a:lstStyle/>
-                    <a:p>
-                      <a:r>
-                        <a:rPr sz="1100" b="0">
-                          <a:solidFill>
-                            <a:srgbClr val="282828"/>
-                          </a:solidFill>
-                          <a:latin typeface="Arial"/>
-                        </a:rPr>
-                        <a:t>random walk, 2 pm per cycle</a:t>
+              <a:tr h="657225">
+                <a:tc>
+                  <a:txBody>
+                    <a:bodyPr wrap="square"/>
+                    <a:lstStyle/>
+                    <a:p>
+                      <a:r>
+                        <a:rPr sz="1100" b="0">
+                          <a:solidFill>
+                            <a:srgbClr val="282828"/>
+                          </a:solidFill>
+                          <a:latin typeface="Arial"/>
+                        </a:rPr>
+                        <a:t>channel amplitude ratio 0.1 / 0.3 rms (a pupil-varying retardance, the all-mirror rig's term)</a:t>
                       </a:r>
                     </a:p>
                   </a:txBody>
@@ -7774,7 +7910,7 @@
                           </a:solidFill>
                           <a:latin typeface="Arial"/>
                         </a:rPr>
-                        <a:t>7.5×10¹²</a:t>
+                        <a:t>2.3 / 7.1 nm</a:t>
                       </a:r>
                     </a:p>
                   </a:txBody>
@@ -7796,7 +7932,7 @@
                           </a:solidFill>
                           <a:latin typeface="Arial"/>
                         </a:rPr>
-                        <a:t>5.3×10¹²</a:t>
+                        <a:t>0.05 pm: removed by the per-channel unmasked reference frames every Zernike-sensor bench takes</a:t>
                       </a:r>
                     </a:p>
                   </a:txBody>
@@ -7818,371 +7954,13 @@
                           </a:solidFill>
                           <a:latin typeface="Arial"/>
                         </a:rPr>
-                        <a:t>2.0×10¹³</a:t>
+                        <a:t>0.993, 4 / 1.000, 3 / 0.43 nm at 0.1 uncalibrated; the ideal numbers once calibrated</a:t>
                       </a:r>
                     </a:p>
                   </a:txBody>
                   <a:tcPr marL="54864" marR="54864" marT="18288" marB="18288">
                     <a:solidFill>
                       <a:srgbClr val="ECF1F6"/>
-                    </a:solidFill>
-                  </a:tcPr>
-                </a:tc>
-                <a:tc>
-                  <a:txBody>
-                    <a:bodyPr wrap="square"/>
-                    <a:lstStyle/>
-                    <a:p>
-                      <a:r>
-                        <a:rPr sz="1100" b="0">
-                          <a:solidFill>
-                            <a:srgbClr val="282828"/>
-                          </a:solidFill>
-                          <a:latin typeface="Arial"/>
-                        </a:rPr>
-                        <a:t>never (4.1 pm floor)</a:t>
-                      </a:r>
-                    </a:p>
-                  </a:txBody>
-                  <a:tcPr marL="54864" marR="54864" marT="18288" marB="18288">
-                    <a:solidFill>
-                      <a:srgbClr val="ECF1F6"/>
-                    </a:solidFill>
-                  </a:tcPr>
-                </a:tc>
-              </a:tr>
-              <a:tr h="280035">
-                <a:tc>
-                  <a:txBody>
-                    <a:bodyPr wrap="square"/>
-                    <a:lstStyle/>
-                    <a:p>
-                      <a:r>
-                        <a:rPr sz="1100" b="0">
-                          <a:solidFill>
-                            <a:srgbClr val="282828"/>
-                          </a:solidFill>
-                          <a:latin typeface="Arial"/>
-                        </a:rPr>
-                        <a:t>thermal ramp, 5 pm per cycle</a:t>
-                      </a:r>
-                    </a:p>
-                  </a:txBody>
-                  <a:tcPr marL="54864" marR="54864" marT="18288" marB="18288">
-                    <a:solidFill>
-                      <a:srgbClr val="FFFFFF"/>
-                    </a:solidFill>
-                  </a:tcPr>
-                </a:tc>
-                <a:tc>
-                  <a:txBody>
-                    <a:bodyPr wrap="square"/>
-                    <a:lstStyle/>
-                    <a:p>
-                      <a:r>
-                        <a:rPr sz="1100" b="0">
-                          <a:solidFill>
-                            <a:srgbClr val="282828"/>
-                          </a:solidFill>
-                          <a:latin typeface="Arial"/>
-                        </a:rPr>
-                        <a:t>10.0 pm (the loop's lag)</a:t>
-                      </a:r>
-                    </a:p>
-                  </a:txBody>
-                  <a:tcPr marL="54864" marR="54864" marT="18288" marB="18288">
-                    <a:solidFill>
-                      <a:srgbClr val="FFFFFF"/>
-                    </a:solidFill>
-                  </a:tcPr>
-                </a:tc>
-                <a:tc>
-                  <a:txBody>
-                    <a:bodyPr wrap="square"/>
-                    <a:lstStyle/>
-                    <a:p>
-                      <a:r>
-                        <a:rPr sz="1100" b="0">
-                          <a:solidFill>
-                            <a:srgbClr val="282828"/>
-                          </a:solidFill>
-                          <a:latin typeface="Arial"/>
-                        </a:rPr>
-                        <a:t>9.9 pm</a:t>
-                      </a:r>
-                    </a:p>
-                  </a:txBody>
-                  <a:tcPr marL="54864" marR="54864" marT="18288" marB="18288">
-                    <a:solidFill>
-                      <a:srgbClr val="FFFFFF"/>
-                    </a:solidFill>
-                  </a:tcPr>
-                </a:tc>
-                <a:tc>
-                  <a:txBody>
-                    <a:bodyPr wrap="square"/>
-                    <a:lstStyle/>
-                    <a:p>
-                      <a:r>
-                        <a:rPr sz="1100" b="0">
-                          <a:solidFill>
-                            <a:srgbClr val="282828"/>
-                          </a:solidFill>
-                          <a:latin typeface="Arial"/>
-                        </a:rPr>
-                        <a:t>13.1 pm</a:t>
-                      </a:r>
-                    </a:p>
-                  </a:txBody>
-                  <a:tcPr marL="54864" marR="54864" marT="18288" marB="18288">
-                    <a:solidFill>
-                      <a:srgbClr val="FFFFFF"/>
-                    </a:solidFill>
-                  </a:tcPr>
-                </a:tc>
-                <a:tc>
-                  <a:txBody>
-                    <a:bodyPr wrap="square"/>
-                    <a:lstStyle/>
-                    <a:p>
-                      <a:r>
-                        <a:rPr sz="1100" b="0">
-                          <a:solidFill>
-                            <a:srgbClr val="282828"/>
-                          </a:solidFill>
-                          <a:latin typeface="Arial"/>
-                        </a:rPr>
-                        <a:t>39 pm</a:t>
-                      </a:r>
-                    </a:p>
-                  </a:txBody>
-                  <a:tcPr marL="54864" marR="54864" marT="18288" marB="18288">
-                    <a:solidFill>
-                      <a:srgbClr val="FFFFFF"/>
-                    </a:solidFill>
-                  </a:tcPr>
-                </a:tc>
-              </a:tr>
-              <a:tr h="280035">
-                <a:tc>
-                  <a:txBody>
-                    <a:bodyPr wrap="square"/>
-                    <a:lstStyle/>
-                    <a:p>
-                      <a:r>
-                        <a:rPr sz="1100" b="0">
-                          <a:solidFill>
-                            <a:srgbClr val="282828"/>
-                          </a:solidFill>
-                          <a:latin typeface="Arial"/>
-                        </a:rPr>
-                        <a:t>noise-free 1 nm step, after 60 cycles</a:t>
-                      </a:r>
-                    </a:p>
-                  </a:txBody>
-                  <a:tcPr marL="54864" marR="54864" marT="18288" marB="18288">
-                    <a:solidFill>
-                      <a:srgbClr val="ECF1F6"/>
-                    </a:solidFill>
-                  </a:tcPr>
-                </a:tc>
-                <a:tc>
-                  <a:txBody>
-                    <a:bodyPr wrap="square"/>
-                    <a:lstStyle/>
-                    <a:p>
-                      <a:r>
-                        <a:rPr sz="1100" b="0">
-                          <a:solidFill>
-                            <a:srgbClr val="282828"/>
-                          </a:solidFill>
-                          <a:latin typeface="Arial"/>
-                        </a:rPr>
-                        <a:t>0.000 pm</a:t>
-                      </a:r>
-                    </a:p>
-                  </a:txBody>
-                  <a:tcPr marL="54864" marR="54864" marT="18288" marB="18288">
-                    <a:solidFill>
-                      <a:srgbClr val="ECF1F6"/>
-                    </a:solidFill>
-                  </a:tcPr>
-                </a:tc>
-                <a:tc>
-                  <a:txBody>
-                    <a:bodyPr wrap="square"/>
-                    <a:lstStyle/>
-                    <a:p>
-                      <a:r>
-                        <a:rPr sz="1100" b="0">
-                          <a:solidFill>
-                            <a:srgbClr val="282828"/>
-                          </a:solidFill>
-                          <a:latin typeface="Arial"/>
-                        </a:rPr>
-                        <a:t>0.000 pm</a:t>
-                      </a:r>
-                    </a:p>
-                  </a:txBody>
-                  <a:tcPr marL="54864" marR="54864" marT="18288" marB="18288">
-                    <a:solidFill>
-                      <a:srgbClr val="ECF1F6"/>
-                    </a:solidFill>
-                  </a:tcPr>
-                </a:tc>
-                <a:tc>
-                  <a:txBody>
-                    <a:bodyPr wrap="square"/>
-                    <a:lstStyle/>
-                    <a:p>
-                      <a:r>
-                        <a:rPr sz="1100" b="0">
-                          <a:solidFill>
-                            <a:srgbClr val="282828"/>
-                          </a:solidFill>
-                          <a:latin typeface="Arial"/>
-                        </a:rPr>
-                        <a:t>87 pm, rising</a:t>
-                      </a:r>
-                    </a:p>
-                  </a:txBody>
-                  <a:tcPr marL="54864" marR="54864" marT="18288" marB="18288">
-                    <a:solidFill>
-                      <a:srgbClr val="ECF1F6"/>
-                    </a:solidFill>
-                  </a:tcPr>
-                </a:tc>
-                <a:tc>
-                  <a:txBody>
-                    <a:bodyPr wrap="square"/>
-                    <a:lstStyle/>
-                    <a:p>
-                      <a:r>
-                        <a:rPr sz="1100" b="0">
-                          <a:solidFill>
-                            <a:srgbClr val="282828"/>
-                          </a:solidFill>
-                          <a:latin typeface="Arial"/>
-                        </a:rPr>
-                        <a:t>276 pm</a:t>
-                      </a:r>
-                    </a:p>
-                  </a:txBody>
-                  <a:tcPr marL="54864" marR="54864" marT="18288" marB="18288">
-                    <a:solidFill>
-                      <a:srgbClr val="ECF1F6"/>
-                    </a:solidFill>
-                  </a:tcPr>
-                </a:tc>
-              </a:tr>
-              <a:tr h="468630">
-                <a:tc>
-                  <a:txBody>
-                    <a:bodyPr wrap="square"/>
-                    <a:lstStyle/>
-                    <a:p>
-                      <a:r>
-                        <a:rPr sz="1100" b="0">
-                          <a:solidFill>
-                            <a:srgbClr val="282828"/>
-                          </a:solidFill>
-                          <a:latin typeface="Arial"/>
-                        </a:rPr>
-                        <a:t>single-shot noise at 10¹² photons per measurement</a:t>
-                      </a:r>
-                    </a:p>
-                  </a:txBody>
-                  <a:tcPr marL="54864" marR="54864" marT="18288" marB="18288">
-                    <a:solidFill>
-                      <a:srgbClr val="FFFFFF"/>
-                    </a:solidFill>
-                  </a:tcPr>
-                </a:tc>
-                <a:tc>
-                  <a:txBody>
-                    <a:bodyPr wrap="square"/>
-                    <a:lstStyle/>
-                    <a:p>
-                      <a:r>
-                        <a:rPr sz="1100" b="0">
-                          <a:solidFill>
-                            <a:srgbClr val="282828"/>
-                          </a:solidFill>
-                          <a:latin typeface="Arial"/>
-                        </a:rPr>
-                        <a:t>8.2 pm</a:t>
-                      </a:r>
-                    </a:p>
-                  </a:txBody>
-                  <a:tcPr marL="54864" marR="54864" marT="18288" marB="18288">
-                    <a:solidFill>
-                      <a:srgbClr val="FFFFFF"/>
-                    </a:solidFill>
-                  </a:tcPr>
-                </a:tc>
-                <a:tc>
-                  <a:txBody>
-                    <a:bodyPr wrap="square"/>
-                    <a:lstStyle/>
-                    <a:p>
-                      <a:r>
-                        <a:rPr sz="1100" b="0">
-                          <a:solidFill>
-                            <a:srgbClr val="282828"/>
-                          </a:solidFill>
-                          <a:latin typeface="Arial"/>
-                        </a:rPr>
-                        <a:t>6.4 pm</a:t>
-                      </a:r>
-                    </a:p>
-                  </a:txBody>
-                  <a:tcPr marL="54864" marR="54864" marT="18288" marB="18288">
-                    <a:solidFill>
-                      <a:srgbClr val="FFFFFF"/>
-                    </a:solidFill>
-                  </a:tcPr>
-                </a:tc>
-                <a:tc>
-                  <a:txBody>
-                    <a:bodyPr wrap="square"/>
-                    <a:lstStyle/>
-                    <a:p>
-                      <a:r>
-                        <a:rPr sz="1100" b="0">
-                          <a:solidFill>
-                            <a:srgbClr val="282828"/>
-                          </a:solidFill>
-                          <a:latin typeface="Arial"/>
-                        </a:rPr>
-                        <a:t>12.0 pm</a:t>
-                      </a:r>
-                    </a:p>
-                  </a:txBody>
-                  <a:tcPr marL="54864" marR="54864" marT="18288" marB="18288">
-                    <a:solidFill>
-                      <a:srgbClr val="FFFFFF"/>
-                    </a:solidFill>
-                  </a:tcPr>
-                </a:tc>
-                <a:tc>
-                  <a:txBody>
-                    <a:bodyPr wrap="square"/>
-                    <a:lstStyle/>
-                    <a:p>
-                      <a:r>
-                        <a:rPr sz="1100" b="0">
-                          <a:solidFill>
-                            <a:srgbClr val="282828"/>
-                          </a:solidFill>
-                          <a:latin typeface="Arial"/>
-                        </a:rPr>
-                        <a:t>—</a:t>
-                      </a:r>
-                    </a:p>
-                  </a:txBody>
-                  <a:tcPr marL="54864" marR="54864" marT="18288" marB="18288">
-                    <a:solidFill>
-                      <a:srgbClr val="FFFFFF"/>
                     </a:solidFill>
                   </a:tcPr>
                 </a:tc>
@@ -8199,7 +7977,7 @@
         </p:nvSpPr>
         <p:spPr>
           <a:xfrm>
-            <a:off x="411480" y="3502152"/>
+            <a:off x="411480" y="4542282"/>
             <a:ext cx="11368735" cy="274320"/>
           </a:xfrm>
           <a:prstGeom prst="rect">
@@ -8225,7 +8003,7 @@
                 </a:solidFill>
                 <a:latin typeface="Arial"/>
               </a:rPr>
-              <a:t>•  Same loop code, same drift realization, same scoring (dm_gauge_lib/dmg_loop; the interferometer rows by CCMac).  The loop propagates noise as theory says on every instrument, so the light each needs follows from its single-shot noise: the interferometer's four-step reading is about 1.5× noisier per photon than the sensor's stepped reading, about twice the photons.</a:t>
+              <a:t>•  How the arm enters: the metasurface converts one circular polarization with +90° and the other with −90°, so each image is of that polarization's own pupil field.  The engine's polarized ray trace of the arm gives both fields at every pixel; a real Jones matrix makes the channels differ in phase only, by the diattenuation times sin 2(axis − laser angle).</a:t>
             </a:r>
           </a:p>
           <a:p>
@@ -8241,7 +8019,7 @@
                 </a:solidFill>
                 <a:latin typeface="Arial"/>
               </a:rPr>
-              <a:t>•  The fixed error is the difference. The sensor's stepped and polarized readings return to zero after a step; the interferometer keeps about 9% of any change (its fine-pattern roll-off and cross-talk, now in closed loop), so it behaves like the sensor's linear reading, not its stepped one.  The reflective interferometer's remaining fold cross-talk (0.18 open-loop, once the ideal-reflector artifact was removed with bare aluminum) becomes a hard wall in hold mode: the 2 pm walk is never held to 3 pm.  Open-loop batteries could not make that distinction.</a:t>
+              <a:t>•  Design rule: specify the arm's pupil-varying diattenuation (0.1 rad rms of channel phase difference costs nothing through the matrix; 0.3 costs the grid row 2.6× and 10% of loop gain) and put the laser on the arm's dominant axis; a pupil-varying retardance the sensor calibrates from frames it takes anyway.</a:t>
             </a:r>
           </a:p>
         </p:txBody>
@@ -8254,7 +8032,7 @@
         </p:nvSpPr>
         <p:spPr>
           <a:xfrm>
-            <a:off x="411480" y="6047994"/>
+            <a:off x="411480" y="6592824"/>
             <a:ext cx="11368735" cy="274320"/>
           </a:xfrm>
           <a:prstGeom prst="rect">
@@ -8280,7 +8058,7 @@
                 </a:solidFill>
                 <a:latin typeface="Arial"/>
               </a:rPr>
-              <a:t>Sensor rows: zwfs_dm96 runs/loop193, vloop193.  Interferometer rows: tg_psi_dm96_oap runs/loop_lens, loop_oap (bare aluminum on both OAPs; the ideal-reflector null was an idealization, its exactly-zero retardance variation).  All at gain 0.5, 60 cycles, matrix measured on the 30 nm working surface.</a:t>
+              <a:t>Astigmatic maps, rms over the pupil; 193 rays; the mask's own change with incidence angle is not modeled.  Records: zwfs_dm96 runs (the v2, v3arm, v3s and v3loop series); README V2 and V3.</a:t>
             </a:r>
           </a:p>
         </p:txBody>
@@ -8337,7 +8115,7 @@
                 </a:solidFill>
                 <a:latin typeface="Arial"/>
               </a:rPr>
-              <a:t>Run it yourself</a:t>
+              <a:t>Both instruments through the same loop</a:t>
             </a:r>
           </a:p>
           <a:p>
@@ -8353,7 +8131,7 @@
                 </a:solidFill>
                 <a:latin typeface="Arial"/>
               </a:rPr>
-              <a:t>One parameter sheet and one script reproduce every number here; the defaults reproduce the stage-7 record to the last printed digit</a:t>
+              <a:t>The interferometer holds the surface at twice the sensor's light but keeps a 9% fixed error; its reflective version cannot hold a 2 pm walk at all</a:t>
             </a:r>
           </a:p>
         </p:txBody>
@@ -8402,56 +8180,17 @@
           </a:p>
         </p:txBody>
       </p:sp>
-      <p:sp>
-        <p:nvSpPr>
-          <p:cNvPr id="4" name="TextBox 3"/>
-          <p:cNvSpPr txBox="1"/>
-          <p:nvPr/>
-        </p:nvSpPr>
-        <p:spPr>
-          <a:xfrm>
-            <a:off x="411480" y="1298448"/>
-            <a:ext cx="11368735" cy="274320"/>
-          </a:xfrm>
-          <a:prstGeom prst="rect">
-            <a:avLst/>
-          </a:prstGeom>
-          <a:noFill/>
-        </p:spPr>
-        <p:txBody>
-          <a:bodyPr wrap="square">
-            <a:spAutoFit/>
-          </a:bodyPr>
-          <a:lstStyle/>
-          <a:p>
-            <a:pPr>
-              <a:spcAft>
-                <a:spcPts val="600"/>
-              </a:spcAft>
-            </a:pPr>
-            <a:r>
-              <a:rPr sz="1500" b="0">
-                <a:solidFill>
-                  <a:srgbClr val="282828"/>
-                </a:solidFill>
-                <a:latin typeface="Arial"/>
-              </a:rPr>
-              <a:t>•  Two files: zwfs_params.m returns every setting at its value of record — grid and ray count, wavelength, the bench's lengths and tuned figures, the mask's etch and spot, the sampling checks, registration, the DM sizes, the test amplitudes and seeds, the color and photon stages.  zwfs_run.m runs the chosen stages and writes the report, a .mat file and the figures into a folder named by the run's tag.</a:t>
-            </a:r>
-          </a:p>
-        </p:txBody>
-      </p:sp>
       <p:graphicFrame>
         <p:nvGraphicFramePr>
-          <p:cNvPr id="5" name="Table 4"/>
+          <p:cNvPr id="4" name="Table 3"/>
           <p:cNvGraphicFramePr>
             <a:graphicFrameLocks noGrp="1"/>
           </p:cNvGraphicFramePr>
           <p:nvPr/>
         </p:nvGraphicFramePr>
         <p:xfrm>
-          <a:off x="411480" y="2465831"/>
-          <a:ext cx="11368735" cy="1680210"/>
+          <a:off x="411480" y="1298448"/>
+          <a:ext cx="11368735" cy="2057400"/>
         </p:xfrm>
         <a:graphic>
           <a:graphicData uri="http://schemas.openxmlformats.org/drawingml/2006/table">
@@ -8460,10 +8199,13 @@
                 <a:tableStyleId>{5C22544A-7EE6-4342-B048-85BDC9FD1C3A}</a:tableStyleId>
               </a:tblPr>
               <a:tblGrid>
-                <a:gridCol w="6601201"/>
-                <a:gridCol w="4767534"/>
+                <a:gridCol w="2977188"/>
+                <a:gridCol w="1889760"/>
+                <a:gridCol w="1817116"/>
+                <a:gridCol w="1889760"/>
+                <a:gridCol w="2794911"/>
               </a:tblGrid>
-              <a:tr h="280035">
+              <a:tr h="468630">
                 <a:tc>
                   <a:txBody>
                     <a:bodyPr wrap="square"/>
@@ -8476,7 +8218,7 @@
                           </a:solidFill>
                           <a:latin typeface="Arial"/>
                         </a:rPr>
-                        <a:t>call</a:t>
+                        <a:t>held to 3 pm rms: photons per cycle</a:t>
                       </a:r>
                     </a:p>
                   </a:txBody>
@@ -8498,7 +8240,73 @@
                           </a:solidFill>
                           <a:latin typeface="Arial"/>
                         </a:rPr>
-                        <a:t>what it does</a:t>
+                        <a:t>ZWFS stepped (S)</a:t>
+                      </a:r>
+                    </a:p>
+                  </a:txBody>
+                  <a:tcPr marL="54864" marR="54864" marT="18288" marB="18288">
+                    <a:solidFill>
+                      <a:srgbClr val="1F4E79"/>
+                    </a:solidFill>
+                  </a:tcPr>
+                </a:tc>
+                <a:tc>
+                  <a:txBody>
+                    <a:bodyPr wrap="square"/>
+                    <a:lstStyle/>
+                    <a:p>
+                      <a:r>
+                        <a:rPr sz="1100" b="1">
+                          <a:solidFill>
+                            <a:srgbClr val="FFFFFF"/>
+                          </a:solidFill>
+                          <a:latin typeface="Arial"/>
+                        </a:rPr>
+                        <a:t>ZWFS polarized pair (V)</a:t>
+                      </a:r>
+                    </a:p>
+                  </a:txBody>
+                  <a:tcPr marL="54864" marR="54864" marT="18288" marB="18288">
+                    <a:solidFill>
+                      <a:srgbClr val="1F4E79"/>
+                    </a:solidFill>
+                  </a:tcPr>
+                </a:tc>
+                <a:tc>
+                  <a:txBody>
+                    <a:bodyPr wrap="square"/>
+                    <a:lstStyle/>
+                    <a:p>
+                      <a:r>
+                        <a:rPr sz="1100" b="1">
+                          <a:solidFill>
+                            <a:srgbClr val="FFFFFF"/>
+                          </a:solidFill>
+                          <a:latin typeface="Arial"/>
+                        </a:rPr>
+                        <a:t>interferometer, lens rig</a:t>
+                      </a:r>
+                    </a:p>
+                  </a:txBody>
+                  <a:tcPr marL="54864" marR="54864" marT="18288" marB="18288">
+                    <a:solidFill>
+                      <a:srgbClr val="1F4E79"/>
+                    </a:solidFill>
+                  </a:tcPr>
+                </a:tc>
+                <a:tc>
+                  <a:txBody>
+                    <a:bodyPr wrap="square"/>
+                    <a:lstStyle/>
+                    <a:p>
+                      <a:r>
+                        <a:rPr sz="1100" b="1">
+                          <a:solidFill>
+                            <a:srgbClr val="FFFFFF"/>
+                          </a:solidFill>
+                          <a:latin typeface="Arial"/>
+                        </a:rPr>
+                        <a:t>interferometer, reflective rig (bare aluminum)</a:t>
                       </a:r>
                     </a:p>
                   </a:txBody>
@@ -8522,7 +8330,7 @@
                           </a:solidFill>
                           <a:latin typeface="Arial"/>
                         </a:rPr>
-                        <a:t>zwfs_run</a:t>
+                        <a:t>noise only</a:t>
                       </a:r>
                     </a:p>
                   </a:txBody>
@@ -8544,7 +8352,73 @@
                           </a:solidFill>
                           <a:latin typeface="Arial"/>
                         </a:rPr>
-                        <a:t>the record: bench checks, the full test set, figures</a:t>
+                        <a:t>2.6×10¹²</a:t>
+                      </a:r>
+                    </a:p>
+                  </a:txBody>
+                  <a:tcPr marL="54864" marR="54864" marT="18288" marB="18288">
+                    <a:solidFill>
+                      <a:srgbClr val="FFFFFF"/>
+                    </a:solidFill>
+                  </a:tcPr>
+                </a:tc>
+                <a:tc>
+                  <a:txBody>
+                    <a:bodyPr wrap="square"/>
+                    <a:lstStyle/>
+                    <a:p>
+                      <a:r>
+                        <a:rPr sz="1100" b="0">
+                          <a:solidFill>
+                            <a:srgbClr val="282828"/>
+                          </a:solidFill>
+                          <a:latin typeface="Arial"/>
+                        </a:rPr>
+                        <a:t>1.5×10¹²</a:t>
+                      </a:r>
+                    </a:p>
+                  </a:txBody>
+                  <a:tcPr marL="54864" marR="54864" marT="18288" marB="18288">
+                    <a:solidFill>
+                      <a:srgbClr val="FFFFFF"/>
+                    </a:solidFill>
+                  </a:tcPr>
+                </a:tc>
+                <a:tc>
+                  <a:txBody>
+                    <a:bodyPr wrap="square"/>
+                    <a:lstStyle/>
+                    <a:p>
+                      <a:r>
+                        <a:rPr sz="1100" b="0">
+                          <a:solidFill>
+                            <a:srgbClr val="282828"/>
+                          </a:solidFill>
+                          <a:latin typeface="Arial"/>
+                        </a:rPr>
+                        <a:t>5.5×10¹²</a:t>
+                      </a:r>
+                    </a:p>
+                  </a:txBody>
+                  <a:tcPr marL="54864" marR="54864" marT="18288" marB="18288">
+                    <a:solidFill>
+                      <a:srgbClr val="FFFFFF"/>
+                    </a:solidFill>
+                  </a:tcPr>
+                </a:tc>
+                <a:tc>
+                  <a:txBody>
+                    <a:bodyPr wrap="square"/>
+                    <a:lstStyle/>
+                    <a:p>
+                      <a:r>
+                        <a:rPr sz="1100" b="0">
+                          <a:solidFill>
+                            <a:srgbClr val="282828"/>
+                          </a:solidFill>
+                          <a:latin typeface="Arial"/>
+                        </a:rPr>
+                        <a:t>3.4×10¹³</a:t>
                       </a:r>
                     </a:p>
                   </a:txBody>
@@ -8568,7 +8442,7 @@
                           </a:solidFill>
                           <a:latin typeface="Arial"/>
                         </a:rPr>
-                        <a:t>zwfs_run('tag','ng385', 'NGRID',385)</a:t>
+                        <a:t>random walk, 2 pm per cycle</a:t>
                       </a:r>
                     </a:p>
                   </a:txBody>
@@ -8590,7 +8464,73 @@
                           </a:solidFill>
                           <a:latin typeface="Arial"/>
                         </a:rPr>
-                        <a:t>the 1-megapixel camera</a:t>
+                        <a:t>7.5×10¹²</a:t>
+                      </a:r>
+                    </a:p>
+                  </a:txBody>
+                  <a:tcPr marL="54864" marR="54864" marT="18288" marB="18288">
+                    <a:solidFill>
+                      <a:srgbClr val="ECF1F6"/>
+                    </a:solidFill>
+                  </a:tcPr>
+                </a:tc>
+                <a:tc>
+                  <a:txBody>
+                    <a:bodyPr wrap="square"/>
+                    <a:lstStyle/>
+                    <a:p>
+                      <a:r>
+                        <a:rPr sz="1100" b="0">
+                          <a:solidFill>
+                            <a:srgbClr val="282828"/>
+                          </a:solidFill>
+                          <a:latin typeface="Arial"/>
+                        </a:rPr>
+                        <a:t>5.3×10¹²</a:t>
+                      </a:r>
+                    </a:p>
+                  </a:txBody>
+                  <a:tcPr marL="54864" marR="54864" marT="18288" marB="18288">
+                    <a:solidFill>
+                      <a:srgbClr val="ECF1F6"/>
+                    </a:solidFill>
+                  </a:tcPr>
+                </a:tc>
+                <a:tc>
+                  <a:txBody>
+                    <a:bodyPr wrap="square"/>
+                    <a:lstStyle/>
+                    <a:p>
+                      <a:r>
+                        <a:rPr sz="1100" b="0">
+                          <a:solidFill>
+                            <a:srgbClr val="282828"/>
+                          </a:solidFill>
+                          <a:latin typeface="Arial"/>
+                        </a:rPr>
+                        <a:t>2.0×10¹³</a:t>
+                      </a:r>
+                    </a:p>
+                  </a:txBody>
+                  <a:tcPr marL="54864" marR="54864" marT="18288" marB="18288">
+                    <a:solidFill>
+                      <a:srgbClr val="ECF1F6"/>
+                    </a:solidFill>
+                  </a:tcPr>
+                </a:tc>
+                <a:tc>
+                  <a:txBody>
+                    <a:bodyPr wrap="square"/>
+                    <a:lstStyle/>
+                    <a:p>
+                      <a:r>
+                        <a:rPr sz="1100" b="0">
+                          <a:solidFill>
+                            <a:srgbClr val="282828"/>
+                          </a:solidFill>
+                          <a:latin typeface="Arial"/>
+                        </a:rPr>
+                        <a:t>never (4.1 pm floor)</a:t>
                       </a:r>
                     </a:p>
                   </a:txBody>
@@ -8614,7 +8554,7 @@
                           </a:solidFill>
                           <a:latin typeface="Arial"/>
                         </a:rPr>
-                        <a:t>zwfs_run('MODEL',2048, 'NGRID',385, 'param_file','macos_param_2048.txt')</a:t>
+                        <a:t>thermal ramp, 5 pm per cycle</a:t>
                       </a:r>
                     </a:p>
                   </a:txBody>
@@ -8636,7 +8576,73 @@
                           </a:solidFill>
                           <a:latin typeface="Arial"/>
                         </a:rPr>
-                        <a:t>the fully sampled setup on a 30 GB machine</a:t>
+                        <a:t>10.0 pm (the loop's lag)</a:t>
+                      </a:r>
+                    </a:p>
+                  </a:txBody>
+                  <a:tcPr marL="54864" marR="54864" marT="18288" marB="18288">
+                    <a:solidFill>
+                      <a:srgbClr val="FFFFFF"/>
+                    </a:solidFill>
+                  </a:tcPr>
+                </a:tc>
+                <a:tc>
+                  <a:txBody>
+                    <a:bodyPr wrap="square"/>
+                    <a:lstStyle/>
+                    <a:p>
+                      <a:r>
+                        <a:rPr sz="1100" b="0">
+                          <a:solidFill>
+                            <a:srgbClr val="282828"/>
+                          </a:solidFill>
+                          <a:latin typeface="Arial"/>
+                        </a:rPr>
+                        <a:t>9.9 pm</a:t>
+                      </a:r>
+                    </a:p>
+                  </a:txBody>
+                  <a:tcPr marL="54864" marR="54864" marT="18288" marB="18288">
+                    <a:solidFill>
+                      <a:srgbClr val="FFFFFF"/>
+                    </a:solidFill>
+                  </a:tcPr>
+                </a:tc>
+                <a:tc>
+                  <a:txBody>
+                    <a:bodyPr wrap="square"/>
+                    <a:lstStyle/>
+                    <a:p>
+                      <a:r>
+                        <a:rPr sz="1100" b="0">
+                          <a:solidFill>
+                            <a:srgbClr val="282828"/>
+                          </a:solidFill>
+                          <a:latin typeface="Arial"/>
+                        </a:rPr>
+                        <a:t>13.1 pm</a:t>
+                      </a:r>
+                    </a:p>
+                  </a:txBody>
+                  <a:tcPr marL="54864" marR="54864" marT="18288" marB="18288">
+                    <a:solidFill>
+                      <a:srgbClr val="FFFFFF"/>
+                    </a:solidFill>
+                  </a:tcPr>
+                </a:tc>
+                <a:tc>
+                  <a:txBody>
+                    <a:bodyPr wrap="square"/>
+                    <a:lstStyle/>
+                    <a:p>
+                      <a:r>
+                        <a:rPr sz="1100" b="0">
+                          <a:solidFill>
+                            <a:srgbClr val="282828"/>
+                          </a:solidFill>
+                          <a:latin typeface="Arial"/>
+                        </a:rPr>
+                        <a:t>39 pm</a:t>
                       </a:r>
                     </a:p>
                   </a:txBody>
@@ -8660,7 +8666,7 @@
                           </a:solidFill>
                           <a:latin typeface="Arial"/>
                         </a:rPr>
-                        <a:t>zwfs_run('stages',{'battery','color','noise','figs'})</a:t>
+                        <a:t>noise-free 1 nm step, after 60 cycles</a:t>
                       </a:r>
                     </a:p>
                   </a:txBody>
@@ -8682,7 +8688,7 @@
                           </a:solidFill>
                           <a:latin typeface="Arial"/>
                         </a:rPr>
-                        <a:t>everything on this deck's later slides</a:t>
+                        <a:t>0.000 pm</a:t>
                       </a:r>
                     </a:p>
                   </a:txBody>
@@ -8692,21 +8698,87 @@
                     </a:solidFill>
                   </a:tcPr>
                 </a:tc>
+                <a:tc>
+                  <a:txBody>
+                    <a:bodyPr wrap="square"/>
+                    <a:lstStyle/>
+                    <a:p>
+                      <a:r>
+                        <a:rPr sz="1100" b="0">
+                          <a:solidFill>
+                            <a:srgbClr val="282828"/>
+                          </a:solidFill>
+                          <a:latin typeface="Arial"/>
+                        </a:rPr>
+                        <a:t>0.000 pm</a:t>
+                      </a:r>
+                    </a:p>
+                  </a:txBody>
+                  <a:tcPr marL="54864" marR="54864" marT="18288" marB="18288">
+                    <a:solidFill>
+                      <a:srgbClr val="ECF1F6"/>
+                    </a:solidFill>
+                  </a:tcPr>
+                </a:tc>
+                <a:tc>
+                  <a:txBody>
+                    <a:bodyPr wrap="square"/>
+                    <a:lstStyle/>
+                    <a:p>
+                      <a:r>
+                        <a:rPr sz="1100" b="0">
+                          <a:solidFill>
+                            <a:srgbClr val="282828"/>
+                          </a:solidFill>
+                          <a:latin typeface="Arial"/>
+                        </a:rPr>
+                        <a:t>87 pm, rising</a:t>
+                      </a:r>
+                    </a:p>
+                  </a:txBody>
+                  <a:tcPr marL="54864" marR="54864" marT="18288" marB="18288">
+                    <a:solidFill>
+                      <a:srgbClr val="ECF1F6"/>
+                    </a:solidFill>
+                  </a:tcPr>
+                </a:tc>
+                <a:tc>
+                  <a:txBody>
+                    <a:bodyPr wrap="square"/>
+                    <a:lstStyle/>
+                    <a:p>
+                      <a:r>
+                        <a:rPr sz="1100" b="0">
+                          <a:solidFill>
+                            <a:srgbClr val="282828"/>
+                          </a:solidFill>
+                          <a:latin typeface="Arial"/>
+                        </a:rPr>
+                        <a:t>276 pm</a:t>
+                      </a:r>
+                    </a:p>
+                  </a:txBody>
+                  <a:tcPr marL="54864" marR="54864" marT="18288" marB="18288">
+                    <a:solidFill>
+                      <a:srgbClr val="ECF1F6"/>
+                    </a:solidFill>
+                  </a:tcPr>
+                </a:tc>
               </a:tr>
-              <a:tr h="280035">
-                <a:tc>
-                  <a:txBody>
-                    <a:bodyPr wrap="square"/>
-                    <a:lstStyle/>
-                    <a:p>
-                      <a:r>
-                        <a:rPr sz="1100" b="0">
-                          <a:solidFill>
-                            <a:srgbClr val="282828"/>
-                          </a:solidFill>
-                          <a:latin typeface="Arial"/>
-                        </a:rPr>
-                        <a:t>./zwfs_batch.sh TAG "the same arguments"</a:t>
+              <a:tr h="468630">
+                <a:tc>
+                  <a:txBody>
+                    <a:bodyPr wrap="square"/>
+                    <a:lstStyle/>
+                    <a:p>
+                      <a:r>
+                        <a:rPr sz="1100" b="0">
+                          <a:solidFill>
+                            <a:srgbClr val="282828"/>
+                          </a:solidFill>
+                          <a:latin typeface="Arial"/>
+                        </a:rPr>
+                        <a:t>single-shot noise at 10¹² photons per measurement</a:t>
                       </a:r>
                     </a:p>
                   </a:txBody>
@@ -8728,7 +8800,73 @@
                           </a:solidFill>
                           <a:latin typeface="Arial"/>
                         </a:rPr>
-                        <a:t>unattended, memory-capped, logged</a:t>
+                        <a:t>8.2 pm</a:t>
+                      </a:r>
+                    </a:p>
+                  </a:txBody>
+                  <a:tcPr marL="54864" marR="54864" marT="18288" marB="18288">
+                    <a:solidFill>
+                      <a:srgbClr val="FFFFFF"/>
+                    </a:solidFill>
+                  </a:tcPr>
+                </a:tc>
+                <a:tc>
+                  <a:txBody>
+                    <a:bodyPr wrap="square"/>
+                    <a:lstStyle/>
+                    <a:p>
+                      <a:r>
+                        <a:rPr sz="1100" b="0">
+                          <a:solidFill>
+                            <a:srgbClr val="282828"/>
+                          </a:solidFill>
+                          <a:latin typeface="Arial"/>
+                        </a:rPr>
+                        <a:t>6.4 pm</a:t>
+                      </a:r>
+                    </a:p>
+                  </a:txBody>
+                  <a:tcPr marL="54864" marR="54864" marT="18288" marB="18288">
+                    <a:solidFill>
+                      <a:srgbClr val="FFFFFF"/>
+                    </a:solidFill>
+                  </a:tcPr>
+                </a:tc>
+                <a:tc>
+                  <a:txBody>
+                    <a:bodyPr wrap="square"/>
+                    <a:lstStyle/>
+                    <a:p>
+                      <a:r>
+                        <a:rPr sz="1100" b="0">
+                          <a:solidFill>
+                            <a:srgbClr val="282828"/>
+                          </a:solidFill>
+                          <a:latin typeface="Arial"/>
+                        </a:rPr>
+                        <a:t>12.0 pm</a:t>
+                      </a:r>
+                    </a:p>
+                  </a:txBody>
+                  <a:tcPr marL="54864" marR="54864" marT="18288" marB="18288">
+                    <a:solidFill>
+                      <a:srgbClr val="FFFFFF"/>
+                    </a:solidFill>
+                  </a:tcPr>
+                </a:tc>
+                <a:tc>
+                  <a:txBody>
+                    <a:bodyPr wrap="square"/>
+                    <a:lstStyle/>
+                    <a:p>
+                      <a:r>
+                        <a:rPr sz="1100" b="0">
+                          <a:solidFill>
+                            <a:srgbClr val="282828"/>
+                          </a:solidFill>
+                          <a:latin typeface="Arial"/>
+                        </a:rPr>
+                        <a:t>—</a:t>
                       </a:r>
                     </a:p>
                   </a:txBody>
@@ -8745,13 +8883,13 @@
       </p:graphicFrame>
       <p:sp>
         <p:nvSpPr>
-          <p:cNvPr id="6" name="TextBox 5"/>
+          <p:cNvPr id="5" name="TextBox 4"/>
           <p:cNvSpPr txBox="1"/>
           <p:nvPr/>
         </p:nvSpPr>
         <p:spPr>
           <a:xfrm>
-            <a:off x="411480" y="4292346"/>
+            <a:off x="411480" y="3502152"/>
             <a:ext cx="11368735" cy="274320"/>
           </a:xfrm>
           <a:prstGeom prst="rect">
@@ -8777,20 +8915,36 @@
                 </a:solidFill>
                 <a:latin typeface="Arial"/>
               </a:rPr>
-              <a:t>•  Checks that run every time: the no-mask round trip through the bracket (must return the field unchanged); the reference-wave model against the engine's own field; the pupil brightness must not change with the DM shape; the sampling checks (pixels across the dimple, camera pixels per actuator); and the search for the camera-to-DM mirror/transpose and sign.</a:t>
-            </a:r>
-          </a:p>
-        </p:txBody>
-      </p:sp>
-      <p:sp>
-        <p:nvSpPr>
-          <p:cNvPr id="7" name="TextBox 6"/>
+              <a:t>•  Same loop code, same drift realization, same scoring (dm_gauge_lib/dmg_loop; the interferometer rows by CCMac).  The loop propagates noise as theory says on every instrument, so the light each needs follows from its single-shot noise: the interferometer's four-step reading is about 1.5× noisier per photon than the sensor's stepped reading, about twice the photons.</a:t>
+            </a:r>
+          </a:p>
+          <a:p>
+            <a:pPr>
+              <a:spcAft>
+                <a:spcPts val="600"/>
+              </a:spcAft>
+            </a:pPr>
+            <a:r>
+              <a:rPr sz="1500" b="0">
+                <a:solidFill>
+                  <a:srgbClr val="282828"/>
+                </a:solidFill>
+                <a:latin typeface="Arial"/>
+              </a:rPr>
+              <a:t>•  The fixed error is the difference. The sensor's stepped and polarized readings return to zero after a step; the interferometer keeps about 9% of any change (its fine-pattern roll-off and cross-talk, now in closed loop), so it behaves like the sensor's linear reading, not its stepped one.  The reflective interferometer's remaining fold cross-talk (0.18 open-loop, once the ideal-reflector artifact was removed with bare aluminum) becomes a hard wall in hold mode: the 2 pm walk is never held to 3 pm.  Open-loop batteries could not make that distinction.</a:t>
+            </a:r>
+          </a:p>
+        </p:txBody>
+      </p:sp>
+      <p:sp>
+        <p:nvSpPr>
+          <p:cNvPr id="6" name="TextBox 5"/>
           <p:cNvSpPr txBox="1"/>
           <p:nvPr/>
         </p:nvSpPr>
         <p:spPr>
           <a:xfrm>
-            <a:off x="411480" y="5459730"/>
+            <a:off x="411480" y="6047994"/>
             <a:ext cx="11368735" cy="274320"/>
           </a:xfrm>
           <a:prstGeom prst="rect">
@@ -8816,7 +8970,7 @@
                 </a:solidFill>
                 <a:latin typeface="Arial"/>
               </a:rPr>
-              <a:t>Reproduction check: 64 lines of results against the stage-7 report, 8 differ in the last printed digit (the actuator fit's solver tolerance).  README "Run it yourself" carries the parameter table.</a:t>
+              <a:t>Sensor rows: zwfs_dm96 runs/loop193, vloop193.  Interferometer rows: tg_psi_dm96_oap runs/loop_lens, loop_oap (bare aluminum on both OAPs; the ideal-reflector null was an idealization, its exactly-zero retardance variation).  All at gain 0.5, 60 cycles, matrix measured on the 30 nm working surface.</a:t>
             </a:r>
           </a:p>
         </p:txBody>
@@ -8873,7 +9027,7 @@
                 </a:solidFill>
                 <a:latin typeface="Arial"/>
               </a:rPr>
-              <a:t>Side by side with the Twyman–Green</a:t>
+              <a:t>Run it yourself</a:t>
             </a:r>
           </a:p>
           <a:p>
@@ -8889,7 +9043,7 @@
                 </a:solidFill>
                 <a:latin typeface="Arial"/>
               </a:rPr>
-              <a:t>The interferometer loses response at fine patterns and never fails; the sensor, calibrated on its working surface, reads a change to 5 pm up to 50–60 nm</a:t>
+              <a:t>One parameter sheet and one script reproduce every number here; the defaults reproduce the stage-7 record to the last printed digit</a:t>
             </a:r>
           </a:p>
         </p:txBody>
@@ -8938,17 +9092,56 @@
           </a:p>
         </p:txBody>
       </p:sp>
+      <p:sp>
+        <p:nvSpPr>
+          <p:cNvPr id="4" name="TextBox 3"/>
+          <p:cNvSpPr txBox="1"/>
+          <p:nvPr/>
+        </p:nvSpPr>
+        <p:spPr>
+          <a:xfrm>
+            <a:off x="411480" y="1298448"/>
+            <a:ext cx="11368735" cy="274320"/>
+          </a:xfrm>
+          <a:prstGeom prst="rect">
+            <a:avLst/>
+          </a:prstGeom>
+          <a:noFill/>
+        </p:spPr>
+        <p:txBody>
+          <a:bodyPr wrap="square">
+            <a:spAutoFit/>
+          </a:bodyPr>
+          <a:lstStyle/>
+          <a:p>
+            <a:pPr>
+              <a:spcAft>
+                <a:spcPts val="600"/>
+              </a:spcAft>
+            </a:pPr>
+            <a:r>
+              <a:rPr sz="1500" b="0">
+                <a:solidFill>
+                  <a:srgbClr val="282828"/>
+                </a:solidFill>
+                <a:latin typeface="Arial"/>
+              </a:rPr>
+              <a:t>•  Two files: zwfs_params.m returns every setting at its value of record — grid and ray count, wavelength, the bench's lengths and tuned figures, the mask's etch and spot, the sampling checks, registration, the DM sizes, the test amplitudes and seeds, the color and photon stages.  zwfs_run.m runs the chosen stages and writes the report, a .mat file and the figures into a folder named by the run's tag.</a:t>
+            </a:r>
+          </a:p>
+        </p:txBody>
+      </p:sp>
       <p:graphicFrame>
         <p:nvGraphicFramePr>
-          <p:cNvPr id="4" name="Table 3"/>
+          <p:cNvPr id="5" name="Table 4"/>
           <p:cNvGraphicFramePr>
             <a:graphicFrameLocks noGrp="1"/>
           </p:cNvGraphicFramePr>
           <p:nvPr/>
         </p:nvGraphicFramePr>
         <p:xfrm>
-          <a:off x="411480" y="1298448"/>
-          <a:ext cx="11368733" cy="4303395"/>
+          <a:off x="411480" y="2465831"/>
+          <a:ext cx="11368735" cy="1680210"/>
         </p:xfrm>
         <a:graphic>
           <a:graphicData uri="http://schemas.openxmlformats.org/drawingml/2006/table">
@@ -8957,16 +9150,25 @@
                 <a:tableStyleId>{5C22544A-7EE6-4342-B048-85BDC9FD1C3A}</a:tableStyleId>
               </a:tblPr>
               <a:tblGrid>
-                <a:gridCol w="3531564"/>
-                <a:gridCol w="2418879"/>
-                <a:gridCol w="5418290"/>
+                <a:gridCol w="6601201"/>
+                <a:gridCol w="4767534"/>
               </a:tblGrid>
               <a:tr h="280035">
                 <a:tc>
                   <a:txBody>
                     <a:bodyPr wrap="square"/>
                     <a:lstStyle/>
-                    <a:p/>
+                    <a:p>
+                      <a:r>
+                        <a:rPr sz="1100" b="1">
+                          <a:solidFill>
+                            <a:srgbClr val="FFFFFF"/>
+                          </a:solidFill>
+                          <a:latin typeface="Arial"/>
+                        </a:rPr>
+                        <a:t>call</a:t>
+                      </a:r>
+                    </a:p>
                   </a:txBody>
                   <a:tcPr marL="54864" marR="54864" marT="18288" marB="18288">
                     <a:solidFill>
@@ -8986,29 +9188,7 @@
                           </a:solidFill>
                           <a:latin typeface="Arial"/>
                         </a:rPr>
-                        <a:t>Twyman–Green PSI (measured)</a:t>
-                      </a:r>
-                    </a:p>
-                  </a:txBody>
-                  <a:tcPr marL="54864" marR="54864" marT="18288" marB="18288">
-                    <a:solidFill>
-                      <a:srgbClr val="1F4E79"/>
-                    </a:solidFill>
-                  </a:tcPr>
-                </a:tc>
-                <a:tc>
-                  <a:txBody>
-                    <a:bodyPr wrap="square"/>
-                    <a:lstStyle/>
-                    <a:p>
-                      <a:r>
-                        <a:rPr sz="1100" b="1">
-                          <a:solidFill>
-                            <a:srgbClr val="FFFFFF"/>
-                          </a:solidFill>
-                          <a:latin typeface="Arial"/>
-                        </a:rPr>
-                        <a:t>Zernike sensor (measured)</a:t>
+                        <a:t>what it does</a:t>
                       </a:r>
                     </a:p>
                   </a:txBody>
@@ -9032,7 +9212,7 @@
                           </a:solidFill>
                           <a:latin typeface="Arial"/>
                         </a:rPr>
-                        <a:t>reference beam</a:t>
+                        <a:t>zwfs_run</a:t>
                       </a:r>
                     </a:p>
                   </a:txBody>
@@ -9054,103 +9234,13 @@
                           </a:solidFill>
                           <a:latin typeface="Arial"/>
                         </a:rPr>
-                        <a:t>the second arm's flat</a:t>
+                        <a:t>the record: bench checks, the full test set, figures</a:t>
                       </a:r>
                     </a:p>
                   </a:txBody>
                   <a:tcPr marL="54864" marR="54864" marT="18288" marB="18288">
                     <a:solidFill>
                       <a:srgbClr val="FFFFFF"/>
-                    </a:solidFill>
-                  </a:tcPr>
-                </a:tc>
-                <a:tc>
-                  <a:txBody>
-                    <a:bodyPr wrap="square"/>
-                    <a:lstStyle/>
-                    <a:p>
-                      <a:r>
-                        <a:rPr sz="1100" b="0">
-                          <a:solidFill>
-                            <a:srgbClr val="282828"/>
-                          </a:solidFill>
-                          <a:latin typeface="Arial"/>
-                        </a:rPr>
-                        <a:t>made from the beam's own focal core</a:t>
-                      </a:r>
-                    </a:p>
-                  </a:txBody>
-                  <a:tcPr marL="54864" marR="54864" marT="18288" marB="18288">
-                    <a:solidFill>
-                      <a:srgbClr val="FFFFFF"/>
-                    </a:solidFill>
-                  </a:tcPr>
-                </a:tc>
-              </a:tr>
-              <a:tr h="468630">
-                <a:tc>
-                  <a:txBody>
-                    <a:bodyPr wrap="square"/>
-                    <a:lstStyle/>
-                    <a:p>
-                      <a:r>
-                        <a:rPr sz="1100" b="0">
-                          <a:solidFill>
-                            <a:srgbClr val="282828"/>
-                          </a:solidFill>
-                          <a:latin typeface="Arial"/>
-                        </a:rPr>
-                        <a:t>one measurement costs</a:t>
-                      </a:r>
-                    </a:p>
-                  </a:txBody>
-                  <a:tcPr marL="54864" marR="54864" marT="18288" marB="18288">
-                    <a:solidFill>
-                      <a:srgbClr val="ECF1F6"/>
-                    </a:solidFill>
-                  </a:tcPr>
-                </a:tc>
-                <a:tc>
-                  <a:txBody>
-                    <a:bodyPr wrap="square"/>
-                    <a:lstStyle/>
-                    <a:p>
-                      <a:r>
-                        <a:rPr sz="1100" b="0">
-                          <a:solidFill>
-                            <a:srgbClr val="282828"/>
-                          </a:solidFill>
-                          <a:latin typeface="Arial"/>
-                        </a:rPr>
-                        <a:t>6 traces (3 per arm), 4 fringe frames</a:t>
-                      </a:r>
-                    </a:p>
-                  </a:txBody>
-                  <a:tcPr marL="54864" marR="54864" marT="18288" marB="18288">
-                    <a:solidFill>
-                      <a:srgbClr val="ECF1F6"/>
-                    </a:solidFill>
-                  </a:tcPr>
-                </a:tc>
-                <a:tc>
-                  <a:txBody>
-                    <a:bodyPr wrap="square"/>
-                    <a:lstStyle/>
-                    <a:p>
-                      <a:r>
-                        <a:rPr sz="1100" b="0">
-                          <a:solidFill>
-                            <a:srgbClr val="282828"/>
-                          </a:solidFill>
-                          <a:latin typeface="Arial"/>
-                        </a:rPr>
-                        <a:t>1 or 4 camera frames; 256 calibration frames once per working surface</a:t>
-                      </a:r>
-                    </a:p>
-                  </a:txBody>
-                  <a:tcPr marL="54864" marR="54864" marT="18288" marB="18288">
-                    <a:solidFill>
-                      <a:srgbClr val="ECF1F6"/>
                     </a:solidFill>
                   </a:tcPr>
                 </a:tc>
@@ -9168,57 +9258,35 @@
                           </a:solidFill>
                           <a:latin typeface="Arial"/>
                         </a:rPr>
-                        <a:t>polarization hardware</a:t>
-                      </a:r>
-                    </a:p>
-                  </a:txBody>
-                  <a:tcPr marL="54864" marR="54864" marT="18288" marB="18288">
-                    <a:solidFill>
-                      <a:srgbClr val="FFFFFF"/>
-                    </a:solidFill>
-                  </a:tcPr>
-                </a:tc>
-                <a:tc>
-                  <a:txBody>
-                    <a:bodyPr wrap="square"/>
-                    <a:lstStyle/>
-                    <a:p>
-                      <a:r>
-                        <a:rPr sz="1100" b="0">
-                          <a:solidFill>
-                            <a:srgbClr val="282828"/>
-                          </a:solidFill>
-                          <a:latin typeface="Arial"/>
-                        </a:rPr>
-                        <a:t>polarizer, 5 waveplates, analyzer</a:t>
-                      </a:r>
-                    </a:p>
-                  </a:txBody>
-                  <a:tcPr marL="54864" marR="54864" marT="18288" marB="18288">
-                    <a:solidFill>
-                      <a:srgbClr val="FFFFFF"/>
-                    </a:solidFill>
-                  </a:tcPr>
-                </a:tc>
-                <a:tc>
-                  <a:txBody>
-                    <a:bodyPr wrap="square"/>
-                    <a:lstStyle/>
-                    <a:p>
-                      <a:r>
-                        <a:rPr sz="1100" b="0">
-                          <a:solidFill>
-                            <a:srgbClr val="282828"/>
-                          </a:solidFill>
-                          <a:latin typeface="Arial"/>
-                        </a:rPr>
-                        <a:t>none</a:t>
-                      </a:r>
-                    </a:p>
-                  </a:txBody>
-                  <a:tcPr marL="54864" marR="54864" marT="18288" marB="18288">
-                    <a:solidFill>
-                      <a:srgbClr val="FFFFFF"/>
+                        <a:t>zwfs_run('tag','ng385', 'NGRID',385)</a:t>
+                      </a:r>
+                    </a:p>
+                  </a:txBody>
+                  <a:tcPr marL="54864" marR="54864" marT="18288" marB="18288">
+                    <a:solidFill>
+                      <a:srgbClr val="ECF1F6"/>
+                    </a:solidFill>
+                  </a:tcPr>
+                </a:tc>
+                <a:tc>
+                  <a:txBody>
+                    <a:bodyPr wrap="square"/>
+                    <a:lstStyle/>
+                    <a:p>
+                      <a:r>
+                        <a:rPr sz="1100" b="0">
+                          <a:solidFill>
+                            <a:srgbClr val="282828"/>
+                          </a:solidFill>
+                          <a:latin typeface="Arial"/>
+                        </a:rPr>
+                        <a:t>the 1-megapixel camera</a:t>
+                      </a:r>
+                    </a:p>
+                  </a:txBody>
+                  <a:tcPr marL="54864" marR="54864" marT="18288" marB="18288">
+                    <a:solidFill>
+                      <a:srgbClr val="ECF1F6"/>
                     </a:solidFill>
                   </a:tcPr>
                 </a:tc>
@@ -9236,57 +9304,35 @@
                           </a:solidFill>
                           <a:latin typeface="Arial"/>
                         </a:rPr>
-                        <a:t>moving parts</a:t>
-                      </a:r>
-                    </a:p>
-                  </a:txBody>
-                  <a:tcPr marL="54864" marR="54864" marT="18288" marB="18288">
-                    <a:solidFill>
-                      <a:srgbClr val="ECF1F6"/>
-                    </a:solidFill>
-                  </a:tcPr>
-                </a:tc>
-                <a:tc>
-                  <a:txBody>
-                    <a:bodyPr wrap="square"/>
-                    <a:lstStyle/>
-                    <a:p>
-                      <a:r>
-                        <a:rPr sz="1100" b="0">
-                          <a:solidFill>
-                            <a:srgbClr val="282828"/>
-                          </a:solidFill>
-                          <a:latin typeface="Arial"/>
-                        </a:rPr>
-                        <a:t>none (polarization-stepped)</a:t>
-                      </a:r>
-                    </a:p>
-                  </a:txBody>
-                  <a:tcPr marL="54864" marR="54864" marT="18288" marB="18288">
-                    <a:solidFill>
-                      <a:srgbClr val="ECF1F6"/>
-                    </a:solidFill>
-                  </a:tcPr>
-                </a:tc>
-                <a:tc>
-                  <a:txBody>
-                    <a:bodyPr wrap="square"/>
-                    <a:lstStyle/>
-                    <a:p>
-                      <a:r>
-                        <a:rPr sz="1100" b="0">
-                          <a:solidFill>
-                            <a:srgbClr val="282828"/>
-                          </a:solidFill>
-                          <a:latin typeface="Arial"/>
-                        </a:rPr>
-                        <a:t>none</a:t>
-                      </a:r>
-                    </a:p>
-                  </a:txBody>
-                  <a:tcPr marL="54864" marR="54864" marT="18288" marB="18288">
-                    <a:solidFill>
-                      <a:srgbClr val="ECF1F6"/>
+                        <a:t>zwfs_run('MODEL',2048, 'NGRID',385, 'param_file','macos_param_2048.txt')</a:t>
+                      </a:r>
+                    </a:p>
+                  </a:txBody>
+                  <a:tcPr marL="54864" marR="54864" marT="18288" marB="18288">
+                    <a:solidFill>
+                      <a:srgbClr val="FFFFFF"/>
+                    </a:solidFill>
+                  </a:tcPr>
+                </a:tc>
+                <a:tc>
+                  <a:txBody>
+                    <a:bodyPr wrap="square"/>
+                    <a:lstStyle/>
+                    <a:p>
+                      <a:r>
+                        <a:rPr sz="1100" b="0">
+                          <a:solidFill>
+                            <a:srgbClr val="282828"/>
+                          </a:solidFill>
+                          <a:latin typeface="Arial"/>
+                        </a:rPr>
+                        <a:t>the fully sampled setup on a 30 GB machine</a:t>
+                      </a:r>
+                    </a:p>
+                  </a:txBody>
+                  <a:tcPr marL="54864" marR="54864" marT="18288" marB="18288">
+                    <a:solidFill>
+                      <a:srgbClr val="FFFFFF"/>
                     </a:solidFill>
                   </a:tcPr>
                 </a:tc>
@@ -9304,75 +9350,7 @@
                           </a:solidFill>
                           <a:latin typeface="Arial"/>
                         </a:rPr>
-                        <a:t>null, nothing aligned</a:t>
-                      </a:r>
-                    </a:p>
-                  </a:txBody>
-                  <a:tcPr marL="54864" marR="54864" marT="18288" marB="18288">
-                    <a:solidFill>
-                      <a:srgbClr val="FFFFFF"/>
-                    </a:solidFill>
-                  </a:tcPr>
-                </a:tc>
-                <a:tc>
-                  <a:txBody>
-                    <a:bodyPr wrap="square"/>
-                    <a:lstStyle/>
-                    <a:p>
-                      <a:r>
-                        <a:rPr sz="1100" b="0">
-                          <a:solidFill>
-                            <a:srgbClr val="282828"/>
-                          </a:solidFill>
-                          <a:latin typeface="Arial"/>
-                        </a:rPr>
-                        <a:t>0.134 nm</a:t>
-                      </a:r>
-                    </a:p>
-                  </a:txBody>
-                  <a:tcPr marL="54864" marR="54864" marT="18288" marB="18288">
-                    <a:solidFill>
-                      <a:srgbClr val="FFFFFF"/>
-                    </a:solidFill>
-                  </a:tcPr>
-                </a:tc>
-                <a:tc>
-                  <a:txBody>
-                    <a:bodyPr wrap="square"/>
-                    <a:lstStyle/>
-                    <a:p>
-                      <a:r>
-                        <a:rPr sz="1100" b="0">
-                          <a:solidFill>
-                            <a:srgbClr val="282828"/>
-                          </a:solidFill>
-                          <a:latin typeface="Arial"/>
-                        </a:rPr>
-                        <a:t>0 by construction (the flat is the reference)</a:t>
-                      </a:r>
-                    </a:p>
-                  </a:txBody>
-                  <a:tcPr marL="54864" marR="54864" marT="18288" marB="18288">
-                    <a:solidFill>
-                      <a:srgbClr val="FFFFFF"/>
-                    </a:solidFill>
-                  </a:tcPr>
-                </a:tc>
-              </a:tr>
-              <a:tr h="468630">
-                <a:tc>
-                  <a:txBody>
-                    <a:bodyPr wrap="square"/>
-                    <a:lstStyle/>
-                    <a:p>
-                      <a:r>
-                        <a:rPr sz="1100" b="0">
-                          <a:solidFill>
-                            <a:srgbClr val="282828"/>
-                          </a:solidFill>
-                          <a:latin typeface="Arial"/>
-                        </a:rPr>
-                        <a:t>response falls off at</a:t>
+                        <a:t>zwfs_run('stages',{'battery','color','noise','figs'})</a:t>
                       </a:r>
                     </a:p>
                   </a:txBody>
@@ -9394,29 +9372,7 @@
                           </a:solidFill>
                           <a:latin typeface="Arial"/>
                         </a:rPr>
-                        <a:t>fine patterns: 0.50 at the 96×96 checkerboard</a:t>
-                      </a:r>
-                    </a:p>
-                  </a:txBody>
-                  <a:tcPr marL="54864" marR="54864" marT="18288" marB="18288">
-                    <a:solidFill>
-                      <a:srgbClr val="ECF1F6"/>
-                    </a:solidFill>
-                  </a:tcPr>
-                </a:tc>
-                <a:tc>
-                  <a:txBody>
-                    <a:bodyPr wrap="square"/>
-                    <a:lstStyle/>
-                    <a:p>
-                      <a:r>
-                        <a:rPr sz="1100" b="0">
-                          <a:solidFill>
-                            <a:srgbClr val="282828"/>
-                          </a:solidFill>
-                          <a:latin typeface="Arial"/>
-                        </a:rPr>
-                        <a:t>0.5 to 1 cycle across the pupil (0.5 at 1); piston unseen</a:t>
+                        <a:t>everything on this deck's later slides</a:t>
                       </a:r>
                     </a:p>
                   </a:txBody>
@@ -9440,7 +9396,7 @@
                           </a:solidFill>
                           <a:latin typeface="Arial"/>
                         </a:rPr>
-                        <a:t>working surface it can handle</a:t>
+                        <a:t>./zwfs_batch.sh TAG "the same arguments"</a:t>
                       </a:r>
                     </a:p>
                   </a:txBody>
@@ -9462,301 +9418,7 @@
                           </a:solidFill>
                           <a:latin typeface="Arial"/>
                         </a:rPr>
-                        <a:t>480 nm rms and beyond</a:t>
-                      </a:r>
-                    </a:p>
-                  </a:txBody>
-                  <a:tcPr marL="54864" marR="54864" marT="18288" marB="18288">
-                    <a:solidFill>
-                      <a:srgbClr val="FFFFFF"/>
-                    </a:solidFill>
-                  </a:tcPr>
-                </a:tc>
-                <a:tc>
-                  <a:txBody>
-                    <a:bodyPr wrap="square"/>
-                    <a:lstStyle/>
-                    <a:p>
-                      <a:r>
-                        <a:rPr sz="1100" b="0">
-                          <a:solidFill>
-                            <a:srgbClr val="282828"/>
-                          </a:solidFill>
-                          <a:latin typeface="Arial"/>
-                        </a:rPr>
-                        <a:t>40 nm rms one-frame (1 mm actuators), 50–60 nm four-frame</a:t>
-                      </a:r>
-                    </a:p>
-                  </a:txBody>
-                  <a:tcPr marL="54864" marR="54864" marT="18288" marB="18288">
-                    <a:solidFill>
-                      <a:srgbClr val="FFFFFF"/>
-                    </a:solidFill>
-                  </a:tcPr>
-                </a:tc>
-              </a:tr>
-              <a:tr h="468630">
-                <a:tc>
-                  <a:txBody>
-                    <a:bodyPr wrap="square"/>
-                    <a:lstStyle/>
-                    <a:p>
-                      <a:r>
-                        <a:rPr sz="1100" b="0">
-                          <a:solidFill>
-                            <a:srgbClr val="282828"/>
-                          </a:solidFill>
-                          <a:latin typeface="Arial"/>
-                        </a:rPr>
-                        <a:t>a 10 nm actuator change on a 30 nm surface</a:t>
-                      </a:r>
-                    </a:p>
-                  </a:txBody>
-                  <a:tcPr marL="54864" marR="54864" marT="18288" marB="18288">
-                    <a:solidFill>
-                      <a:srgbClr val="ECF1F6"/>
-                    </a:solidFill>
-                  </a:tcPr>
-                </a:tc>
-                <a:tc>
-                  <a:txBody>
-                    <a:bodyPr wrap="square"/>
-                    <a:lstStyle/>
-                    <a:p>
-                      <a:r>
-                        <a:rPr sz="1100" b="0">
-                          <a:solidFill>
-                            <a:srgbClr val="282828"/>
-                          </a:solidFill>
-                          <a:latin typeface="Arial"/>
-                        </a:rPr>
-                        <a:t>gain 0.92, floor 46 pm</a:t>
-                      </a:r>
-                    </a:p>
-                  </a:txBody>
-                  <a:tcPr marL="54864" marR="54864" marT="18288" marB="18288">
-                    <a:solidFill>
-                      <a:srgbClr val="ECF1F6"/>
-                    </a:solidFill>
-                  </a:tcPr>
-                </a:tc>
-                <a:tc>
-                  <a:txBody>
-                    <a:bodyPr wrap="square"/>
-                    <a:lstStyle/>
-                    <a:p>
-                      <a:r>
-                        <a:rPr sz="1100" b="0">
-                          <a:solidFill>
-                            <a:srgbClr val="282828"/>
-                          </a:solidFill>
-                          <a:latin typeface="Arial"/>
-                        </a:rPr>
-                        <a:t>gain 0.99, floor 5 pm (stepped, four frames; matrix on the surface) — gain 1.05, floor 23 pm (linear, one frame)</a:t>
-                      </a:r>
-                    </a:p>
-                  </a:txBody>
-                  <a:tcPr marL="54864" marR="54864" marT="18288" marB="18288">
-                    <a:solidFill>
-                      <a:srgbClr val="ECF1F6"/>
-                    </a:solidFill>
-                  </a:tcPr>
-                </a:tc>
-              </a:tr>
-              <a:tr h="280035">
-                <a:tc>
-                  <a:txBody>
-                    <a:bodyPr wrap="square"/>
-                    <a:lstStyle/>
-                    <a:p>
-                      <a:r>
-                        <a:rPr sz="1100" b="0">
-                          <a:solidFill>
-                            <a:srgbClr val="282828"/>
-                          </a:solidFill>
-                          <a:latin typeface="Arial"/>
-                        </a:rPr>
-                        <a:t>photons per measurement for 1 pm</a:t>
-                      </a:r>
-                    </a:p>
-                  </a:txBody>
-                  <a:tcPr marL="54864" marR="54864" marT="18288" marB="18288">
-                    <a:solidFill>
-                      <a:srgbClr val="FFFFFF"/>
-                    </a:solidFill>
-                  </a:tcPr>
-                </a:tc>
-                <a:tc>
-                  <a:txBody>
-                    <a:bodyPr wrap="square"/>
-                    <a:lstStyle/>
-                    <a:p>
-                      <a:r>
-                        <a:rPr sz="1100" b="0">
-                          <a:solidFill>
-                            <a:srgbClr val="282828"/>
-                          </a:solidFill>
-                          <a:latin typeface="Arial"/>
-                        </a:rPr>
-                        <a:t>8×10¹⁴</a:t>
-                      </a:r>
-                    </a:p>
-                  </a:txBody>
-                  <a:tcPr marL="54864" marR="54864" marT="18288" marB="18288">
-                    <a:solidFill>
-                      <a:srgbClr val="FFFFFF"/>
-                    </a:solidFill>
-                  </a:tcPr>
-                </a:tc>
-                <a:tc>
-                  <a:txBody>
-                    <a:bodyPr wrap="square"/>
-                    <a:lstStyle/>
-                    <a:p>
-                      <a:r>
-                        <a:rPr sz="1100" b="0">
-                          <a:solidFill>
-                            <a:srgbClr val="282828"/>
-                          </a:solidFill>
-                          <a:latin typeface="Arial"/>
-                        </a:rPr>
-                        <a:t>0.4 to 1×10¹⁴</a:t>
-                      </a:r>
-                    </a:p>
-                  </a:txBody>
-                  <a:tcPr marL="54864" marR="54864" marT="18288" marB="18288">
-                    <a:solidFill>
-                      <a:srgbClr val="FFFFFF"/>
-                    </a:solidFill>
-                  </a:tcPr>
-                </a:tc>
-              </a:tr>
-              <a:tr h="468630">
-                <a:tc>
-                  <a:txBody>
-                    <a:bodyPr wrap="square"/>
-                    <a:lstStyle/>
-                    <a:p>
-                      <a:r>
-                        <a:rPr sz="1100" b="0">
-                          <a:solidFill>
-                            <a:srgbClr val="282828"/>
-                          </a:solidFill>
-                          <a:latin typeface="Arial"/>
-                        </a:rPr>
-                        <a:t>held in closed loop to 3 pm against a 2 pm random walk: photons per cycle</a:t>
-                      </a:r>
-                    </a:p>
-                  </a:txBody>
-                  <a:tcPr marL="54864" marR="54864" marT="18288" marB="18288">
-                    <a:solidFill>
-                      <a:srgbClr val="ECF1F6"/>
-                    </a:solidFill>
-                  </a:tcPr>
-                </a:tc>
-                <a:tc>
-                  <a:txBody>
-                    <a:bodyPr wrap="square"/>
-                    <a:lstStyle/>
-                    <a:p>
-                      <a:r>
-                        <a:rPr sz="1100" b="0">
-                          <a:solidFill>
-                            <a:srgbClr val="282828"/>
-                          </a:solidFill>
-                          <a:latin typeface="Arial"/>
-                        </a:rPr>
-                        <a:t>2.0×10¹³ (lens rig); never with the reflective rig</a:t>
-                      </a:r>
-                    </a:p>
-                  </a:txBody>
-                  <a:tcPr marL="54864" marR="54864" marT="18288" marB="18288">
-                    <a:solidFill>
-                      <a:srgbClr val="ECF1F6"/>
-                    </a:solidFill>
-                  </a:tcPr>
-                </a:tc>
-                <a:tc>
-                  <a:txBody>
-                    <a:bodyPr wrap="square"/>
-                    <a:lstStyle/>
-                    <a:p>
-                      <a:r>
-                        <a:rPr sz="1100" b="0">
-                          <a:solidFill>
-                            <a:srgbClr val="282828"/>
-                          </a:solidFill>
-                          <a:latin typeface="Arial"/>
-                        </a:rPr>
-                        <a:t>7.5×10¹² (stepped), 7.3×10¹² (linear), 5.3×10¹² (polarized pair)</a:t>
-                      </a:r>
-                    </a:p>
-                  </a:txBody>
-                  <a:tcPr marL="54864" marR="54864" marT="18288" marB="18288">
-                    <a:solidFill>
-                      <a:srgbClr val="ECF1F6"/>
-                    </a:solidFill>
-                  </a:tcPr>
-                </a:tc>
-              </a:tr>
-              <a:tr h="468630">
-                <a:tc>
-                  <a:txBody>
-                    <a:bodyPr wrap="square"/>
-                    <a:lstStyle/>
-                    <a:p>
-                      <a:r>
-                        <a:rPr sz="1100" b="0">
-                          <a:solidFill>
-                            <a:srgbClr val="282828"/>
-                          </a:solidFill>
-                          <a:latin typeface="Arial"/>
-                        </a:rPr>
-                        <a:t>fixed error in closed loop (noise-free 1 nm step after 60 cycles)</a:t>
-                      </a:r>
-                    </a:p>
-                  </a:txBody>
-                  <a:tcPr marL="54864" marR="54864" marT="18288" marB="18288">
-                    <a:solidFill>
-                      <a:srgbClr val="FFFFFF"/>
-                    </a:solidFill>
-                  </a:tcPr>
-                </a:tc>
-                <a:tc>
-                  <a:txBody>
-                    <a:bodyPr wrap="square"/>
-                    <a:lstStyle/>
-                    <a:p>
-                      <a:r>
-                        <a:rPr sz="1100" b="0">
-                          <a:solidFill>
-                            <a:srgbClr val="282828"/>
-                          </a:solidFill>
-                          <a:latin typeface="Arial"/>
-                        </a:rPr>
-                        <a:t>87 pm and rising (lens); 276 pm (reflective)</a:t>
-                      </a:r>
-                    </a:p>
-                  </a:txBody>
-                  <a:tcPr marL="54864" marR="54864" marT="18288" marB="18288">
-                    <a:solidFill>
-                      <a:srgbClr val="FFFFFF"/>
-                    </a:solidFill>
-                  </a:tcPr>
-                </a:tc>
-                <a:tc>
-                  <a:txBody>
-                    <a:bodyPr wrap="square"/>
-                    <a:lstStyle/>
-                    <a:p>
-                      <a:r>
-                        <a:rPr sz="1100" b="0">
-                          <a:solidFill>
-                            <a:srgbClr val="282828"/>
-                          </a:solidFill>
-                          <a:latin typeface="Arial"/>
-                        </a:rPr>
-                        <a:t>0.000 pm (stepped, polarized pair)</a:t>
+                        <a:t>unattended, memory-capped, logged</a:t>
                       </a:r>
                     </a:p>
                   </a:txBody>
@@ -9773,13 +9435,13 @@
       </p:graphicFrame>
       <p:sp>
         <p:nvSpPr>
-          <p:cNvPr id="5" name="TextBox 4"/>
+          <p:cNvPr id="6" name="TextBox 5"/>
           <p:cNvSpPr txBox="1"/>
           <p:nvPr/>
         </p:nvSpPr>
         <p:spPr>
           <a:xfrm>
-            <a:off x="411480" y="5748147"/>
+            <a:off x="411480" y="4292346"/>
             <a:ext cx="11368735" cy="274320"/>
           </a:xfrm>
           <a:prstGeom prst="rect">
@@ -9805,20 +9467,20 @@
                 </a:solidFill>
                 <a:latin typeface="Arial"/>
               </a:rPr>
-              <a:t>•  Reading: the interferometer measures any surface and pays at fine patterns; the sensor measures small changes on a small working surface more cheaply — no polarization train, a floor ten times lower once its response matrix is measured on that surface — and pays at the lowest spatial frequencies and in the surface it can handle.</a:t>
-            </a:r>
-          </a:p>
-        </p:txBody>
-      </p:sp>
-      <p:sp>
-        <p:nvSpPr>
-          <p:cNvPr id="6" name="TextBox 5"/>
+              <a:t>•  Checks that run every time: the no-mask round trip through the bracket (must return the field unchanged); the reference-wave model against the engine's own field; the pupil brightness must not change with the DM shape; the sampling checks (pixels across the dimple, camera pixels per actuator); and the search for the camera-to-DM mirror/transpose and sign.</a:t>
+            </a:r>
+          </a:p>
+        </p:txBody>
+      </p:sp>
+      <p:sp>
+        <p:nvSpPr>
+          <p:cNvPr id="7" name="TextBox 6"/>
           <p:cNvSpPr txBox="1"/>
           <p:nvPr/>
         </p:nvSpPr>
         <p:spPr>
           <a:xfrm>
-            <a:off x="411480" y="6667881"/>
+            <a:off x="411480" y="5459730"/>
             <a:ext cx="11368735" cy="274320"/>
           </a:xfrm>
           <a:prstGeom prst="rect">
@@ -9844,7 +9506,7 @@
                 </a:solidFill>
                 <a:latin typeface="Arial"/>
               </a:rPr>
-              <a:t>PSI column: tg_psi_dm96 run 10 and S4/S5; sensor column: 385 rays, matrix calibration on the working surface (slide 10), photons at development sampling.  Both in actuator units through the same code (dm_gauge_lib).</a:t>
+              <a:t>Reproduction check: 64 lines of results against the stage-7 report, 8 differ in the last printed digit (the actuator fit's solver tolerance).  README "Run it yourself" carries the parameter table.</a:t>
             </a:r>
           </a:p>
         </p:txBody>
@@ -9901,7 +9563,7 @@
                 </a:solidFill>
                 <a:latin typeface="Arial"/>
               </a:rPr>
-              <a:t>What the Zernike-sensor literature offers, in priority order</a:t>
+              <a:t>Side by side with the Twyman–Green</a:t>
             </a:r>
           </a:p>
           <a:p>
@@ -9917,7 +9579,7 @@
                 </a:solidFill>
                 <a:latin typeface="Arial"/>
               </a:rPr>
-              <a:t>Twelve papers read; the first import — re-computing the reference wave — is now built and measured (slide 8)</a:t>
+              <a:t>The interferometer loses response at fine patterns and never fails; the sensor, calibrated on its working surface, reads a change to 5 pm up to 50–60 nm</a:t>
             </a:r>
           </a:p>
         </p:txBody>
@@ -9976,7 +9638,7 @@
         </p:nvGraphicFramePr>
         <p:xfrm>
           <a:off x="411480" y="1298448"/>
-          <a:ext cx="11368734" cy="3091815"/>
+          <a:ext cx="11368733" cy="4303395"/>
         </p:xfrm>
         <a:graphic>
           <a:graphicData uri="http://schemas.openxmlformats.org/drawingml/2006/table">
@@ -9985,15 +9647,27 @@
                 <a:tableStyleId>{5C22544A-7EE6-4342-B048-85BDC9FD1C3A}</a:tableStyleId>
               </a:tblPr>
               <a:tblGrid>
-                <a:gridCol w="218948"/>
-                <a:gridCol w="2691327"/>
-                <a:gridCol w="8458459"/>
+                <a:gridCol w="3531564"/>
+                <a:gridCol w="2418879"/>
+                <a:gridCol w="5418290"/>
               </a:tblGrid>
               <a:tr h="280035">
                 <a:tc>
                   <a:txBody>
                     <a:bodyPr wrap="square"/>
                     <a:lstStyle/>
+                    <a:p/>
+                  </a:txBody>
+                  <a:tcPr marL="54864" marR="54864" marT="18288" marB="18288">
+                    <a:solidFill>
+                      <a:srgbClr val="1F4E79"/>
+                    </a:solidFill>
+                  </a:tcPr>
+                </a:tc>
+                <a:tc>
+                  <a:txBody>
+                    <a:bodyPr wrap="square"/>
+                    <a:lstStyle/>
                     <a:p>
                       <a:r>
                         <a:rPr sz="1100" b="1">
@@ -10002,7 +9676,7 @@
                           </a:solidFill>
                           <a:latin typeface="Arial"/>
                         </a:rPr>
-                        <a:t>#</a:t>
+                        <a:t>Twyman–Green PSI (measured)</a:t>
                       </a:r>
                     </a:p>
                   </a:txBody>
@@ -10024,7 +9698,7 @@
                           </a:solidFill>
                           <a:latin typeface="Arial"/>
                         </a:rPr>
-                        <a:t>paper</a:t>
+                        <a:t>Zernike sensor (measured)</a:t>
                       </a:r>
                     </a:p>
                   </a:txBody>
@@ -10034,25 +9708,71 @@
                     </a:solidFill>
                   </a:tcPr>
                 </a:tc>
-                <a:tc>
-                  <a:txBody>
-                    <a:bodyPr wrap="square"/>
-                    <a:lstStyle/>
-                    <a:p>
-                      <a:r>
-                        <a:rPr sz="1100" b="1">
-                          <a:solidFill>
-                            <a:srgbClr val="FFFFFF"/>
-                          </a:solidFill>
-                          <a:latin typeface="Arial"/>
-                        </a:rPr>
-                        <a:t>what it gives this model</a:t>
-                      </a:r>
-                    </a:p>
-                  </a:txBody>
-                  <a:tcPr marL="54864" marR="54864" marT="18288" marB="18288">
-                    <a:solidFill>
-                      <a:srgbClr val="1F4E79"/>
+              </a:tr>
+              <a:tr h="280035">
+                <a:tc>
+                  <a:txBody>
+                    <a:bodyPr wrap="square"/>
+                    <a:lstStyle/>
+                    <a:p>
+                      <a:r>
+                        <a:rPr sz="1100" b="0">
+                          <a:solidFill>
+                            <a:srgbClr val="282828"/>
+                          </a:solidFill>
+                          <a:latin typeface="Arial"/>
+                        </a:rPr>
+                        <a:t>reference beam</a:t>
+                      </a:r>
+                    </a:p>
+                  </a:txBody>
+                  <a:tcPr marL="54864" marR="54864" marT="18288" marB="18288">
+                    <a:solidFill>
+                      <a:srgbClr val="FFFFFF"/>
+                    </a:solidFill>
+                  </a:tcPr>
+                </a:tc>
+                <a:tc>
+                  <a:txBody>
+                    <a:bodyPr wrap="square"/>
+                    <a:lstStyle/>
+                    <a:p>
+                      <a:r>
+                        <a:rPr sz="1100" b="0">
+                          <a:solidFill>
+                            <a:srgbClr val="282828"/>
+                          </a:solidFill>
+                          <a:latin typeface="Arial"/>
+                        </a:rPr>
+                        <a:t>the second arm's flat</a:t>
+                      </a:r>
+                    </a:p>
+                  </a:txBody>
+                  <a:tcPr marL="54864" marR="54864" marT="18288" marB="18288">
+                    <a:solidFill>
+                      <a:srgbClr val="FFFFFF"/>
+                    </a:solidFill>
+                  </a:tcPr>
+                </a:tc>
+                <a:tc>
+                  <a:txBody>
+                    <a:bodyPr wrap="square"/>
+                    <a:lstStyle/>
+                    <a:p>
+                      <a:r>
+                        <a:rPr sz="1100" b="0">
+                          <a:solidFill>
+                            <a:srgbClr val="282828"/>
+                          </a:solidFill>
+                          <a:latin typeface="Arial"/>
+                        </a:rPr>
+                        <a:t>made from the beam's own focal core</a:t>
+                      </a:r>
+                    </a:p>
+                  </a:txBody>
+                  <a:tcPr marL="54864" marR="54864" marT="18288" marB="18288">
+                    <a:solidFill>
+                      <a:srgbClr val="FFFFFF"/>
                     </a:solidFill>
                   </a:tcPr>
                 </a:tc>
@@ -10070,7 +9790,75 @@
                           </a:solidFill>
                           <a:latin typeface="Arial"/>
                         </a:rPr>
-                        <a:t>1</a:t>
+                        <a:t>one measurement costs</a:t>
+                      </a:r>
+                    </a:p>
+                  </a:txBody>
+                  <a:tcPr marL="54864" marR="54864" marT="18288" marB="18288">
+                    <a:solidFill>
+                      <a:srgbClr val="ECF1F6"/>
+                    </a:solidFill>
+                  </a:tcPr>
+                </a:tc>
+                <a:tc>
+                  <a:txBody>
+                    <a:bodyPr wrap="square"/>
+                    <a:lstStyle/>
+                    <a:p>
+                      <a:r>
+                        <a:rPr sz="1100" b="0">
+                          <a:solidFill>
+                            <a:srgbClr val="282828"/>
+                          </a:solidFill>
+                          <a:latin typeface="Arial"/>
+                        </a:rPr>
+                        <a:t>6 traces (3 per arm), 4 fringe frames</a:t>
+                      </a:r>
+                    </a:p>
+                  </a:txBody>
+                  <a:tcPr marL="54864" marR="54864" marT="18288" marB="18288">
+                    <a:solidFill>
+                      <a:srgbClr val="ECF1F6"/>
+                    </a:solidFill>
+                  </a:tcPr>
+                </a:tc>
+                <a:tc>
+                  <a:txBody>
+                    <a:bodyPr wrap="square"/>
+                    <a:lstStyle/>
+                    <a:p>
+                      <a:r>
+                        <a:rPr sz="1100" b="0">
+                          <a:solidFill>
+                            <a:srgbClr val="282828"/>
+                          </a:solidFill>
+                          <a:latin typeface="Arial"/>
+                        </a:rPr>
+                        <a:t>1 or 4 camera frames; 256 calibration frames once per working surface</a:t>
+                      </a:r>
+                    </a:p>
+                  </a:txBody>
+                  <a:tcPr marL="54864" marR="54864" marT="18288" marB="18288">
+                    <a:solidFill>
+                      <a:srgbClr val="ECF1F6"/>
+                    </a:solidFill>
+                  </a:tcPr>
+                </a:tc>
+              </a:tr>
+              <a:tr h="280035">
+                <a:tc>
+                  <a:txBody>
+                    <a:bodyPr wrap="square"/>
+                    <a:lstStyle/>
+                    <a:p>
+                      <a:r>
+                        <a:rPr sz="1100" b="0">
+                          <a:solidFill>
+                            <a:srgbClr val="282828"/>
+                          </a:solidFill>
+                          <a:latin typeface="Arial"/>
+                        </a:rPr>
+                        <a:t>polarization hardware</a:t>
                       </a:r>
                     </a:p>
                   </a:txBody>
@@ -10092,7 +9880,7 @@
                           </a:solidFill>
                           <a:latin typeface="Arial"/>
                         </a:rPr>
-                        <a:t>Ruane, Wallace, Steeves et al. 2020, JATIS 6, 045005</a:t>
+                        <a:t>polarizer, 5 waveplates, analyzer</a:t>
                       </a:r>
                     </a:p>
                   </a:txBody>
@@ -10114,7 +9902,143 @@
                           </a:solidFill>
                           <a:latin typeface="Arial"/>
                         </a:rPr>
-                        <a:t>Exact per-pixel reconstruction from the pupil amplitude, the reference wave b and the masked image; a sensitivity factor per pixel; a four-term systematic budget; 1 pm reached at 4.4×10⁵ frames; no loss to 25 % bandwidth</a:t>
+                        <a:t>none</a:t>
+                      </a:r>
+                    </a:p>
+                  </a:txBody>
+                  <a:tcPr marL="54864" marR="54864" marT="18288" marB="18288">
+                    <a:solidFill>
+                      <a:srgbClr val="FFFFFF"/>
+                    </a:solidFill>
+                  </a:tcPr>
+                </a:tc>
+              </a:tr>
+              <a:tr h="280035">
+                <a:tc>
+                  <a:txBody>
+                    <a:bodyPr wrap="square"/>
+                    <a:lstStyle/>
+                    <a:p>
+                      <a:r>
+                        <a:rPr sz="1100" b="0">
+                          <a:solidFill>
+                            <a:srgbClr val="282828"/>
+                          </a:solidFill>
+                          <a:latin typeface="Arial"/>
+                        </a:rPr>
+                        <a:t>moving parts</a:t>
+                      </a:r>
+                    </a:p>
+                  </a:txBody>
+                  <a:tcPr marL="54864" marR="54864" marT="18288" marB="18288">
+                    <a:solidFill>
+                      <a:srgbClr val="ECF1F6"/>
+                    </a:solidFill>
+                  </a:tcPr>
+                </a:tc>
+                <a:tc>
+                  <a:txBody>
+                    <a:bodyPr wrap="square"/>
+                    <a:lstStyle/>
+                    <a:p>
+                      <a:r>
+                        <a:rPr sz="1100" b="0">
+                          <a:solidFill>
+                            <a:srgbClr val="282828"/>
+                          </a:solidFill>
+                          <a:latin typeface="Arial"/>
+                        </a:rPr>
+                        <a:t>none (polarization-stepped)</a:t>
+                      </a:r>
+                    </a:p>
+                  </a:txBody>
+                  <a:tcPr marL="54864" marR="54864" marT="18288" marB="18288">
+                    <a:solidFill>
+                      <a:srgbClr val="ECF1F6"/>
+                    </a:solidFill>
+                  </a:tcPr>
+                </a:tc>
+                <a:tc>
+                  <a:txBody>
+                    <a:bodyPr wrap="square"/>
+                    <a:lstStyle/>
+                    <a:p>
+                      <a:r>
+                        <a:rPr sz="1100" b="0">
+                          <a:solidFill>
+                            <a:srgbClr val="282828"/>
+                          </a:solidFill>
+                          <a:latin typeface="Arial"/>
+                        </a:rPr>
+                        <a:t>none</a:t>
+                      </a:r>
+                    </a:p>
+                  </a:txBody>
+                  <a:tcPr marL="54864" marR="54864" marT="18288" marB="18288">
+                    <a:solidFill>
+                      <a:srgbClr val="ECF1F6"/>
+                    </a:solidFill>
+                  </a:tcPr>
+                </a:tc>
+              </a:tr>
+              <a:tr h="280035">
+                <a:tc>
+                  <a:txBody>
+                    <a:bodyPr wrap="square"/>
+                    <a:lstStyle/>
+                    <a:p>
+                      <a:r>
+                        <a:rPr sz="1100" b="0">
+                          <a:solidFill>
+                            <a:srgbClr val="282828"/>
+                          </a:solidFill>
+                          <a:latin typeface="Arial"/>
+                        </a:rPr>
+                        <a:t>null, nothing aligned</a:t>
+                      </a:r>
+                    </a:p>
+                  </a:txBody>
+                  <a:tcPr marL="54864" marR="54864" marT="18288" marB="18288">
+                    <a:solidFill>
+                      <a:srgbClr val="FFFFFF"/>
+                    </a:solidFill>
+                  </a:tcPr>
+                </a:tc>
+                <a:tc>
+                  <a:txBody>
+                    <a:bodyPr wrap="square"/>
+                    <a:lstStyle/>
+                    <a:p>
+                      <a:r>
+                        <a:rPr sz="1100" b="0">
+                          <a:solidFill>
+                            <a:srgbClr val="282828"/>
+                          </a:solidFill>
+                          <a:latin typeface="Arial"/>
+                        </a:rPr>
+                        <a:t>0.134 nm</a:t>
+                      </a:r>
+                    </a:p>
+                  </a:txBody>
+                  <a:tcPr marL="54864" marR="54864" marT="18288" marB="18288">
+                    <a:solidFill>
+                      <a:srgbClr val="FFFFFF"/>
+                    </a:solidFill>
+                  </a:tcPr>
+                </a:tc>
+                <a:tc>
+                  <a:txBody>
+                    <a:bodyPr wrap="square"/>
+                    <a:lstStyle/>
+                    <a:p>
+                      <a:r>
+                        <a:rPr sz="1100" b="0">
+                          <a:solidFill>
+                            <a:srgbClr val="282828"/>
+                          </a:solidFill>
+                          <a:latin typeface="Arial"/>
+                        </a:rPr>
+                        <a:t>0 by construction (the flat is the reference)</a:t>
                       </a:r>
                     </a:p>
                   </a:txBody>
@@ -10138,7 +10062,7 @@
                           </a:solidFill>
                           <a:latin typeface="Arial"/>
                         </a:rPr>
-                        <a:t>2</a:t>
+                        <a:t>response falls off at</a:t>
                       </a:r>
                     </a:p>
                   </a:txBody>
@@ -10160,7 +10084,7 @@
                           </a:solidFill>
                           <a:latin typeface="Arial"/>
                         </a:rPr>
-                        <a:t>Doelman, Fagginger Auer, Escuti, Snik 2019, Opt. Lett. 44, 17</a:t>
+                        <a:t>fine patterns: 0.50 at the 96×96 checkerboard</a:t>
                       </a:r>
                     </a:p>
                   </a:txBody>
@@ -10182,13 +10106,81 @@
                           </a:solidFill>
                           <a:latin typeface="Arial"/>
                         </a:rPr>
-                        <a:t>Vector Zernike: ±π/2 on opposite circular polarizations gives two pupil images, an exact phase-and-amplitude solution, an iterated b, achromatic to 100 % bandwidth; the leakage terms are written down</a:t>
+                        <a:t>0.5 to 1 cycle across the pupil (0.5 at 1); piston unseen</a:t>
                       </a:r>
                     </a:p>
                   </a:txBody>
                   <a:tcPr marL="54864" marR="54864" marT="18288" marB="18288">
                     <a:solidFill>
                       <a:srgbClr val="ECF1F6"/>
+                    </a:solidFill>
+                  </a:tcPr>
+                </a:tc>
+              </a:tr>
+              <a:tr h="280035">
+                <a:tc>
+                  <a:txBody>
+                    <a:bodyPr wrap="square"/>
+                    <a:lstStyle/>
+                    <a:p>
+                      <a:r>
+                        <a:rPr sz="1100" b="0">
+                          <a:solidFill>
+                            <a:srgbClr val="282828"/>
+                          </a:solidFill>
+                          <a:latin typeface="Arial"/>
+                        </a:rPr>
+                        <a:t>working surface it can handle</a:t>
+                      </a:r>
+                    </a:p>
+                  </a:txBody>
+                  <a:tcPr marL="54864" marR="54864" marT="18288" marB="18288">
+                    <a:solidFill>
+                      <a:srgbClr val="FFFFFF"/>
+                    </a:solidFill>
+                  </a:tcPr>
+                </a:tc>
+                <a:tc>
+                  <a:txBody>
+                    <a:bodyPr wrap="square"/>
+                    <a:lstStyle/>
+                    <a:p>
+                      <a:r>
+                        <a:rPr sz="1100" b="0">
+                          <a:solidFill>
+                            <a:srgbClr val="282828"/>
+                          </a:solidFill>
+                          <a:latin typeface="Arial"/>
+                        </a:rPr>
+                        <a:t>480 nm rms and beyond</a:t>
+                      </a:r>
+                    </a:p>
+                  </a:txBody>
+                  <a:tcPr marL="54864" marR="54864" marT="18288" marB="18288">
+                    <a:solidFill>
+                      <a:srgbClr val="FFFFFF"/>
+                    </a:solidFill>
+                  </a:tcPr>
+                </a:tc>
+                <a:tc>
+                  <a:txBody>
+                    <a:bodyPr wrap="square"/>
+                    <a:lstStyle/>
+                    <a:p>
+                      <a:r>
+                        <a:rPr sz="1100" b="0">
+                          <a:solidFill>
+                            <a:srgbClr val="282828"/>
+                          </a:solidFill>
+                          <a:latin typeface="Arial"/>
+                        </a:rPr>
+                        <a:t>40 nm rms one-frame (1 mm actuators), 50–60 nm four-frame</a:t>
+                      </a:r>
+                    </a:p>
+                  </a:txBody>
+                  <a:tcPr marL="54864" marR="54864" marT="18288" marB="18288">
+                    <a:solidFill>
+                      <a:srgbClr val="FFFFFF"/>
                     </a:solidFill>
                   </a:tcPr>
                 </a:tc>
@@ -10206,7 +10198,75 @@
                           </a:solidFill>
                           <a:latin typeface="Arial"/>
                         </a:rPr>
-                        <a:t>3</a:t>
+                        <a:t>a 10 nm actuator change on a 30 nm surface</a:t>
+                      </a:r>
+                    </a:p>
+                  </a:txBody>
+                  <a:tcPr marL="54864" marR="54864" marT="18288" marB="18288">
+                    <a:solidFill>
+                      <a:srgbClr val="ECF1F6"/>
+                    </a:solidFill>
+                  </a:tcPr>
+                </a:tc>
+                <a:tc>
+                  <a:txBody>
+                    <a:bodyPr wrap="square"/>
+                    <a:lstStyle/>
+                    <a:p>
+                      <a:r>
+                        <a:rPr sz="1100" b="0">
+                          <a:solidFill>
+                            <a:srgbClr val="282828"/>
+                          </a:solidFill>
+                          <a:latin typeface="Arial"/>
+                        </a:rPr>
+                        <a:t>gain 0.92, floor 46 pm</a:t>
+                      </a:r>
+                    </a:p>
+                  </a:txBody>
+                  <a:tcPr marL="54864" marR="54864" marT="18288" marB="18288">
+                    <a:solidFill>
+                      <a:srgbClr val="ECF1F6"/>
+                    </a:solidFill>
+                  </a:tcPr>
+                </a:tc>
+                <a:tc>
+                  <a:txBody>
+                    <a:bodyPr wrap="square"/>
+                    <a:lstStyle/>
+                    <a:p>
+                      <a:r>
+                        <a:rPr sz="1100" b="0">
+                          <a:solidFill>
+                            <a:srgbClr val="282828"/>
+                          </a:solidFill>
+                          <a:latin typeface="Arial"/>
+                        </a:rPr>
+                        <a:t>gain 0.99, floor 5 pm (stepped, four frames; matrix on the surface) — gain 1.05, floor 23 pm (linear, one frame)</a:t>
+                      </a:r>
+                    </a:p>
+                  </a:txBody>
+                  <a:tcPr marL="54864" marR="54864" marT="18288" marB="18288">
+                    <a:solidFill>
+                      <a:srgbClr val="ECF1F6"/>
+                    </a:solidFill>
+                  </a:tcPr>
+                </a:tc>
+              </a:tr>
+              <a:tr h="280035">
+                <a:tc>
+                  <a:txBody>
+                    <a:bodyPr wrap="square"/>
+                    <a:lstStyle/>
+                    <a:p>
+                      <a:r>
+                        <a:rPr sz="1100" b="0">
+                          <a:solidFill>
+                            <a:srgbClr val="282828"/>
+                          </a:solidFill>
+                          <a:latin typeface="Arial"/>
+                        </a:rPr>
+                        <a:t>photons per measurement for 1 pm</a:t>
                       </a:r>
                     </a:p>
                   </a:txBody>
@@ -10228,7 +10288,7 @@
                           </a:solidFill>
                           <a:latin typeface="Arial"/>
                         </a:rPr>
-                        <a:t>N'Diaye, Vigan, Dohlen et al. 2016, A&amp;A 592, A79 (ZELDA II)</a:t>
+                        <a:t>8×10¹⁴</a:t>
                       </a:r>
                     </a:p>
                   </a:txBody>
@@ -10250,7 +10310,7 @@
                           </a:solidFill>
                           <a:latin typeface="Arial"/>
                         </a:rPr>
-                        <a:t>Second-order reconstruction with b from the mask model; 1.06 λ/D at π/2; range −0.14 to +0.36 λ; the sensitivity factor drifts 10 % day to day on SPHERE</a:t>
+                        <a:t>0.4 to 1×10¹⁴</a:t>
                       </a:r>
                     </a:p>
                   </a:txBody>
@@ -10274,7 +10334,7 @@
                           </a:solidFill>
                           <a:latin typeface="Arial"/>
                         </a:rPr>
-                        <a:t>4</a:t>
+                        <a:t>held in closed loop to 3 pm against a 2 pm random walk: photons per cycle</a:t>
                       </a:r>
                     </a:p>
                   </a:txBody>
@@ -10296,7 +10356,7 @@
                           </a:solidFill>
                           <a:latin typeface="Arial"/>
                         </a:rPr>
-                        <a:t>Chambouleyron, Cissé, Salama, Haffert, Wallace et al. 2024, SPIE 13097</a:t>
+                        <a:t>2.0×10¹³ (lens rig); never with the reflective rig</a:t>
                       </a:r>
                     </a:p>
                   </a:txBody>
@@ -10318,7 +10378,7 @@
                           </a:solidFill>
                           <a:latin typeface="Arial"/>
                         </a:rPr>
-                        <a:t>A phase-shifted pair (±π/2) yields cos φ and sin φ; iterative reconstructors reach about 1 rad rms; the bench limits were polarization crosstalk and defocus between the two pupils</a:t>
+                        <a:t>7.5×10¹² (stepped), 7.3×10¹² (linear), 5.3×10¹² (polarized pair)</a:t>
                       </a:r>
                     </a:p>
                   </a:txBody>
@@ -10342,7 +10402,7 @@
                           </a:solidFill>
                           <a:latin typeface="Arial"/>
                         </a:rPr>
-                        <a:t>5</a:t>
+                        <a:t>fixed error in closed loop (noise-free 1 nm step after 60 cycles)</a:t>
                       </a:r>
                     </a:p>
                   </a:txBody>
@@ -10364,7 +10424,7 @@
                           </a:solidFill>
                           <a:latin typeface="Arial"/>
                         </a:rPr>
-                        <a:t>Haffert 2024, A&amp;A 683, A113</a:t>
+                        <a:t>87 pm and rising (lens); 276 pm (reflective)</a:t>
                       </a:r>
                     </a:p>
                   </a:txBody>
@@ -10386,81 +10446,13 @@
                           </a:solidFill>
                           <a:latin typeface="Arial"/>
                         </a:rPr>
-                        <a:t>Iterative nonlinear reconstructors reach machine precision below 0.25 rad rms; phase sorting extends to 0.75 rad; adding wavelengths to 1.4 rad rms</a:t>
+                        <a:t>0.000 pm (stepped, polarized pair)</a:t>
                       </a:r>
                     </a:p>
                   </a:txBody>
                   <a:tcPr marL="54864" marR="54864" marT="18288" marB="18288">
                     <a:solidFill>
                       <a:srgbClr val="FFFFFF"/>
-                    </a:solidFill>
-                  </a:tcPr>
-                </a:tc>
-              </a:tr>
-              <a:tr h="468630">
-                <a:tc>
-                  <a:txBody>
-                    <a:bodyPr wrap="square"/>
-                    <a:lstStyle/>
-                    <a:p>
-                      <a:r>
-                        <a:rPr sz="1100" b="0">
-                          <a:solidFill>
-                            <a:srgbClr val="282828"/>
-                          </a:solidFill>
-                          <a:latin typeface="Arial"/>
-                        </a:rPr>
-                        <a:t>6</a:t>
-                      </a:r>
-                    </a:p>
-                  </a:txBody>
-                  <a:tcPr marL="54864" marR="54864" marT="18288" marB="18288">
-                    <a:solidFill>
-                      <a:srgbClr val="ECF1F6"/>
-                    </a:solidFill>
-                  </a:tcPr>
-                </a:tc>
-                <a:tc>
-                  <a:txBody>
-                    <a:bodyPr wrap="square"/>
-                    <a:lstStyle/>
-                    <a:p>
-                      <a:r>
-                        <a:rPr sz="1100" b="0">
-                          <a:solidFill>
-                            <a:srgbClr val="282828"/>
-                          </a:solidFill>
-                          <a:latin typeface="Arial"/>
-                        </a:rPr>
-                        <a:t>Darcis, Haffert, Chambouleyron, Doelman et al. 2025, A&amp;A</a:t>
-                      </a:r>
-                    </a:p>
-                  </a:txBody>
-                  <a:tcPr marL="54864" marR="54864" marT="18288" marB="18288">
-                    <a:solidFill>
-                      <a:srgbClr val="ECF1F6"/>
-                    </a:solidFill>
-                  </a:tcPr>
-                </a:tc>
-                <a:tc>
-                  <a:txBody>
-                    <a:bodyPr wrap="square"/>
-                    <a:lstStyle/>
-                    <a:p>
-                      <a:r>
-                        <a:rPr sz="1100" b="0">
-                          <a:solidFill>
-                            <a:srgbClr val="282828"/>
-                          </a:solidFill>
-                          <a:latin typeface="Arial"/>
-                        </a:rPr>
-                        <a:t>Multi-wavelength gradient descent through the forward model: dynamic range for the scalar sensor, photon robustness across a wider band, two-wavelength unwrapping of petal errors</a:t>
-                      </a:r>
-                    </a:p>
-                  </a:txBody>
-                  <a:tcPr marL="54864" marR="54864" marT="18288" marB="18288">
-                    <a:solidFill>
-                      <a:srgbClr val="ECF1F6"/>
                     </a:solidFill>
                   </a:tcPr>
                 </a:tc>
@@ -10477,7 +10469,7 @@
         </p:nvSpPr>
         <p:spPr>
           <a:xfrm>
-            <a:off x="411480" y="4536567"/>
+            <a:off x="411480" y="5748147"/>
             <a:ext cx="11368735" cy="274320"/>
           </a:xfrm>
           <a:prstGeom prst="rect">
@@ -10497,13 +10489,52 @@
               </a:spcAft>
             </a:pPr>
             <a:r>
-              <a:rPr sz="1050" b="0">
-                <a:solidFill>
-                  <a:srgbClr val="6E6E6E"/>
+              <a:rPr sz="1500" b="0">
+                <a:solidFill>
+                  <a:srgbClr val="282828"/>
                 </a:solidFill>
                 <a:latin typeface="Arial"/>
               </a:rPr>
-              <a:t>Priority = payoff against this campaign's measured weak results.  Synopses and links: macos/REPORT_zwfs_lit_scan.md.</a:t>
+              <a:t>•  Reading: the interferometer measures any surface and pays at fine patterns; the sensor measures small changes on a small working surface more cheaply — no polarization train, a floor ten times lower once its response matrix is measured on that surface — and pays at the lowest spatial frequencies and in the surface it can handle.</a:t>
+            </a:r>
+          </a:p>
+        </p:txBody>
+      </p:sp>
+      <p:sp>
+        <p:nvSpPr>
+          <p:cNvPr id="6" name="TextBox 5"/>
+          <p:cNvSpPr txBox="1"/>
+          <p:nvPr/>
+        </p:nvSpPr>
+        <p:spPr>
+          <a:xfrm>
+            <a:off x="411480" y="6667881"/>
+            <a:ext cx="11368735" cy="274320"/>
+          </a:xfrm>
+          <a:prstGeom prst="rect">
+            <a:avLst/>
+          </a:prstGeom>
+          <a:noFill/>
+        </p:spPr>
+        <p:txBody>
+          <a:bodyPr wrap="square">
+            <a:spAutoFit/>
+          </a:bodyPr>
+          <a:lstStyle/>
+          <a:p>
+            <a:pPr>
+              <a:spcAft>
+                <a:spcPts val="600"/>
+              </a:spcAft>
+            </a:pPr>
+            <a:r>
+              <a:rPr sz="1050" b="0">
+                <a:solidFill>
+                  <a:srgbClr val="6E6E6E"/>
+                </a:solidFill>
+                <a:latin typeface="Arial"/>
+              </a:rPr>
+              <a:t>PSI column: tg_psi_dm96 run 10 and S4/S5; sensor column: 385 rays, matrix calibration on the working surface (slide 10), photons at development sampling.  Both in actuator units through the same code (dm_gauge_lib).</a:t>
             </a:r>
           </a:p>
         </p:txBody>
@@ -10850,7 +10881,7 @@
                 </a:solidFill>
                 <a:latin typeface="Arial"/>
               </a:rPr>
-              <a:t>Demonstrations, segmented mirrors, and the in-house precedent</a:t>
+              <a:t>What the Zernike-sensor literature offers, in priority order</a:t>
             </a:r>
           </a:p>
           <a:p>
@@ -10866,7 +10897,7 @@
                 </a:solidFill>
                 <a:latin typeface="Arial"/>
               </a:rPr>
-              <a:t>Picometers by alternating DM shapes and averaging; segment piston by model iteration, underestimated below 50 % Strehl</a:t>
+              <a:t>Twelve papers read; the first import — re-computing the reference wave — is now built and measured (slide 8)</a:t>
             </a:r>
           </a:p>
         </p:txBody>
@@ -10934,9 +10965,9 @@
                 <a:tableStyleId>{5C22544A-7EE6-4342-B048-85BDC9FD1C3A}</a:tableStyleId>
               </a:tblPr>
               <a:tblGrid>
-                <a:gridCol w="291592"/>
-                <a:gridCol w="3730058"/>
-                <a:gridCol w="7347084"/>
+                <a:gridCol w="218948"/>
+                <a:gridCol w="2691327"/>
+                <a:gridCol w="8458459"/>
               </a:tblGrid>
               <a:tr h="280035">
                 <a:tc>
@@ -11019,7 +11050,7 @@
                           </a:solidFill>
                           <a:latin typeface="Arial"/>
                         </a:rPr>
-                        <a:t>7</a:t>
+                        <a:t>1</a:t>
                       </a:r>
                     </a:p>
                   </a:txBody>
@@ -11041,7 +11072,7 @@
                           </a:solidFill>
                           <a:latin typeface="Arial"/>
                         </a:rPr>
-                        <a:t>Steeves, Wallace, Kettenbeil, Jewell 2020, Optica 7, 1267</a:t>
+                        <a:t>Ruane, Wallace, Steeves et al. 2020, JATIS 6, 045005</a:t>
                       </a:r>
                     </a:p>
                   </a:txBody>
@@ -11063,7 +11094,7 @@
                           </a:solidFill>
                           <a:latin typeface="Arial"/>
                         </a:rPr>
-                        <a:t>1.6 pm repeatability in 4.3 s by alternating flat and waffle DM shapes and averaging the differences; a reconstruction robust at the highest spatial frequencies</a:t>
+                        <a:t>Exact per-pixel reconstruction from the pupil amplitude, the reference wave b and the masked image; a sensitivity factor per pixel; a four-term systematic budget; 1 pm reached at 4.4×10⁵ frames; no loss to 25 % bandwidth</a:t>
                       </a:r>
                     </a:p>
                   </a:txBody>
@@ -11087,7 +11118,7 @@
                           </a:solidFill>
                           <a:latin typeface="Arial"/>
                         </a:rPr>
-                        <a:t>8</a:t>
+                        <a:t>2</a:t>
                       </a:r>
                     </a:p>
                   </a:txBody>
@@ -11109,7 +11140,7 @@
                           </a:solidFill>
                           <a:latin typeface="Arial"/>
                         </a:rPr>
-                        <a:t>Wallace, Rao, Jensen-Clem, Serabyn 2011, SPIE 8126</a:t>
+                        <a:t>Doelman, Fagginger Auer, Escuti, Snik 2019, Opt. Lett. 44, 17</a:t>
                       </a:r>
                     </a:p>
                   </a:txBody>
@@ -11131,7 +11162,7 @@
                           </a:solidFill>
                           <a:latin typeface="Arial"/>
                         </a:rPr>
-                        <a:t>All-reflective phase-shifting Zernike interferometer: a dynamic, arbitrary core phase shift read in four steps gives phase and amplitude; low sensitivity to vibration, polarization and wavelength</a:t>
+                        <a:t>Vector Zernike: ±π/2 on opposite circular polarizations gives two pupil images, an exact phase-and-amplitude solution, an iterated b, achromatic to 100 % bandwidth; the leakage terms are written down</a:t>
                       </a:r>
                     </a:p>
                   </a:txBody>
@@ -11155,7 +11186,7 @@
                           </a:solidFill>
                           <a:latin typeface="Arial"/>
                         </a:rPr>
-                        <a:t>9</a:t>
+                        <a:t>3</a:t>
                       </a:r>
                     </a:p>
                   </a:txBody>
@@ -11177,7 +11208,7 @@
                           </a:solidFill>
                           <a:latin typeface="Arial"/>
                         </a:rPr>
-                        <a:t>Moore and Redding 2018, SPIE 10698</a:t>
+                        <a:t>N'Diaye, Vigan, Dohlen et al. 2016, A&amp;A 592, A79 (ZELDA II)</a:t>
                       </a:r>
                     </a:p>
                   </a:txBody>
@@ -11199,7 +11230,7 @@
                           </a:solidFill>
                           <a:latin typeface="Arial"/>
                         </a:rPr>
-                        <a:t>Nonlinear polychromatic physical-optics reconstruction for picometer differential metrology on LUVOIR; the in-house precedent for the reconstructor above</a:t>
+                        <a:t>Second-order reconstruction with b from the mask model; 1.06 λ/D at π/2; range −0.14 to +0.36 λ; the sensitivity factor drifts 10 % day to day on SPHERE</a:t>
                       </a:r>
                     </a:p>
                   </a:txBody>
@@ -11223,7 +11254,7 @@
                           </a:solidFill>
                           <a:latin typeface="Arial"/>
                         </a:rPr>
-                        <a:t>10</a:t>
+                        <a:t>4</a:t>
                       </a:r>
                     </a:p>
                   </a:txBody>
@@ -11245,7 +11276,7 @@
                           </a:solidFill>
                           <a:latin typeface="Arial"/>
                         </a:rPr>
-                        <a:t>Keck vector-Zernike segment control 2024 (arXiv 2404.08728); Wallace et al. 2022 (arXiv 2205.02241)</a:t>
+                        <a:t>Chambouleyron, Cissé, Salama, Haffert, Wallace et al. 2024, SPIE 13097</a:t>
                       </a:r>
                     </a:p>
                   </a:txBody>
@@ -11267,7 +11298,7 @@
                           </a:solidFill>
                           <a:latin typeface="Arial"/>
                         </a:rPr>
-                        <a:t>Segment piston by model-based iteration; 11 nm rms piston uncertainty; underestimation 2 to 4× below 50 % Strehl; fabricated shifts 0.30π and 0.68π instead of ±0.5π</a:t>
+                        <a:t>A phase-shifted pair (±π/2) yields cos φ and sin φ; iterative reconstructors reach about 1 rad rms; the bench limits were polarization crosstalk and defocus between the two pupils</a:t>
                       </a:r>
                     </a:p>
                   </a:txBody>
@@ -11291,7 +11322,7 @@
                           </a:solidFill>
                           <a:latin typeface="Arial"/>
                         </a:rPr>
-                        <a:t>11</a:t>
+                        <a:t>5</a:t>
                       </a:r>
                     </a:p>
                   </a:txBody>
@@ -11313,7 +11344,7 @@
                           </a:solidFill>
                           <a:latin typeface="Arial"/>
                         </a:rPr>
-                        <a:t>HiCAT mid-order Zernike sensor 2024 (arXiv 2409.03411)</a:t>
+                        <a:t>Haffert 2024, A&amp;A 683, A113</a:t>
                       </a:r>
                     </a:p>
                   </a:txBody>
@@ -11335,7 +11366,7 @@
                           </a:solidFill>
                           <a:latin typeface="Arial"/>
                         </a:rPr>
-                        <a:t>Per-segment piston, tip and tilt by interaction matrix; a minimal step of 125 ± 31 pm at SNR 4; 14-bit DM quantization reads as steps in the response</a:t>
+                        <a:t>Iterative nonlinear reconstructors reach machine precision below 0.25 rad rms; phase sorting extends to 0.75 rad; adding wavelengths to 1.4 rad rms</a:t>
                       </a:r>
                     </a:p>
                   </a:txBody>
@@ -11359,7 +11390,7 @@
                           </a:solidFill>
                           <a:latin typeface="Arial"/>
                         </a:rPr>
-                        <a:t>12</a:t>
+                        <a:t>6</a:t>
                       </a:r>
                     </a:p>
                   </a:txBody>
@@ -11381,7 +11412,7 @@
                           </a:solidFill>
                           <a:latin typeface="Arial"/>
                         </a:rPr>
-                        <a:t>Shi et al. 2015, SPIE 9605 (Roman low-order sensor)</a:t>
+                        <a:t>Darcis, Haffert, Chambouleyron, Doelman et al. 2025, A&amp;A</a:t>
                       </a:r>
                     </a:p>
                   </a:txBody>
@@ -11403,7 +11434,7 @@
                           </a:solidFill>
                           <a:latin typeface="Arial"/>
                         </a:rPr>
-                        <a:t>A reflective dimple on the focal-plane mask senses Z2 to Z11 from the rejected starlight: the spatially filtered form of the same sensor</a:t>
+                        <a:t>Multi-wavelength gradient descent through the forward model: dynamic range for the scalar sensor, photon robustness across a wider band, two-wavelength unwrapping of petal errors</a:t>
                       </a:r>
                     </a:p>
                   </a:txBody>
@@ -11452,7 +11483,7 @@
                 </a:solidFill>
                 <a:latin typeface="Arial"/>
               </a:rPr>
-              <a:t>Also read: PIAA-ZWFS (2026, arXiv 2606.28136), lossless pupil apodization that closes the gap to the fundamental sensitivity limit by 10× — a design lever, not a model change.</a:t>
+              <a:t>Priority = payoff against this campaign's measured weak results.  Synopses and links: macos/REPORT_zwfs_lit_scan.md.</a:t>
             </a:r>
           </a:p>
         </p:txBody>
@@ -11509,7 +11540,7 @@
                 </a:solidFill>
                 <a:latin typeface="Arial"/>
               </a:rPr>
-              <a:t>Conclusions: what the corrected model and the exact reading settled</a:t>
+              <a:t>Demonstrations, segmented mirrors, and the in-house precedent</a:t>
             </a:r>
           </a:p>
           <a:p>
@@ -11525,7 +11556,7 @@
                 </a:solidFill>
                 <a:latin typeface="Arial"/>
               </a:rPr>
-              <a:t>Fixing the model was the bigger gain; a response matrix measured on the working surface takes the stepped reading to 5 pm; color and photons are not the limit</a:t>
+              <a:t>Picometers by alternating DM shapes and averaging; segment piston by model iteration, underestimated below 50 % Strehl</a:t>
             </a:r>
           </a:p>
         </p:txBody>
@@ -11574,15 +11605,518 @@
           </a:p>
         </p:txBody>
       </p:sp>
-      <p:sp>
-        <p:nvSpPr>
-          <p:cNvPr id="4" name="TextBox 3"/>
+      <p:graphicFrame>
+        <p:nvGraphicFramePr>
+          <p:cNvPr id="4" name="Table 3"/>
+          <p:cNvGraphicFramePr>
+            <a:graphicFrameLocks noGrp="1"/>
+          </p:cNvGraphicFramePr>
+          <p:nvPr/>
+        </p:nvGraphicFramePr>
+        <p:xfrm>
+          <a:off x="411480" y="1298448"/>
+          <a:ext cx="11368734" cy="3091815"/>
+        </p:xfrm>
+        <a:graphic>
+          <a:graphicData uri="http://schemas.openxmlformats.org/drawingml/2006/table">
+            <a:tbl>
+              <a:tblPr firstRow="1" bandRow="1">
+                <a:tableStyleId>{5C22544A-7EE6-4342-B048-85BDC9FD1C3A}</a:tableStyleId>
+              </a:tblPr>
+              <a:tblGrid>
+                <a:gridCol w="291592"/>
+                <a:gridCol w="3730058"/>
+                <a:gridCol w="7347084"/>
+              </a:tblGrid>
+              <a:tr h="280035">
+                <a:tc>
+                  <a:txBody>
+                    <a:bodyPr wrap="square"/>
+                    <a:lstStyle/>
+                    <a:p>
+                      <a:r>
+                        <a:rPr sz="1100" b="1">
+                          <a:solidFill>
+                            <a:srgbClr val="FFFFFF"/>
+                          </a:solidFill>
+                          <a:latin typeface="Arial"/>
+                        </a:rPr>
+                        <a:t>#</a:t>
+                      </a:r>
+                    </a:p>
+                  </a:txBody>
+                  <a:tcPr marL="54864" marR="54864" marT="18288" marB="18288">
+                    <a:solidFill>
+                      <a:srgbClr val="1F4E79"/>
+                    </a:solidFill>
+                  </a:tcPr>
+                </a:tc>
+                <a:tc>
+                  <a:txBody>
+                    <a:bodyPr wrap="square"/>
+                    <a:lstStyle/>
+                    <a:p>
+                      <a:r>
+                        <a:rPr sz="1100" b="1">
+                          <a:solidFill>
+                            <a:srgbClr val="FFFFFF"/>
+                          </a:solidFill>
+                          <a:latin typeface="Arial"/>
+                        </a:rPr>
+                        <a:t>paper</a:t>
+                      </a:r>
+                    </a:p>
+                  </a:txBody>
+                  <a:tcPr marL="54864" marR="54864" marT="18288" marB="18288">
+                    <a:solidFill>
+                      <a:srgbClr val="1F4E79"/>
+                    </a:solidFill>
+                  </a:tcPr>
+                </a:tc>
+                <a:tc>
+                  <a:txBody>
+                    <a:bodyPr wrap="square"/>
+                    <a:lstStyle/>
+                    <a:p>
+                      <a:r>
+                        <a:rPr sz="1100" b="1">
+                          <a:solidFill>
+                            <a:srgbClr val="FFFFFF"/>
+                          </a:solidFill>
+                          <a:latin typeface="Arial"/>
+                        </a:rPr>
+                        <a:t>what it gives this model</a:t>
+                      </a:r>
+                    </a:p>
+                  </a:txBody>
+                  <a:tcPr marL="54864" marR="54864" marT="18288" marB="18288">
+                    <a:solidFill>
+                      <a:srgbClr val="1F4E79"/>
+                    </a:solidFill>
+                  </a:tcPr>
+                </a:tc>
+              </a:tr>
+              <a:tr h="468630">
+                <a:tc>
+                  <a:txBody>
+                    <a:bodyPr wrap="square"/>
+                    <a:lstStyle/>
+                    <a:p>
+                      <a:r>
+                        <a:rPr sz="1100" b="0">
+                          <a:solidFill>
+                            <a:srgbClr val="282828"/>
+                          </a:solidFill>
+                          <a:latin typeface="Arial"/>
+                        </a:rPr>
+                        <a:t>7</a:t>
+                      </a:r>
+                    </a:p>
+                  </a:txBody>
+                  <a:tcPr marL="54864" marR="54864" marT="18288" marB="18288">
+                    <a:solidFill>
+                      <a:srgbClr val="FFFFFF"/>
+                    </a:solidFill>
+                  </a:tcPr>
+                </a:tc>
+                <a:tc>
+                  <a:txBody>
+                    <a:bodyPr wrap="square"/>
+                    <a:lstStyle/>
+                    <a:p>
+                      <a:r>
+                        <a:rPr sz="1100" b="0">
+                          <a:solidFill>
+                            <a:srgbClr val="282828"/>
+                          </a:solidFill>
+                          <a:latin typeface="Arial"/>
+                        </a:rPr>
+                        <a:t>Steeves, Wallace, Kettenbeil, Jewell 2020, Optica 7, 1267</a:t>
+                      </a:r>
+                    </a:p>
+                  </a:txBody>
+                  <a:tcPr marL="54864" marR="54864" marT="18288" marB="18288">
+                    <a:solidFill>
+                      <a:srgbClr val="FFFFFF"/>
+                    </a:solidFill>
+                  </a:tcPr>
+                </a:tc>
+                <a:tc>
+                  <a:txBody>
+                    <a:bodyPr wrap="square"/>
+                    <a:lstStyle/>
+                    <a:p>
+                      <a:r>
+                        <a:rPr sz="1100" b="0">
+                          <a:solidFill>
+                            <a:srgbClr val="282828"/>
+                          </a:solidFill>
+                          <a:latin typeface="Arial"/>
+                        </a:rPr>
+                        <a:t>1.6 pm repeatability in 4.3 s by alternating flat and waffle DM shapes and averaging the differences; a reconstruction robust at the highest spatial frequencies</a:t>
+                      </a:r>
+                    </a:p>
+                  </a:txBody>
+                  <a:tcPr marL="54864" marR="54864" marT="18288" marB="18288">
+                    <a:solidFill>
+                      <a:srgbClr val="FFFFFF"/>
+                    </a:solidFill>
+                  </a:tcPr>
+                </a:tc>
+              </a:tr>
+              <a:tr h="468630">
+                <a:tc>
+                  <a:txBody>
+                    <a:bodyPr wrap="square"/>
+                    <a:lstStyle/>
+                    <a:p>
+                      <a:r>
+                        <a:rPr sz="1100" b="0">
+                          <a:solidFill>
+                            <a:srgbClr val="282828"/>
+                          </a:solidFill>
+                          <a:latin typeface="Arial"/>
+                        </a:rPr>
+                        <a:t>8</a:t>
+                      </a:r>
+                    </a:p>
+                  </a:txBody>
+                  <a:tcPr marL="54864" marR="54864" marT="18288" marB="18288">
+                    <a:solidFill>
+                      <a:srgbClr val="ECF1F6"/>
+                    </a:solidFill>
+                  </a:tcPr>
+                </a:tc>
+                <a:tc>
+                  <a:txBody>
+                    <a:bodyPr wrap="square"/>
+                    <a:lstStyle/>
+                    <a:p>
+                      <a:r>
+                        <a:rPr sz="1100" b="0">
+                          <a:solidFill>
+                            <a:srgbClr val="282828"/>
+                          </a:solidFill>
+                          <a:latin typeface="Arial"/>
+                        </a:rPr>
+                        <a:t>Wallace, Rao, Jensen-Clem, Serabyn 2011, SPIE 8126</a:t>
+                      </a:r>
+                    </a:p>
+                  </a:txBody>
+                  <a:tcPr marL="54864" marR="54864" marT="18288" marB="18288">
+                    <a:solidFill>
+                      <a:srgbClr val="ECF1F6"/>
+                    </a:solidFill>
+                  </a:tcPr>
+                </a:tc>
+                <a:tc>
+                  <a:txBody>
+                    <a:bodyPr wrap="square"/>
+                    <a:lstStyle/>
+                    <a:p>
+                      <a:r>
+                        <a:rPr sz="1100" b="0">
+                          <a:solidFill>
+                            <a:srgbClr val="282828"/>
+                          </a:solidFill>
+                          <a:latin typeface="Arial"/>
+                        </a:rPr>
+                        <a:t>All-reflective phase-shifting Zernike interferometer: a dynamic, arbitrary core phase shift read in four steps gives phase and amplitude; low sensitivity to vibration, polarization and wavelength</a:t>
+                      </a:r>
+                    </a:p>
+                  </a:txBody>
+                  <a:tcPr marL="54864" marR="54864" marT="18288" marB="18288">
+                    <a:solidFill>
+                      <a:srgbClr val="ECF1F6"/>
+                    </a:solidFill>
+                  </a:tcPr>
+                </a:tc>
+              </a:tr>
+              <a:tr h="468630">
+                <a:tc>
+                  <a:txBody>
+                    <a:bodyPr wrap="square"/>
+                    <a:lstStyle/>
+                    <a:p>
+                      <a:r>
+                        <a:rPr sz="1100" b="0">
+                          <a:solidFill>
+                            <a:srgbClr val="282828"/>
+                          </a:solidFill>
+                          <a:latin typeface="Arial"/>
+                        </a:rPr>
+                        <a:t>9</a:t>
+                      </a:r>
+                    </a:p>
+                  </a:txBody>
+                  <a:tcPr marL="54864" marR="54864" marT="18288" marB="18288">
+                    <a:solidFill>
+                      <a:srgbClr val="FFFFFF"/>
+                    </a:solidFill>
+                  </a:tcPr>
+                </a:tc>
+                <a:tc>
+                  <a:txBody>
+                    <a:bodyPr wrap="square"/>
+                    <a:lstStyle/>
+                    <a:p>
+                      <a:r>
+                        <a:rPr sz="1100" b="0">
+                          <a:solidFill>
+                            <a:srgbClr val="282828"/>
+                          </a:solidFill>
+                          <a:latin typeface="Arial"/>
+                        </a:rPr>
+                        <a:t>Moore and Redding 2018, SPIE 10698</a:t>
+                      </a:r>
+                    </a:p>
+                  </a:txBody>
+                  <a:tcPr marL="54864" marR="54864" marT="18288" marB="18288">
+                    <a:solidFill>
+                      <a:srgbClr val="FFFFFF"/>
+                    </a:solidFill>
+                  </a:tcPr>
+                </a:tc>
+                <a:tc>
+                  <a:txBody>
+                    <a:bodyPr wrap="square"/>
+                    <a:lstStyle/>
+                    <a:p>
+                      <a:r>
+                        <a:rPr sz="1100" b="0">
+                          <a:solidFill>
+                            <a:srgbClr val="282828"/>
+                          </a:solidFill>
+                          <a:latin typeface="Arial"/>
+                        </a:rPr>
+                        <a:t>Nonlinear polychromatic physical-optics reconstruction for picometer differential metrology on LUVOIR; the in-house precedent for the reconstructor above</a:t>
+                      </a:r>
+                    </a:p>
+                  </a:txBody>
+                  <a:tcPr marL="54864" marR="54864" marT="18288" marB="18288">
+                    <a:solidFill>
+                      <a:srgbClr val="FFFFFF"/>
+                    </a:solidFill>
+                  </a:tcPr>
+                </a:tc>
+              </a:tr>
+              <a:tr h="468630">
+                <a:tc>
+                  <a:txBody>
+                    <a:bodyPr wrap="square"/>
+                    <a:lstStyle/>
+                    <a:p>
+                      <a:r>
+                        <a:rPr sz="1100" b="0">
+                          <a:solidFill>
+                            <a:srgbClr val="282828"/>
+                          </a:solidFill>
+                          <a:latin typeface="Arial"/>
+                        </a:rPr>
+                        <a:t>10</a:t>
+                      </a:r>
+                    </a:p>
+                  </a:txBody>
+                  <a:tcPr marL="54864" marR="54864" marT="18288" marB="18288">
+                    <a:solidFill>
+                      <a:srgbClr val="ECF1F6"/>
+                    </a:solidFill>
+                  </a:tcPr>
+                </a:tc>
+                <a:tc>
+                  <a:txBody>
+                    <a:bodyPr wrap="square"/>
+                    <a:lstStyle/>
+                    <a:p>
+                      <a:r>
+                        <a:rPr sz="1100" b="0">
+                          <a:solidFill>
+                            <a:srgbClr val="282828"/>
+                          </a:solidFill>
+                          <a:latin typeface="Arial"/>
+                        </a:rPr>
+                        <a:t>Keck vector-Zernike segment control 2024 (arXiv 2404.08728); Wallace et al. 2022 (arXiv 2205.02241)</a:t>
+                      </a:r>
+                    </a:p>
+                  </a:txBody>
+                  <a:tcPr marL="54864" marR="54864" marT="18288" marB="18288">
+                    <a:solidFill>
+                      <a:srgbClr val="ECF1F6"/>
+                    </a:solidFill>
+                  </a:tcPr>
+                </a:tc>
+                <a:tc>
+                  <a:txBody>
+                    <a:bodyPr wrap="square"/>
+                    <a:lstStyle/>
+                    <a:p>
+                      <a:r>
+                        <a:rPr sz="1100" b="0">
+                          <a:solidFill>
+                            <a:srgbClr val="282828"/>
+                          </a:solidFill>
+                          <a:latin typeface="Arial"/>
+                        </a:rPr>
+                        <a:t>Segment piston by model-based iteration; 11 nm rms piston uncertainty; underestimation 2 to 4× below 50 % Strehl; fabricated shifts 0.30π and 0.68π instead of ±0.5π</a:t>
+                      </a:r>
+                    </a:p>
+                  </a:txBody>
+                  <a:tcPr marL="54864" marR="54864" marT="18288" marB="18288">
+                    <a:solidFill>
+                      <a:srgbClr val="ECF1F6"/>
+                    </a:solidFill>
+                  </a:tcPr>
+                </a:tc>
+              </a:tr>
+              <a:tr h="468630">
+                <a:tc>
+                  <a:txBody>
+                    <a:bodyPr wrap="square"/>
+                    <a:lstStyle/>
+                    <a:p>
+                      <a:r>
+                        <a:rPr sz="1100" b="0">
+                          <a:solidFill>
+                            <a:srgbClr val="282828"/>
+                          </a:solidFill>
+                          <a:latin typeface="Arial"/>
+                        </a:rPr>
+                        <a:t>11</a:t>
+                      </a:r>
+                    </a:p>
+                  </a:txBody>
+                  <a:tcPr marL="54864" marR="54864" marT="18288" marB="18288">
+                    <a:solidFill>
+                      <a:srgbClr val="FFFFFF"/>
+                    </a:solidFill>
+                  </a:tcPr>
+                </a:tc>
+                <a:tc>
+                  <a:txBody>
+                    <a:bodyPr wrap="square"/>
+                    <a:lstStyle/>
+                    <a:p>
+                      <a:r>
+                        <a:rPr sz="1100" b="0">
+                          <a:solidFill>
+                            <a:srgbClr val="282828"/>
+                          </a:solidFill>
+                          <a:latin typeface="Arial"/>
+                        </a:rPr>
+                        <a:t>HiCAT mid-order Zernike sensor 2024 (arXiv 2409.03411)</a:t>
+                      </a:r>
+                    </a:p>
+                  </a:txBody>
+                  <a:tcPr marL="54864" marR="54864" marT="18288" marB="18288">
+                    <a:solidFill>
+                      <a:srgbClr val="FFFFFF"/>
+                    </a:solidFill>
+                  </a:tcPr>
+                </a:tc>
+                <a:tc>
+                  <a:txBody>
+                    <a:bodyPr wrap="square"/>
+                    <a:lstStyle/>
+                    <a:p>
+                      <a:r>
+                        <a:rPr sz="1100" b="0">
+                          <a:solidFill>
+                            <a:srgbClr val="282828"/>
+                          </a:solidFill>
+                          <a:latin typeface="Arial"/>
+                        </a:rPr>
+                        <a:t>Per-segment piston, tip and tilt by interaction matrix; a minimal step of 125 ± 31 pm at SNR 4; 14-bit DM quantization reads as steps in the response</a:t>
+                      </a:r>
+                    </a:p>
+                  </a:txBody>
+                  <a:tcPr marL="54864" marR="54864" marT="18288" marB="18288">
+                    <a:solidFill>
+                      <a:srgbClr val="FFFFFF"/>
+                    </a:solidFill>
+                  </a:tcPr>
+                </a:tc>
+              </a:tr>
+              <a:tr h="468630">
+                <a:tc>
+                  <a:txBody>
+                    <a:bodyPr wrap="square"/>
+                    <a:lstStyle/>
+                    <a:p>
+                      <a:r>
+                        <a:rPr sz="1100" b="0">
+                          <a:solidFill>
+                            <a:srgbClr val="282828"/>
+                          </a:solidFill>
+                          <a:latin typeface="Arial"/>
+                        </a:rPr>
+                        <a:t>12</a:t>
+                      </a:r>
+                    </a:p>
+                  </a:txBody>
+                  <a:tcPr marL="54864" marR="54864" marT="18288" marB="18288">
+                    <a:solidFill>
+                      <a:srgbClr val="ECF1F6"/>
+                    </a:solidFill>
+                  </a:tcPr>
+                </a:tc>
+                <a:tc>
+                  <a:txBody>
+                    <a:bodyPr wrap="square"/>
+                    <a:lstStyle/>
+                    <a:p>
+                      <a:r>
+                        <a:rPr sz="1100" b="0">
+                          <a:solidFill>
+                            <a:srgbClr val="282828"/>
+                          </a:solidFill>
+                          <a:latin typeface="Arial"/>
+                        </a:rPr>
+                        <a:t>Shi et al. 2015, SPIE 9605 (Roman low-order sensor)</a:t>
+                      </a:r>
+                    </a:p>
+                  </a:txBody>
+                  <a:tcPr marL="54864" marR="54864" marT="18288" marB="18288">
+                    <a:solidFill>
+                      <a:srgbClr val="ECF1F6"/>
+                    </a:solidFill>
+                  </a:tcPr>
+                </a:tc>
+                <a:tc>
+                  <a:txBody>
+                    <a:bodyPr wrap="square"/>
+                    <a:lstStyle/>
+                    <a:p>
+                      <a:r>
+                        <a:rPr sz="1100" b="0">
+                          <a:solidFill>
+                            <a:srgbClr val="282828"/>
+                          </a:solidFill>
+                          <a:latin typeface="Arial"/>
+                        </a:rPr>
+                        <a:t>A reflective dimple on the focal-plane mask senses Z2 to Z11 from the rejected starlight: the spatially filtered form of the same sensor</a:t>
+                      </a:r>
+                    </a:p>
+                  </a:txBody>
+                  <a:tcPr marL="54864" marR="54864" marT="18288" marB="18288">
+                    <a:solidFill>
+                      <a:srgbClr val="ECF1F6"/>
+                    </a:solidFill>
+                  </a:tcPr>
+                </a:tc>
+              </a:tr>
+            </a:tbl>
+          </a:graphicData>
+        </a:graphic>
+      </p:graphicFrame>
+      <p:sp>
+        <p:nvSpPr>
+          <p:cNvPr id="5" name="TextBox 4"/>
           <p:cNvSpPr txBox="1"/>
           <p:nvPr/>
         </p:nvSpPr>
         <p:spPr>
           <a:xfrm>
-            <a:off x="411480" y="1298448"/>
+            <a:off x="411480" y="4536567"/>
             <a:ext cx="11368735" cy="274320"/>
           </a:xfrm>
           <a:prstGeom prst="rect">
@@ -11602,148 +12136,13 @@
               </a:spcAft>
             </a:pPr>
             <a:r>
-              <a:rPr sz="1500" b="0">
-                <a:solidFill>
-                  <a:srgbClr val="282828"/>
+              <a:rPr sz="1050" b="0">
+                <a:solidFill>
+                  <a:srgbClr val="6E6E6E"/>
                 </a:solidFill>
                 <a:latin typeface="Arial"/>
               </a:rPr>
-              <a:t>•  The model must keep the pupil image in focus: the two spheres around the mask share one radius, and the script checks the no-mask round trip on every run.  The correction alone took the single-actuator floor from 744 to 67 pm and made the undetected grid case detectable.</a:t>
-            </a:r>
-          </a:p>
-          <a:p>
-            <a:pPr>
-              <a:spcAft>
-                <a:spcPts val="600"/>
-              </a:spcAft>
-            </a:pPr>
-            <a:r>
-              <a:rPr sz="1500" b="0">
-                <a:solidFill>
-                  <a:srgbClr val="282828"/>
-                </a:solidFill>
-                <a:latin typeface="Arial"/>
-              </a:rPr>
-              <a:t>•  The exact reading with a re-computed reference is the import that paid (paper 1): 26 pm from one frame on a 30 nm working surface, SNR 355 — with the sign fold settled once from four stepped frames and refined.  The plain stepped sign map misses 3% of pixels and can flip a single actuator's sign.</a:t>
-            </a:r>
-          </a:p>
-          <a:p>
-            <a:pPr>
-              <a:spcAft>
-                <a:spcPts val="600"/>
-              </a:spcAft>
-            </a:pPr>
-            <a:r>
-              <a:rPr sz="1500" b="0">
-                <a:solidFill>
-                  <a:srgbClr val="282828"/>
-                </a:solidFill>
-                <a:latin typeface="Arial"/>
-              </a:rPr>
-              <a:t>•  Calibrate with a measured response matrix, on the working surface: the sparse-grid measurement of every actuator's response (with the sensor's piston null carried) reads a single actuator on the flat at 0.994 with a 4 pm floor; measured on the working surface it gives the stepped reading 0.99 and 5 pm there and makes the linear one-frame reading usable (1.05, 23 pm).  The floors fall ten times; what remains is gain stability as the surface drifts (7% over 20 nm rms) and the one-frame exact readings' sign fold.</a:t>
-            </a:r>
-          </a:p>
-          <a:p>
-            <a:pPr>
-              <a:spcAft>
-                <a:spcPts val="600"/>
-              </a:spcAft>
-            </a:pPr>
-            <a:r>
-              <a:rPr sz="1500" b="0">
-                <a:solidFill>
-                  <a:srgbClr val="282828"/>
-                </a:solidFill>
-                <a:latin typeface="Arial"/>
-              </a:rPr>
-              <a:t>•  Sampling is settled, and a bias in the fit is fixed: camera pixels per actuator (the ray count) set the gain on a test actuator; sampling the single-site response pattern at the actuator center took that gain to 0.996 at 5 pixels per actuator.</a:t>
-            </a:r>
-          </a:p>
-          <a:p>
-            <a:pPr>
-              <a:spcAft>
-                <a:spcPts val="600"/>
-              </a:spcAft>
-            </a:pPr>
-            <a:r>
-              <a:rPr sz="1500" b="0">
-                <a:solidFill>
-                  <a:srgbClr val="282828"/>
-                </a:solidFill>
-                <a:latin typeface="Arial"/>
-              </a:rPr>
-              <a:t>•  Color and photons are not levers: the chromatic null was the defocus; 10¹⁴ photons per measurement reach 1 pm.  The budget is systematic error: the 25 to 60 pm floors and the gain's stability.</a:t>
-            </a:r>
-          </a:p>
-          <a:p>
-            <a:pPr>
-              <a:spcAft>
-                <a:spcPts val="600"/>
-              </a:spcAft>
-            </a:pPr>
-            <a:r>
-              <a:rPr sz="1500" b="0">
-                <a:solidFill>
-                  <a:srgbClr val="282828"/>
-                </a:solidFill>
-                <a:latin typeface="Arial"/>
-              </a:rPr>
-              <a:t>•  In closed loop the stepped reading has no fixed error: it holds a 2 pm-per-cycle walk to 3 pm from 7.5×10¹² photons per cycle and returns to zero after a step; the linear reading costs the same light but leaves a fine-scale error under a slow ramp; the one-frame exact reading runs away.</a:t>
-            </a:r>
-          </a:p>
-          <a:p>
-            <a:pPr>
-              <a:spcAft>
-                <a:spcPts val="600"/>
-              </a:spcAft>
-            </a:pPr>
-            <a:r>
-              <a:rPr sz="1500" b="0">
-                <a:solidFill>
-                  <a:srgbClr val="282828"/>
-                </a:solidFill>
-                <a:latin typeface="Arial"/>
-              </a:rPr>
-              <a:t>•  The polarized dimple is the best reading on every line: two simultaneous frames, no fold, 3 pm held from 5.3×10¹² photons per cycle, and a calibration that stays within 2% out to 60 nm rms.</a:t>
-            </a:r>
-          </a:p>
-        </p:txBody>
-      </p:sp>
-      <p:sp>
-        <p:nvSpPr>
-          <p:cNvPr id="5" name="TextBox 4"/>
-          <p:cNvSpPr txBox="1"/>
-          <p:nvPr/>
-        </p:nvSpPr>
-        <p:spPr>
-          <a:xfrm>
-            <a:off x="411480" y="7517130"/>
-            <a:ext cx="11368735" cy="274320"/>
-          </a:xfrm>
-          <a:prstGeom prst="rect">
-            <a:avLst/>
-          </a:prstGeom>
-          <a:noFill/>
-        </p:spPr>
-        <p:txBody>
-          <a:bodyPr wrap="square">
-            <a:spAutoFit/>
-          </a:bodyPr>
-          <a:lstStyle/>
-          <a:p>
-            <a:pPr>
-              <a:spcAft>
-                <a:spcPts val="600"/>
-              </a:spcAft>
-            </a:pPr>
-            <a:r>
-              <a:rPr sz="1050" b="0">
-                <a:solidFill>
-                  <a:srgbClr val="6E6E6E"/>
-                </a:solidFill>
-                <a:latin typeface="Arial"/>
-              </a:rPr>
-              <a:t>Script and records: templates/40_benches/zwfs_dm96 (README S7/S8; runs/rec193, ng385, ng385s3, m2048, rec193full).</a:t>
+              <a:t>Also read: PIAA-ZWFS (2026, arXiv 2606.28136), lossless pupil apodization that closes the gap to the fundamental sensitivity limit by 10× — a design lever, not a model change.</a:t>
             </a:r>
           </a:p>
         </p:txBody>
@@ -11800,7 +12199,7 @@
                 </a:solidFill>
                 <a:latin typeface="Arial"/>
               </a:rPr>
-              <a:t>Conclusions: what to import next, in order</a:t>
+              <a:t>Conclusions: what the corrected model and the exact reading settled</a:t>
             </a:r>
           </a:p>
           <a:p>
@@ -11816,7 +12215,7 @@
                 </a:solidFill>
                 <a:latin typeface="Arial"/>
               </a:rPr>
-              <a:t>The JPL budget form, DM calibration through the sensor's own images, the vector sensor priced before it is built, and the interferometer's lever</a:t>
+              <a:t>Fixing the model was the bigger gain; a response matrix measured on the working surface takes the stepped reading to 5 pm; color and photons are not the limit</a:t>
             </a:r>
           </a:p>
         </p:txBody>
@@ -11899,7 +12298,7 @@
                 </a:solidFill>
                 <a:latin typeface="Arial"/>
               </a:rPr>
-              <a:t>•  The JPL budget form: a sensitivity factor per pixel from the measured fields — the quantity the working-surface effect on slide 10 is made of — predicts the photon-noise stage analytically, and four systematic terms (pupil calibration at ½, reference wave at 1, dimple depth, initial phase) become the rows of the error budget.</a:t>
+              <a:t>•  The model must keep the pupil image in focus: the two spheres around the mask share one radius, and the script checks the no-mask round trip on every run.  The correction alone took the single-actuator floor from 744 to 67 pm and made the undetected grid case detectable.</a:t>
             </a:r>
           </a:p>
           <a:p>
@@ -11915,7 +12314,7 @@
                 </a:solidFill>
                 <a:latin typeface="Arial"/>
               </a:rPr>
-              <a:t>•  The response matrix for the interferometer too: its calibration still uses a single-site response pattern, with the stencil bias fixed here (slide 9); the sparse-grid measured matrix is the calibration its reflective build should carry.  Model-matched DM calibration (actuator positions and gains through the sensor's own images) remains the lever for a real DM's geometry.</a:t>
+              <a:t>•  The exact reading with a re-computed reference is the import that paid (paper 1): 26 pm from one frame on a 30 nm working surface, SNR 355 — with the sign fold settled once from four stepped frames and refined.  The plain stepped sign map misses 3% of pixels and can flip a single actuator's sign.</a:t>
             </a:r>
           </a:p>
           <a:p>
@@ -11931,7 +12330,7 @@
                 </a:solidFill>
                 <a:latin typeface="Arial"/>
               </a:rPr>
-              <a:t>•  Color as a joint fit, not a combination: an equal-weight combination inherits a bad channel; a joint fit through the exact reading would use 700 to 780 nm for range and 632.8 nm for the calibration of record.</a:t>
+              <a:t>•  Calibrate with a measured response matrix, on the working surface: the sparse-grid measurement of every actuator's response (with the sensor's piston null carried) reads a single actuator on the flat at 0.994 with a 4 pm floor; measured on the working surface it gives the stepped reading 0.99 and 5 pm there and makes the linear one-frame reading usable (1.05, 23 pm).  The floors fall ten times; what remains is gain stability as the surface drifts (7% over 20 nm rms) and the one-frame exact readings' sign fold.</a:t>
             </a:r>
           </a:p>
           <a:p>
@@ -11947,7 +12346,7 @@
                 </a:solidFill>
                 <a:latin typeface="Arial"/>
               </a:rPr>
-              <a:t>•  Model the vector sensor before the metasurface is built: the exact two-image solution and its leakage terms (retardance offsets, splitter rotation) run on the engine's polarization machinery; the bench limits at Keck and SEAL were defocus and crosstalk between the two pupil images, both priceable here.</a:t>
+              <a:t>•  Sampling is settled, and a bias in the fit is fixed: camera pixels per actuator (the ray count) set the gain on a test actuator; sampling the single-site response pattern at the actuator center took that gain to 0.996 at 5 pixels per actuator.</a:t>
             </a:r>
           </a:p>
           <a:p>
@@ -11963,7 +12362,39 @@
                 </a:solidFill>
                 <a:latin typeface="Arial"/>
               </a:rPr>
-              <a:t>•  The interferometer, for balance: a PZT phase shift buys no model gain — its floors are geometric and color-independent — but on hardware an absolute phase scale and freedom from polarization systematics; the recommended form is a hybrid: polarization snapshot for the change measurements, a PZT on the reference flat as calibrator.  Its all-mirror (OAP) version is in build.</a:t>
+              <a:t>•  Color and photons are not levers: the chromatic null was the defocus; 10¹⁴ photons per measurement reach 1 pm.  The budget is systematic error: the 25 to 60 pm floors and the gain's stability.</a:t>
+            </a:r>
+          </a:p>
+          <a:p>
+            <a:pPr>
+              <a:spcAft>
+                <a:spcPts val="600"/>
+              </a:spcAft>
+            </a:pPr>
+            <a:r>
+              <a:rPr sz="1500" b="0">
+                <a:solidFill>
+                  <a:srgbClr val="282828"/>
+                </a:solidFill>
+                <a:latin typeface="Arial"/>
+              </a:rPr>
+              <a:t>•  In closed loop the stepped reading has no fixed error: it holds a 2 pm-per-cycle walk to 3 pm from 7.5×10¹² photons per cycle and returns to zero after a step; the linear reading costs the same light but leaves a fine-scale error under a slow ramp; the one-frame exact reading runs away.</a:t>
+            </a:r>
+          </a:p>
+          <a:p>
+            <a:pPr>
+              <a:spcAft>
+                <a:spcPts val="600"/>
+              </a:spcAft>
+            </a:pPr>
+            <a:r>
+              <a:rPr sz="1500" b="0">
+                <a:solidFill>
+                  <a:srgbClr val="282828"/>
+                </a:solidFill>
+                <a:latin typeface="Arial"/>
+              </a:rPr>
+              <a:t>•  The polarized dimple is the best reading on every line: two simultaneous frames, no fold, 3 pm held from 5.3×10¹² photons per cycle, and a calibration that stays within 2% out to 60 nm rms.</a:t>
             </a:r>
           </a:p>
         </p:txBody>
@@ -11976,7 +12407,7 @@
         </p:nvSpPr>
         <p:spPr>
           <a:xfrm>
-            <a:off x="411480" y="5998464"/>
+            <a:off x="411480" y="7517130"/>
             <a:ext cx="11368735" cy="274320"/>
           </a:xfrm>
           <a:prstGeom prst="rect">
@@ -12002,7 +12433,7 @@
                 </a:solidFill>
                 <a:latin typeface="Arial"/>
               </a:rPr>
-              <a:t>Segmented-mirror lessons carried forward: the sensor reads segment piston but not global piston, DM quantization appears as steps in the response, and piston is underestimated below 50 % Strehl (Keck) — all three enter the e5-class segmented gauges.</a:t>
+              <a:t>Script and records: templates/40_benches/zwfs_dm96 (README S7/S8; runs/rec193, ng385, ng385s3, m2048, rec193full).</a:t>
             </a:r>
           </a:p>
         </p:txBody>
@@ -12033,63 +12464,6 @@
         </p:nvSpPr>
         <p:spPr>
           <a:xfrm>
-            <a:off x="822960" y="2743200"/>
-            <a:ext cx="10545775" cy="1280160"/>
-          </a:xfrm>
-          <a:prstGeom prst="rect">
-            <a:avLst/>
-          </a:prstGeom>
-          <a:noFill/>
-        </p:spPr>
-        <p:txBody>
-          <a:bodyPr wrap="square">
-            <a:spAutoFit/>
-          </a:bodyPr>
-          <a:lstStyle/>
-          <a:p>
-            <a:pPr algn="ctr">
-              <a:spcAft>
-                <a:spcPts val="400"/>
-              </a:spcAft>
-            </a:pPr>
-            <a:r>
-              <a:rPr sz="4000" b="1">
-                <a:solidFill>
-                  <a:srgbClr val="1F4E79"/>
-                </a:solidFill>
-                <a:latin typeface="Arial"/>
-              </a:rPr>
-              <a:t>Backup</a:t>
-            </a:r>
-          </a:p>
-        </p:txBody>
-      </p:sp>
-    </p:spTree>
-  </p:cSld>
-  <p:clrMapOvr>
-    <a:masterClrMapping/>
-  </p:clrMapOvr>
-</p:sld>
-</file>
-
-<file path=ppt/slides/slide24.xml><?xml version="1.0" encoding="utf-8"?>
-<p:sld xmlns:a="http://schemas.openxmlformats.org/drawingml/2006/main" xmlns:p="http://schemas.openxmlformats.org/presentationml/2006/main" xmlns:r="http://schemas.openxmlformats.org/officeDocument/2006/relationships">
-  <p:cSld>
-    <p:spTree>
-      <p:nvGrpSpPr>
-        <p:cNvPr id="1" name=""/>
-        <p:cNvGrpSpPr/>
-        <p:nvPr/>
-      </p:nvGrpSpPr>
-      <p:grpSpPr/>
-      <p:sp>
-        <p:nvSpPr>
-          <p:cNvPr id="2" name="TextBox 1"/>
-          <p:cNvSpPr txBox="1"/>
-          <p:nvPr/>
-        </p:nvSpPr>
-        <p:spPr>
-          <a:xfrm>
             <a:off x="411480" y="201168"/>
             <a:ext cx="11368735" cy="914400"/>
           </a:xfrm>
@@ -12116,7 +12490,7 @@
                 </a:solidFill>
                 <a:latin typeface="Arial"/>
               </a:rPr>
-              <a:t>Before the correction: the first poke and color results</a:t>
+              <a:t>Conclusions: what to import next, in order</a:t>
             </a:r>
           </a:p>
           <a:p>
@@ -12132,7 +12506,7 @@
                 </a:solidFill>
                 <a:latin typeface="Arial"/>
               </a:rPr>
-              <a:t>Kept for the record; every number on this slide is from the out-of-focus model</a:t>
+              <a:t>The JPL budget form, DM calibration through the sensor's own images, the vector sensor priced before it is built, and the interferometer's lever</a:t>
             </a:r>
           </a:p>
         </p:txBody>
@@ -12181,6 +12555,322 @@
           </a:p>
         </p:txBody>
       </p:sp>
+      <p:sp>
+        <p:nvSpPr>
+          <p:cNvPr id="4" name="TextBox 3"/>
+          <p:cNvSpPr txBox="1"/>
+          <p:nvPr/>
+        </p:nvSpPr>
+        <p:spPr>
+          <a:xfrm>
+            <a:off x="411480" y="1298448"/>
+            <a:ext cx="11368735" cy="274320"/>
+          </a:xfrm>
+          <a:prstGeom prst="rect">
+            <a:avLst/>
+          </a:prstGeom>
+          <a:noFill/>
+        </p:spPr>
+        <p:txBody>
+          <a:bodyPr wrap="square">
+            <a:spAutoFit/>
+          </a:bodyPr>
+          <a:lstStyle/>
+          <a:p>
+            <a:pPr>
+              <a:spcAft>
+                <a:spcPts val="600"/>
+              </a:spcAft>
+            </a:pPr>
+            <a:r>
+              <a:rPr sz="1500" b="0">
+                <a:solidFill>
+                  <a:srgbClr val="282828"/>
+                </a:solidFill>
+                <a:latin typeface="Arial"/>
+              </a:rPr>
+              <a:t>•  The JPL budget form: a sensitivity factor per pixel from the measured fields — the quantity the working-surface effect on slide 10 is made of — predicts the photon-noise stage analytically, and four systematic terms (pupil calibration at ½, reference wave at 1, dimple depth, initial phase) become the rows of the error budget.</a:t>
+            </a:r>
+          </a:p>
+          <a:p>
+            <a:pPr>
+              <a:spcAft>
+                <a:spcPts val="600"/>
+              </a:spcAft>
+            </a:pPr>
+            <a:r>
+              <a:rPr sz="1500" b="0">
+                <a:solidFill>
+                  <a:srgbClr val="282828"/>
+                </a:solidFill>
+                <a:latin typeface="Arial"/>
+              </a:rPr>
+              <a:t>•  The response matrix for the interferometer too: its calibration still uses a single-site response pattern, with the stencil bias fixed here (slide 9); the sparse-grid measured matrix is the calibration its reflective build should carry.  Model-matched DM calibration (actuator positions and gains through the sensor's own images) remains the lever for a real DM's geometry.</a:t>
+            </a:r>
+          </a:p>
+          <a:p>
+            <a:pPr>
+              <a:spcAft>
+                <a:spcPts val="600"/>
+              </a:spcAft>
+            </a:pPr>
+            <a:r>
+              <a:rPr sz="1500" b="0">
+                <a:solidFill>
+                  <a:srgbClr val="282828"/>
+                </a:solidFill>
+                <a:latin typeface="Arial"/>
+              </a:rPr>
+              <a:t>•  Color as a joint fit, not a combination: an equal-weight combination inherits a bad channel; a joint fit through the exact reading would use 700 to 780 nm for range and 632.8 nm for the calibration of record.</a:t>
+            </a:r>
+          </a:p>
+          <a:p>
+            <a:pPr>
+              <a:spcAft>
+                <a:spcPts val="600"/>
+              </a:spcAft>
+            </a:pPr>
+            <a:r>
+              <a:rPr sz="1500" b="0">
+                <a:solidFill>
+                  <a:srgbClr val="282828"/>
+                </a:solidFill>
+                <a:latin typeface="Arial"/>
+              </a:rPr>
+              <a:t>•  The vector sensor, priced before the metasurface is built: the exact two-image solution stands (slide 15); its metasurface retardance error and the arm's polarization aberration are priced (slide 16) and neither reaches the working-surface rows; still to price: the splitter's crosstalk between the two pupil images and defocus between them, the bench limits at Keck and SEAL.</a:t>
+            </a:r>
+          </a:p>
+          <a:p>
+            <a:pPr>
+              <a:spcAft>
+                <a:spcPts val="600"/>
+              </a:spcAft>
+            </a:pPr>
+            <a:r>
+              <a:rPr sz="1500" b="0">
+                <a:solidFill>
+                  <a:srgbClr val="282828"/>
+                </a:solidFill>
+                <a:latin typeface="Arial"/>
+              </a:rPr>
+              <a:t>•  The interferometer, for balance: a PZT phase shift buys no model gain — its floors are geometric and color-independent — but on hardware an absolute phase scale and freedom from polarization systematics; the recommended form is a hybrid: polarization snapshot for the change measurements, a PZT on the reference flat as calibrator.  Its all-mirror (OAP) version is in build.</a:t>
+            </a:r>
+          </a:p>
+        </p:txBody>
+      </p:sp>
+      <p:sp>
+        <p:nvSpPr>
+          <p:cNvPr id="5" name="TextBox 4"/>
+          <p:cNvSpPr txBox="1"/>
+          <p:nvPr/>
+        </p:nvSpPr>
+        <p:spPr>
+          <a:xfrm>
+            <a:off x="411480" y="6246113"/>
+            <a:ext cx="11368735" cy="274320"/>
+          </a:xfrm>
+          <a:prstGeom prst="rect">
+            <a:avLst/>
+          </a:prstGeom>
+          <a:noFill/>
+        </p:spPr>
+        <p:txBody>
+          <a:bodyPr wrap="square">
+            <a:spAutoFit/>
+          </a:bodyPr>
+          <a:lstStyle/>
+          <a:p>
+            <a:pPr>
+              <a:spcAft>
+                <a:spcPts val="600"/>
+              </a:spcAft>
+            </a:pPr>
+            <a:r>
+              <a:rPr sz="1050" b="0">
+                <a:solidFill>
+                  <a:srgbClr val="6E6E6E"/>
+                </a:solidFill>
+                <a:latin typeface="Arial"/>
+              </a:rPr>
+              <a:t>Segmented-mirror lessons carried forward: the sensor reads segment piston but not global piston, DM quantization appears as steps in the response, and piston is underestimated below 50 % Strehl (Keck) — all three enter the e5-class segmented gauges.</a:t>
+            </a:r>
+          </a:p>
+        </p:txBody>
+      </p:sp>
+    </p:spTree>
+  </p:cSld>
+  <p:clrMapOvr>
+    <a:masterClrMapping/>
+  </p:clrMapOvr>
+</p:sld>
+</file>
+
+<file path=ppt/slides/slide24.xml><?xml version="1.0" encoding="utf-8"?>
+<p:sld xmlns:a="http://schemas.openxmlformats.org/drawingml/2006/main" xmlns:p="http://schemas.openxmlformats.org/presentationml/2006/main" xmlns:r="http://schemas.openxmlformats.org/officeDocument/2006/relationships">
+  <p:cSld>
+    <p:spTree>
+      <p:nvGrpSpPr>
+        <p:cNvPr id="1" name=""/>
+        <p:cNvGrpSpPr/>
+        <p:nvPr/>
+      </p:nvGrpSpPr>
+      <p:grpSpPr/>
+      <p:sp>
+        <p:nvSpPr>
+          <p:cNvPr id="2" name="TextBox 1"/>
+          <p:cNvSpPr txBox="1"/>
+          <p:nvPr/>
+        </p:nvSpPr>
+        <p:spPr>
+          <a:xfrm>
+            <a:off x="822960" y="2743200"/>
+            <a:ext cx="10545775" cy="1280160"/>
+          </a:xfrm>
+          <a:prstGeom prst="rect">
+            <a:avLst/>
+          </a:prstGeom>
+          <a:noFill/>
+        </p:spPr>
+        <p:txBody>
+          <a:bodyPr wrap="square">
+            <a:spAutoFit/>
+          </a:bodyPr>
+          <a:lstStyle/>
+          <a:p>
+            <a:pPr algn="ctr">
+              <a:spcAft>
+                <a:spcPts val="400"/>
+              </a:spcAft>
+            </a:pPr>
+            <a:r>
+              <a:rPr sz="4000" b="1">
+                <a:solidFill>
+                  <a:srgbClr val="1F4E79"/>
+                </a:solidFill>
+                <a:latin typeface="Arial"/>
+              </a:rPr>
+              <a:t>Backup</a:t>
+            </a:r>
+          </a:p>
+        </p:txBody>
+      </p:sp>
+    </p:spTree>
+  </p:cSld>
+  <p:clrMapOvr>
+    <a:masterClrMapping/>
+  </p:clrMapOvr>
+</p:sld>
+</file>
+
+<file path=ppt/slides/slide25.xml><?xml version="1.0" encoding="utf-8"?>
+<p:sld xmlns:a="http://schemas.openxmlformats.org/drawingml/2006/main" xmlns:p="http://schemas.openxmlformats.org/presentationml/2006/main" xmlns:r="http://schemas.openxmlformats.org/officeDocument/2006/relationships">
+  <p:cSld>
+    <p:spTree>
+      <p:nvGrpSpPr>
+        <p:cNvPr id="1" name=""/>
+        <p:cNvGrpSpPr/>
+        <p:nvPr/>
+      </p:nvGrpSpPr>
+      <p:grpSpPr/>
+      <p:sp>
+        <p:nvSpPr>
+          <p:cNvPr id="2" name="TextBox 1"/>
+          <p:cNvSpPr txBox="1"/>
+          <p:nvPr/>
+        </p:nvSpPr>
+        <p:spPr>
+          <a:xfrm>
+            <a:off x="411480" y="201168"/>
+            <a:ext cx="11368735" cy="914400"/>
+          </a:xfrm>
+          <a:prstGeom prst="rect">
+            <a:avLst/>
+          </a:prstGeom>
+          <a:noFill/>
+        </p:spPr>
+        <p:txBody>
+          <a:bodyPr wrap="square">
+            <a:spAutoFit/>
+          </a:bodyPr>
+          <a:lstStyle/>
+          <a:p>
+            <a:pPr>
+              <a:spcAft>
+                <a:spcPts val="400"/>
+              </a:spcAft>
+            </a:pPr>
+            <a:r>
+              <a:rPr sz="2400" b="1">
+                <a:solidFill>
+                  <a:srgbClr val="1F4E79"/>
+                </a:solidFill>
+                <a:latin typeface="Arial"/>
+              </a:rPr>
+              <a:t>Before the correction: the first poke and color results</a:t>
+            </a:r>
+          </a:p>
+          <a:p>
+            <a:pPr>
+              <a:spcAft>
+                <a:spcPts val="0"/>
+              </a:spcAft>
+            </a:pPr>
+            <a:r>
+              <a:rPr sz="1250" b="0">
+                <a:solidFill>
+                  <a:srgbClr val="6E6E6E"/>
+                </a:solidFill>
+                <a:latin typeface="Arial"/>
+              </a:rPr>
+              <a:t>Kept for the record; every number on this slide is from the out-of-focus model</a:t>
+            </a:r>
+          </a:p>
+        </p:txBody>
+      </p:sp>
+      <p:sp>
+        <p:nvSpPr>
+          <p:cNvPr id="3" name="Rectangle 2"/>
+          <p:cNvSpPr/>
+          <p:nvPr/>
+        </p:nvSpPr>
+        <p:spPr>
+          <a:xfrm>
+            <a:off x="411480" y="1133856"/>
+            <a:ext cx="11368735" cy="20320"/>
+          </a:xfrm>
+          <a:prstGeom prst="rect">
+            <a:avLst/>
+          </a:prstGeom>
+          <a:solidFill>
+            <a:srgbClr val="B8C6D4"/>
+          </a:solidFill>
+          <a:ln>
+            <a:noFill/>
+          </a:ln>
+          <a:effectLst/>
+        </p:spPr>
+        <p:style>
+          <a:lnRef idx="1">
+            <a:schemeClr val="accent1"/>
+          </a:lnRef>
+          <a:fillRef idx="3">
+            <a:schemeClr val="accent1"/>
+          </a:fillRef>
+          <a:effectRef idx="2">
+            <a:schemeClr val="accent1"/>
+          </a:effectRef>
+          <a:fontRef idx="minor">
+            <a:schemeClr val="lt1"/>
+          </a:fontRef>
+        </p:style>
+        <p:txBody>
+          <a:bodyPr rtlCol="0" anchor="ctr"/>
+          <a:lstStyle/>
+          <a:p>
+            <a:pPr algn="ctr"/>
+          </a:p>
+        </p:txBody>
+      </p:sp>
       <p:pic>
         <p:nvPicPr>
           <p:cNvPr id="4" name="Picture 3" descr="zwfs_poke_triptych.png"/>
@@ -12409,7 +13099,7 @@
 </p:sld>
 </file>
 
-<file path=ppt/slides/slide25.xml><?xml version="1.0" encoding="utf-8"?>
+<file path=ppt/slides/slide26.xml><?xml version="1.0" encoding="utf-8"?>
 <p:sld xmlns:a="http://schemas.openxmlformats.org/drawingml/2006/main" xmlns:p="http://schemas.openxmlformats.org/presentationml/2006/main" xmlns:r="http://schemas.openxmlformats.org/officeDocument/2006/relationships">
   <p:cSld>
     <p:spTree>

</xml_diff>